<commit_message>
Sales pitch pack v3: Owl channel hub, live site-map heat view, Howler One stack page
Page 3 becomes a hub diagram (the Owl as the central brain; Pulse app,
WhatsApp, ChatGPT and Claude as the four doors); Fan Owl removed from the
client-facing assets; Event Ops page gains a live site-plan heat-map mockup
modelled on the Flow board Map view; new page/slide for the Howler One stack
(Ticketing, Cashless, Pulse, SuperApp, VIP Table Management). Deck now 13
slides with the site-map image embedded.

Co-Authored-By: Claude Fable 5 <noreply@anthropic.com>
Claude-Session: https://claude.ai/code/session_016kfeoZ1Zgn8t5cLdc8YKFo
</commit_message>
<xml_diff>
--- a/docs/sales-collateral/Pulse-Sales-Deck.pptx
+++ b/docs/sales-collateral/Pulse-Sales-Deck.pptx
@@ -17,9 +17,10 @@
     <p:sldId id="265" r:id="rId11"/>
     <p:sldId id="266" r:id="rId12"/>
     <p:sldId id="267" r:id="rId13"/>
+    <p:sldId id="268" r:id="rId14"/>
   </p:sldIdLst>
   <p:notesMasterIdLst>
-    <p:notesMasterId r:id="rId14"/>
+    <p:notesMasterId r:id="rId15"/>
   </p:notesMasterIdLst>
   <p:sldSz cx="12188952" cy="6858000"/>
   <p:notesSz cx="6858000" cy="12188952"/>
@@ -801,6 +802,94 @@
             <a:fld id="{F7021451-1387-4CA6-816F-3879F97B5CBC}" type="slidenum">
               <a:rPr lang="en-US"/>
               <a:t>12</a:t>
+            </a:fld>
+            <a:endParaRPr lang="en-US"/>
+          </a:p>
+        </p:txBody>
+      </p:sp>
+    </p:spTree>
+    <p:extLst>
+      <p:ext uri="{BB962C8B-B14F-4D97-AF65-F5344CB8AC3E}">
+        <p14:creationId xmlns:p14="http://schemas.microsoft.com/office/powerpoint/2010/main" val="1024086991"/>
+      </p:ext>
+    </p:extLst>
+  </p:cSld>
+  <p:clrMapOvr>
+    <a:masterClrMapping/>
+  </p:clrMapOvr>
+</p:notes>
+</file>
+
+<file path=ppt/notesSlides/notesSlide13.xml><?xml version="1.0" encoding="utf-8"?>
+<p:notes xmlns:a="http://schemas.openxmlformats.org/drawingml/2006/main" xmlns:r="http://schemas.openxmlformats.org/officeDocument/2006/relationships" xmlns:p="http://schemas.openxmlformats.org/presentationml/2006/main">
+  <p:cSld>
+    <p:spTree>
+      <p:nvGrpSpPr>
+        <p:cNvPr id="1" name=""/>
+        <p:cNvGrpSpPr/>
+        <p:nvPr/>
+      </p:nvGrpSpPr>
+      <p:grpSpPr>
+        <a:xfrm>
+          <a:off x="0" y="0"/>
+          <a:ext cx="0" cy="0"/>
+          <a:chOff x="0" y="0"/>
+          <a:chExt cx="0" cy="0"/>
+        </a:xfrm>
+      </p:grpSpPr>
+      <p:sp>
+        <p:nvSpPr>
+          <p:cNvPr id="2" name="Slide Image Placeholder 1"/>
+          <p:cNvSpPr>
+            <a:spLocks noGrp="1" noRot="1" noChangeAspect="1"/>
+          </p:cNvSpPr>
+          <p:nvPr>
+            <p:ph type="sldImg"/>
+          </p:nvPr>
+        </p:nvSpPr>
+        <p:spPr/>
+      </p:sp>
+      <p:sp>
+        <p:nvSpPr>
+          <p:cNvPr id="3" name="Notes Placeholder 2"/>
+          <p:cNvSpPr>
+            <a:spLocks noGrp="1"/>
+          </p:cNvSpPr>
+          <p:nvPr>
+            <p:ph type="body" idx="1"/>
+          </p:nvPr>
+        </p:nvSpPr>
+        <p:spPr/>
+        <p:txBody>
+          <a:bodyPr/>
+          <a:lstStyle/>
+          <a:p>
+            <a:r>
+              <a:rPr lang="en-US" dirty="0"/>
+              <a:t/>
+            </a:r>
+            <a:endParaRPr lang="en-US" dirty="0"/>
+          </a:p>
+        </p:txBody>
+      </p:sp>
+      <p:sp>
+        <p:nvSpPr>
+          <p:cNvPr id="4" name="Slide Number Placeholder 3"/>
+          <p:cNvSpPr>
+            <a:spLocks noGrp="1"/>
+          </p:cNvSpPr>
+          <p:nvPr>
+            <p:ph type="sldNum" sz="quarter" idx="10"/>
+          </p:nvPr>
+        </p:nvSpPr>
+        <p:spPr/>
+        <p:txBody>
+          <a:bodyPr/>
+          <a:lstStyle/>
+          <a:p>
+            <a:fld id="{F7021451-1387-4CA6-816F-3879F97B5CBC}" type="slidenum">
+              <a:rPr lang="en-US"/>
+              <a:t>13</a:t>
             </a:fld>
             <a:endParaRPr lang="en-US"/>
           </a:p>
@@ -4388,6 +4477,1289 @@
     <p:bg>
       <p:bgPr>
         <a:solidFill>
+          <a:srgbClr val="FFFFFF"/>
+        </a:solidFill>
+      </p:bgPr>
+    </p:bg>
+    <p:spTree>
+      <p:nvGrpSpPr>
+        <p:cNvPr id="1" name=""/>
+        <p:cNvGrpSpPr/>
+        <p:nvPr/>
+      </p:nvGrpSpPr>
+      <p:grpSpPr>
+        <a:xfrm>
+          <a:off x="0" y="0"/>
+          <a:ext cx="0" cy="0"/>
+          <a:chOff x="0" y="0"/>
+          <a:chExt cx="0" cy="0"/>
+        </a:xfrm>
+      </p:grpSpPr>
+      <p:sp>
+        <p:nvSpPr>
+          <p:cNvPr id="2" name="Shape 0"/>
+          <p:cNvSpPr/>
+          <p:nvPr/>
+        </p:nvSpPr>
+        <p:spPr>
+          <a:xfrm>
+            <a:off x="0" y="0"/>
+            <a:ext cx="12188952" cy="1051560"/>
+          </a:xfrm>
+          <a:prstGeom prst="rect">
+            <a:avLst/>
+          </a:prstGeom>
+          <a:solidFill>
+            <a:srgbClr val="7C3AED"/>
+          </a:solidFill>
+          <a:ln/>
+        </p:spPr>
+      </p:sp>
+      <p:sp>
+        <p:nvSpPr>
+          <p:cNvPr id="3" name="Text 1"/>
+          <p:cNvSpPr/>
+          <p:nvPr/>
+        </p:nvSpPr>
+        <p:spPr>
+          <a:xfrm>
+            <a:off x="457200" y="73152"/>
+            <a:ext cx="8686800" cy="594360"/>
+          </a:xfrm>
+          <a:prstGeom prst="rect">
+            <a:avLst/>
+          </a:prstGeom>
+          <a:noFill/>
+          <a:ln/>
+        </p:spPr>
+        <p:txBody>
+          <a:bodyPr wrap="square" rtlCol="0" anchor="ctr"/>
+          <a:lstStyle/>
+          <a:p>
+            <a:pPr indent="0" marL="0">
+              <a:buNone/>
+            </a:pPr>
+            <a:r>
+              <a:rPr lang="en-US" sz="2600" b="1" dirty="0">
+                <a:solidFill>
+                  <a:srgbClr val="FFFFFF"/>
+                </a:solidFill>
+                <a:latin typeface="Segoe UI" pitchFamily="34" charset="0"/>
+                <a:ea typeface="Segoe UI" pitchFamily="34" charset="-122"/>
+                <a:cs typeface="Segoe UI" pitchFamily="34" charset="-120"/>
+              </a:rPr>
+              <a:t>The Howler One stack</a:t>
+            </a:r>
+            <a:endParaRPr lang="en-US" sz="2600" dirty="0"/>
+          </a:p>
+        </p:txBody>
+      </p:sp>
+      <p:sp>
+        <p:nvSpPr>
+          <p:cNvPr id="4" name="Text 2"/>
+          <p:cNvSpPr/>
+          <p:nvPr/>
+        </p:nvSpPr>
+        <p:spPr>
+          <a:xfrm>
+            <a:off x="475488" y="566928"/>
+            <a:ext cx="10972800" cy="365760"/>
+          </a:xfrm>
+          <a:prstGeom prst="rect">
+            <a:avLst/>
+          </a:prstGeom>
+          <a:noFill/>
+          <a:ln/>
+        </p:spPr>
+        <p:txBody>
+          <a:bodyPr wrap="square" rtlCol="0" anchor="ctr"/>
+          <a:lstStyle/>
+          <a:p>
+            <a:pPr indent="0" marL="0">
+              <a:buNone/>
+            </a:pPr>
+            <a:r>
+              <a:rPr lang="en-US" sz="1200" i="1" dirty="0">
+                <a:solidFill>
+                  <a:srgbClr val="FFFFFF">
+                    <a:alpha val="88000"/>
+                  </a:srgbClr>
+                </a:solidFill>
+                <a:latin typeface="Segoe UI" pitchFamily="34" charset="0"/>
+                <a:ea typeface="Segoe UI" pitchFamily="34" charset="-122"/>
+                <a:cs typeface="Segoe UI" pitchFamily="34" charset="-120"/>
+              </a:rPr>
+              <a:t>one experience, one dataset, one partner — Pulse is the brain of the whole thing</a:t>
+            </a:r>
+            <a:endParaRPr lang="en-US" sz="1200" dirty="0"/>
+          </a:p>
+        </p:txBody>
+      </p:sp>
+      <p:sp>
+        <p:nvSpPr>
+          <p:cNvPr id="5" name="Shape 3"/>
+          <p:cNvSpPr/>
+          <p:nvPr/>
+        </p:nvSpPr>
+        <p:spPr>
+          <a:xfrm>
+            <a:off x="0" y="1051560"/>
+            <a:ext cx="4062984" cy="41148"/>
+          </a:xfrm>
+          <a:prstGeom prst="rect">
+            <a:avLst/>
+          </a:prstGeom>
+          <a:solidFill>
+            <a:srgbClr val="FF385C"/>
+          </a:solidFill>
+          <a:ln/>
+        </p:spPr>
+      </p:sp>
+      <p:sp>
+        <p:nvSpPr>
+          <p:cNvPr id="6" name="Shape 4"/>
+          <p:cNvSpPr/>
+          <p:nvPr/>
+        </p:nvSpPr>
+        <p:spPr>
+          <a:xfrm>
+            <a:off x="4062984" y="1051560"/>
+            <a:ext cx="4062984" cy="41148"/>
+          </a:xfrm>
+          <a:prstGeom prst="rect">
+            <a:avLst/>
+          </a:prstGeom>
+          <a:solidFill>
+            <a:srgbClr val="FF6B35"/>
+          </a:solidFill>
+          <a:ln/>
+        </p:spPr>
+      </p:sp>
+      <p:sp>
+        <p:nvSpPr>
+          <p:cNvPr id="7" name="Shape 5"/>
+          <p:cNvSpPr/>
+          <p:nvPr/>
+        </p:nvSpPr>
+        <p:spPr>
+          <a:xfrm>
+            <a:off x="8125968" y="1051560"/>
+            <a:ext cx="4062984" cy="41148"/>
+          </a:xfrm>
+          <a:prstGeom prst="rect">
+            <a:avLst/>
+          </a:prstGeom>
+          <a:solidFill>
+            <a:srgbClr val="7C3AED"/>
+          </a:solidFill>
+          <a:ln/>
+        </p:spPr>
+      </p:sp>
+      <p:sp>
+        <p:nvSpPr>
+          <p:cNvPr id="8" name="Text 6"/>
+          <p:cNvSpPr/>
+          <p:nvPr/>
+        </p:nvSpPr>
+        <p:spPr>
+          <a:xfrm>
+            <a:off x="457200" y="6446520"/>
+            <a:ext cx="4572000" cy="274320"/>
+          </a:xfrm>
+          <a:prstGeom prst="rect">
+            <a:avLst/>
+          </a:prstGeom>
+          <a:noFill/>
+          <a:ln/>
+        </p:spPr>
+        <p:txBody>
+          <a:bodyPr wrap="square" rtlCol="0" anchor="ctr"/>
+          <a:lstStyle/>
+          <a:p>
+            <a:pPr indent="0" marL="0">
+              <a:buNone/>
+            </a:pPr>
+            <a:r>
+              <a:rPr lang="en-US" sz="900" b="1" dirty="0">
+                <a:solidFill>
+                  <a:srgbClr val="9A97AD"/>
+                </a:solidFill>
+                <a:latin typeface="Segoe UI" pitchFamily="34" charset="0"/>
+                <a:ea typeface="Segoe UI" pitchFamily="34" charset="-122"/>
+                <a:cs typeface="Segoe UI" pitchFamily="34" charset="-120"/>
+              </a:rPr>
+              <a:t>Pulse</a:t>
+            </a:r>
+            <a:pPr indent="0" marL="0">
+              <a:buNone/>
+            </a:pPr>
+            <a:r>
+              <a:rPr lang="en-US" sz="900" dirty="0">
+                <a:solidFill>
+                  <a:srgbClr val="9A97AD"/>
+                </a:solidFill>
+                <a:latin typeface="Segoe UI" pitchFamily="34" charset="0"/>
+                <a:ea typeface="Segoe UI" pitchFamily="34" charset="-122"/>
+                <a:cs typeface="Segoe UI" pitchFamily="34" charset="-120"/>
+              </a:rPr>
+              <a:t>  ·  The Experience OS by Howler</a:t>
+            </a:r>
+            <a:endParaRPr lang="en-US" sz="900" dirty="0"/>
+          </a:p>
+        </p:txBody>
+      </p:sp>
+      <p:sp>
+        <p:nvSpPr>
+          <p:cNvPr id="9" name="Text 7"/>
+          <p:cNvSpPr/>
+          <p:nvPr/>
+        </p:nvSpPr>
+        <p:spPr>
+          <a:xfrm>
+            <a:off x="5029200" y="6446520"/>
+            <a:ext cx="2743200" cy="274320"/>
+          </a:xfrm>
+          <a:prstGeom prst="rect">
+            <a:avLst/>
+          </a:prstGeom>
+          <a:noFill/>
+          <a:ln/>
+        </p:spPr>
+        <p:txBody>
+          <a:bodyPr wrap="square" rtlCol="0" anchor="ctr"/>
+          <a:lstStyle/>
+          <a:p>
+            <a:pPr algn="ctr" indent="0" marL="0">
+              <a:buNone/>
+            </a:pPr>
+            <a:r>
+              <a:rPr lang="en-US" sz="900" dirty="0">
+                <a:solidFill>
+                  <a:srgbClr val="9A97AD"/>
+                </a:solidFill>
+                <a:latin typeface="Segoe UI" pitchFamily="34" charset="0"/>
+                <a:ea typeface="Segoe UI" pitchFamily="34" charset="-122"/>
+                <a:cs typeface="Segoe UI" pitchFamily="34" charset="-120"/>
+              </a:rPr>
+              <a:t>howler-pulse-v2.onrender.com</a:t>
+            </a:r>
+            <a:endParaRPr lang="en-US" sz="900" dirty="0"/>
+          </a:p>
+        </p:txBody>
+      </p:sp>
+      <p:sp>
+        <p:nvSpPr>
+          <p:cNvPr id="10" name="Text 8"/>
+          <p:cNvSpPr/>
+          <p:nvPr/>
+        </p:nvSpPr>
+        <p:spPr>
+          <a:xfrm>
+            <a:off x="11247120" y="6446520"/>
+            <a:ext cx="548640" cy="274320"/>
+          </a:xfrm>
+          <a:prstGeom prst="rect">
+            <a:avLst/>
+          </a:prstGeom>
+          <a:noFill/>
+          <a:ln/>
+        </p:spPr>
+        <p:txBody>
+          <a:bodyPr wrap="square" rtlCol="0" anchor="ctr"/>
+          <a:lstStyle/>
+          <a:p>
+            <a:pPr algn="r" indent="0" marL="0">
+              <a:buNone/>
+            </a:pPr>
+            <a:r>
+              <a:rPr lang="en-US" sz="900" dirty="0">
+                <a:solidFill>
+                  <a:srgbClr val="9A97AD"/>
+                </a:solidFill>
+                <a:latin typeface="Segoe UI" pitchFamily="34" charset="0"/>
+                <a:ea typeface="Segoe UI" pitchFamily="34" charset="-122"/>
+                <a:cs typeface="Segoe UI" pitchFamily="34" charset="-120"/>
+              </a:rPr>
+              <a:t>12</a:t>
+            </a:r>
+            <a:endParaRPr lang="en-US" sz="900" dirty="0"/>
+          </a:p>
+        </p:txBody>
+      </p:sp>
+      <p:sp>
+        <p:nvSpPr>
+          <p:cNvPr id="11" name="Shape 9"/>
+          <p:cNvSpPr/>
+          <p:nvPr/>
+        </p:nvSpPr>
+        <p:spPr>
+          <a:xfrm>
+            <a:off x="457200" y="1371600"/>
+            <a:ext cx="2697480" cy="1828800"/>
+          </a:xfrm>
+          <a:prstGeom prst="roundRect">
+            <a:avLst>
+              <a:gd name="adj" fmla="val 5000"/>
+            </a:avLst>
+          </a:prstGeom>
+          <a:solidFill>
+            <a:srgbClr val="FBFAFF"/>
+          </a:solidFill>
+          <a:ln w="12700">
+            <a:solidFill>
+              <a:srgbClr val="ECE9F5"/>
+            </a:solidFill>
+            <a:prstDash val="solid"/>
+          </a:ln>
+        </p:spPr>
+      </p:sp>
+      <p:sp>
+        <p:nvSpPr>
+          <p:cNvPr id="12" name="Text 10"/>
+          <p:cNvSpPr/>
+          <p:nvPr/>
+        </p:nvSpPr>
+        <p:spPr>
+          <a:xfrm>
+            <a:off x="594360" y="1463040"/>
+            <a:ext cx="2423160" cy="502920"/>
+          </a:xfrm>
+          <a:prstGeom prst="rect">
+            <a:avLst/>
+          </a:prstGeom>
+          <a:noFill/>
+          <a:ln/>
+        </p:spPr>
+        <p:txBody>
+          <a:bodyPr wrap="square" rtlCol="0" anchor="ctr"/>
+          <a:lstStyle/>
+          <a:p>
+            <a:pPr indent="0" marL="0">
+              <a:buNone/>
+            </a:pPr>
+            <a:r>
+              <a:rPr lang="en-US" sz="1250" b="1" dirty="0">
+                <a:solidFill>
+                  <a:srgbClr val="1A1A2E"/>
+                </a:solidFill>
+                <a:latin typeface="Segoe UI" pitchFamily="34" charset="0"/>
+                <a:ea typeface="Segoe UI" pitchFamily="34" charset="-122"/>
+                <a:cs typeface="Segoe UI" pitchFamily="34" charset="-120"/>
+              </a:rPr>
+              <a:t>🎟 Ticketing</a:t>
+            </a:r>
+            <a:endParaRPr lang="en-US" sz="1250" dirty="0"/>
+          </a:p>
+        </p:txBody>
+      </p:sp>
+      <p:sp>
+        <p:nvSpPr>
+          <p:cNvPr id="13" name="Text 11"/>
+          <p:cNvSpPr/>
+          <p:nvPr/>
+        </p:nvSpPr>
+        <p:spPr>
+          <a:xfrm>
+            <a:off x="594360" y="1938528"/>
+            <a:ext cx="2423160" cy="1188720"/>
+          </a:xfrm>
+          <a:prstGeom prst="rect">
+            <a:avLst/>
+          </a:prstGeom>
+          <a:noFill/>
+          <a:ln/>
+        </p:spPr>
+        <p:txBody>
+          <a:bodyPr wrap="square" rtlCol="0" anchor="t"/>
+          <a:lstStyle/>
+          <a:p>
+            <a:pPr indent="0" marL="0">
+              <a:lnSpc>
+                <a:spcPts val="1250"/>
+              </a:lnSpc>
+              <a:buNone/>
+            </a:pPr>
+            <a:r>
+              <a:rPr lang="en-US" sz="950" dirty="0">
+                <a:solidFill>
+                  <a:srgbClr val="55556D"/>
+                </a:solidFill>
+                <a:latin typeface="Segoe UI" pitchFamily="34" charset="0"/>
+                <a:ea typeface="Segoe UI" pitchFamily="34" charset="-122"/>
+                <a:cs typeface="Segoe UI" pitchFamily="34" charset="-120"/>
+              </a:rPr>
+              <a:t>Ticket sales, tiers &amp; releases, access control and scanning — every buyer and every entry, captured from minute one.</a:t>
+            </a:r>
+            <a:endParaRPr lang="en-US" sz="950" dirty="0"/>
+          </a:p>
+        </p:txBody>
+      </p:sp>
+      <p:sp>
+        <p:nvSpPr>
+          <p:cNvPr id="14" name="Text 12"/>
+          <p:cNvSpPr/>
+          <p:nvPr/>
+        </p:nvSpPr>
+        <p:spPr>
+          <a:xfrm>
+            <a:off x="1536192" y="3200400"/>
+            <a:ext cx="548640" cy="365760"/>
+          </a:xfrm>
+          <a:prstGeom prst="rect">
+            <a:avLst/>
+          </a:prstGeom>
+          <a:noFill/>
+          <a:ln/>
+        </p:spPr>
+        <p:txBody>
+          <a:bodyPr wrap="square" rtlCol="0" anchor="ctr"/>
+          <a:lstStyle/>
+          <a:p>
+            <a:pPr algn="ctr" indent="0" marL="0">
+              <a:buNone/>
+            </a:pPr>
+            <a:r>
+              <a:rPr lang="en-US" sz="1800" b="1" dirty="0">
+                <a:solidFill>
+                  <a:srgbClr val="A89DDD"/>
+                </a:solidFill>
+                <a:latin typeface="Segoe UI" pitchFamily="34" charset="0"/>
+                <a:ea typeface="Segoe UI" pitchFamily="34" charset="-122"/>
+                <a:cs typeface="Segoe UI" pitchFamily="34" charset="-120"/>
+              </a:rPr>
+              <a:t>↓</a:t>
+            </a:r>
+            <a:endParaRPr lang="en-US" sz="1800" dirty="0"/>
+          </a:p>
+        </p:txBody>
+      </p:sp>
+      <p:sp>
+        <p:nvSpPr>
+          <p:cNvPr id="15" name="Shape 13"/>
+          <p:cNvSpPr/>
+          <p:nvPr/>
+        </p:nvSpPr>
+        <p:spPr>
+          <a:xfrm>
+            <a:off x="3337560" y="1371600"/>
+            <a:ext cx="2697480" cy="1828800"/>
+          </a:xfrm>
+          <a:prstGeom prst="roundRect">
+            <a:avLst>
+              <a:gd name="adj" fmla="val 5000"/>
+            </a:avLst>
+          </a:prstGeom>
+          <a:solidFill>
+            <a:srgbClr val="FBFAFF"/>
+          </a:solidFill>
+          <a:ln w="12700">
+            <a:solidFill>
+              <a:srgbClr val="ECE9F5"/>
+            </a:solidFill>
+            <a:prstDash val="solid"/>
+          </a:ln>
+        </p:spPr>
+      </p:sp>
+      <p:sp>
+        <p:nvSpPr>
+          <p:cNvPr id="16" name="Text 14"/>
+          <p:cNvSpPr/>
+          <p:nvPr/>
+        </p:nvSpPr>
+        <p:spPr>
+          <a:xfrm>
+            <a:off x="3474720" y="1463040"/>
+            <a:ext cx="2423160" cy="502920"/>
+          </a:xfrm>
+          <a:prstGeom prst="rect">
+            <a:avLst/>
+          </a:prstGeom>
+          <a:noFill/>
+          <a:ln/>
+        </p:spPr>
+        <p:txBody>
+          <a:bodyPr wrap="square" rtlCol="0" anchor="ctr"/>
+          <a:lstStyle/>
+          <a:p>
+            <a:pPr indent="0" marL="0">
+              <a:buNone/>
+            </a:pPr>
+            <a:r>
+              <a:rPr lang="en-US" sz="1250" b="1" dirty="0">
+                <a:solidFill>
+                  <a:srgbClr val="1A1A2E"/>
+                </a:solidFill>
+                <a:latin typeface="Segoe UI" pitchFamily="34" charset="0"/>
+                <a:ea typeface="Segoe UI" pitchFamily="34" charset="-122"/>
+                <a:cs typeface="Segoe UI" pitchFamily="34" charset="-120"/>
+              </a:rPr>
+              <a:t>💳 Cashless Payments</a:t>
+            </a:r>
+            <a:endParaRPr lang="en-US" sz="1250" dirty="0"/>
+          </a:p>
+        </p:txBody>
+      </p:sp>
+      <p:sp>
+        <p:nvSpPr>
+          <p:cNvPr id="17" name="Text 15"/>
+          <p:cNvSpPr/>
+          <p:nvPr/>
+        </p:nvSpPr>
+        <p:spPr>
+          <a:xfrm>
+            <a:off x="3474720" y="1938528"/>
+            <a:ext cx="2423160" cy="1188720"/>
+          </a:xfrm>
+          <a:prstGeom prst="rect">
+            <a:avLst/>
+          </a:prstGeom>
+          <a:noFill/>
+          <a:ln/>
+        </p:spPr>
+        <p:txBody>
+          <a:bodyPr wrap="square" rtlCol="0" anchor="t"/>
+          <a:lstStyle/>
+          <a:p>
+            <a:pPr indent="0" marL="0">
+              <a:lnSpc>
+                <a:spcPts val="1250"/>
+              </a:lnSpc>
+              <a:buNone/>
+            </a:pPr>
+            <a:r>
+              <a:rPr lang="en-US" sz="950" dirty="0">
+                <a:solidFill>
+                  <a:srgbClr val="55556D"/>
+                </a:solidFill>
+                <a:latin typeface="Segoe UI" pitchFamily="34" charset="0"/>
+                <a:ea typeface="Segoe UI" pitchFamily="34" charset="-122"/>
+                <a:cs typeface="Segoe UI" pitchFamily="34" charset="-120"/>
+              </a:rPr>
+              <a:t>Tap-to-pay across bars and vendors: faster queues, higher spend, zero cash risk — every transaction is live data.</a:t>
+            </a:r>
+            <a:endParaRPr lang="en-US" sz="950" dirty="0"/>
+          </a:p>
+        </p:txBody>
+      </p:sp>
+      <p:sp>
+        <p:nvSpPr>
+          <p:cNvPr id="18" name="Text 16"/>
+          <p:cNvSpPr/>
+          <p:nvPr/>
+        </p:nvSpPr>
+        <p:spPr>
+          <a:xfrm>
+            <a:off x="4416552" y="3200400"/>
+            <a:ext cx="548640" cy="365760"/>
+          </a:xfrm>
+          <a:prstGeom prst="rect">
+            <a:avLst/>
+          </a:prstGeom>
+          <a:noFill/>
+          <a:ln/>
+        </p:spPr>
+        <p:txBody>
+          <a:bodyPr wrap="square" rtlCol="0" anchor="ctr"/>
+          <a:lstStyle/>
+          <a:p>
+            <a:pPr algn="ctr" indent="0" marL="0">
+              <a:buNone/>
+            </a:pPr>
+            <a:r>
+              <a:rPr lang="en-US" sz="1800" b="1" dirty="0">
+                <a:solidFill>
+                  <a:srgbClr val="A89DDD"/>
+                </a:solidFill>
+                <a:latin typeface="Segoe UI" pitchFamily="34" charset="0"/>
+                <a:ea typeface="Segoe UI" pitchFamily="34" charset="-122"/>
+                <a:cs typeface="Segoe UI" pitchFamily="34" charset="-120"/>
+              </a:rPr>
+              <a:t>↓</a:t>
+            </a:r>
+            <a:endParaRPr lang="en-US" sz="1800" dirty="0"/>
+          </a:p>
+        </p:txBody>
+      </p:sp>
+      <p:sp>
+        <p:nvSpPr>
+          <p:cNvPr id="19" name="Shape 17"/>
+          <p:cNvSpPr/>
+          <p:nvPr/>
+        </p:nvSpPr>
+        <p:spPr>
+          <a:xfrm>
+            <a:off x="6217920" y="1371600"/>
+            <a:ext cx="2697480" cy="1828800"/>
+          </a:xfrm>
+          <a:prstGeom prst="roundRect">
+            <a:avLst>
+              <a:gd name="adj" fmla="val 5000"/>
+            </a:avLst>
+          </a:prstGeom>
+          <a:solidFill>
+            <a:srgbClr val="FBFAFF"/>
+          </a:solidFill>
+          <a:ln w="12700">
+            <a:solidFill>
+              <a:srgbClr val="ECE9F5"/>
+            </a:solidFill>
+            <a:prstDash val="solid"/>
+          </a:ln>
+        </p:spPr>
+      </p:sp>
+      <p:sp>
+        <p:nvSpPr>
+          <p:cNvPr id="20" name="Text 18"/>
+          <p:cNvSpPr/>
+          <p:nvPr/>
+        </p:nvSpPr>
+        <p:spPr>
+          <a:xfrm>
+            <a:off x="6355080" y="1463040"/>
+            <a:ext cx="2423160" cy="502920"/>
+          </a:xfrm>
+          <a:prstGeom prst="rect">
+            <a:avLst/>
+          </a:prstGeom>
+          <a:noFill/>
+          <a:ln/>
+        </p:spPr>
+        <p:txBody>
+          <a:bodyPr wrap="square" rtlCol="0" anchor="ctr"/>
+          <a:lstStyle/>
+          <a:p>
+            <a:pPr indent="0" marL="0">
+              <a:buNone/>
+            </a:pPr>
+            <a:r>
+              <a:rPr lang="en-US" sz="1250" b="1" dirty="0">
+                <a:solidFill>
+                  <a:srgbClr val="1A1A2E"/>
+                </a:solidFill>
+                <a:latin typeface="Segoe UI" pitchFamily="34" charset="0"/>
+                <a:ea typeface="Segoe UI" pitchFamily="34" charset="-122"/>
+                <a:cs typeface="Segoe UI" pitchFamily="34" charset="-120"/>
+              </a:rPr>
+              <a:t>📱 SuperApp</a:t>
+            </a:r>
+            <a:endParaRPr lang="en-US" sz="1250" dirty="0"/>
+          </a:p>
+        </p:txBody>
+      </p:sp>
+      <p:sp>
+        <p:nvSpPr>
+          <p:cNvPr id="21" name="Text 19"/>
+          <p:cNvSpPr/>
+          <p:nvPr/>
+        </p:nvSpPr>
+        <p:spPr>
+          <a:xfrm>
+            <a:off x="6355080" y="1938528"/>
+            <a:ext cx="2423160" cy="1188720"/>
+          </a:xfrm>
+          <a:prstGeom prst="rect">
+            <a:avLst/>
+          </a:prstGeom>
+          <a:noFill/>
+          <a:ln/>
+        </p:spPr>
+        <p:txBody>
+          <a:bodyPr wrap="square" rtlCol="0" anchor="t"/>
+          <a:lstStyle/>
+          <a:p>
+            <a:pPr indent="0" marL="0">
+              <a:lnSpc>
+                <a:spcPts val="1250"/>
+              </a:lnSpc>
+              <a:buNone/>
+            </a:pPr>
+            <a:r>
+              <a:rPr lang="en-US" sz="950" dirty="0">
+                <a:solidFill>
+                  <a:srgbClr val="55556D"/>
+                </a:solidFill>
+                <a:latin typeface="Segoe UI" pitchFamily="34" charset="0"/>
+                <a:ea typeface="Segoe UI" pitchFamily="34" charset="-122"/>
+                <a:cs typeface="Segoe UI" pitchFamily="34" charset="-120"/>
+              </a:rPr>
+              <a:t>The fan’s companion: tickets, top-ups, line-ups and offers in one place — an ownable channel to every attendee.</a:t>
+            </a:r>
+            <a:endParaRPr lang="en-US" sz="950" dirty="0"/>
+          </a:p>
+        </p:txBody>
+      </p:sp>
+      <p:sp>
+        <p:nvSpPr>
+          <p:cNvPr id="22" name="Text 20"/>
+          <p:cNvSpPr/>
+          <p:nvPr/>
+        </p:nvSpPr>
+        <p:spPr>
+          <a:xfrm>
+            <a:off x="7296912" y="3200400"/>
+            <a:ext cx="548640" cy="365760"/>
+          </a:xfrm>
+          <a:prstGeom prst="rect">
+            <a:avLst/>
+          </a:prstGeom>
+          <a:noFill/>
+          <a:ln/>
+        </p:spPr>
+        <p:txBody>
+          <a:bodyPr wrap="square" rtlCol="0" anchor="ctr"/>
+          <a:lstStyle/>
+          <a:p>
+            <a:pPr algn="ctr" indent="0" marL="0">
+              <a:buNone/>
+            </a:pPr>
+            <a:r>
+              <a:rPr lang="en-US" sz="1800" b="1" dirty="0">
+                <a:solidFill>
+                  <a:srgbClr val="A89DDD"/>
+                </a:solidFill>
+                <a:latin typeface="Segoe UI" pitchFamily="34" charset="0"/>
+                <a:ea typeface="Segoe UI" pitchFamily="34" charset="-122"/>
+                <a:cs typeface="Segoe UI" pitchFamily="34" charset="-120"/>
+              </a:rPr>
+              <a:t>↓</a:t>
+            </a:r>
+            <a:endParaRPr lang="en-US" sz="1800" dirty="0"/>
+          </a:p>
+        </p:txBody>
+      </p:sp>
+      <p:sp>
+        <p:nvSpPr>
+          <p:cNvPr id="23" name="Shape 21"/>
+          <p:cNvSpPr/>
+          <p:nvPr/>
+        </p:nvSpPr>
+        <p:spPr>
+          <a:xfrm>
+            <a:off x="9098280" y="1371600"/>
+            <a:ext cx="2697480" cy="1828800"/>
+          </a:xfrm>
+          <a:prstGeom prst="roundRect">
+            <a:avLst>
+              <a:gd name="adj" fmla="val 5000"/>
+            </a:avLst>
+          </a:prstGeom>
+          <a:solidFill>
+            <a:srgbClr val="FBFAFF"/>
+          </a:solidFill>
+          <a:ln w="12700">
+            <a:solidFill>
+              <a:srgbClr val="ECE9F5"/>
+            </a:solidFill>
+            <a:prstDash val="solid"/>
+          </a:ln>
+        </p:spPr>
+      </p:sp>
+      <p:sp>
+        <p:nvSpPr>
+          <p:cNvPr id="24" name="Text 22"/>
+          <p:cNvSpPr/>
+          <p:nvPr/>
+        </p:nvSpPr>
+        <p:spPr>
+          <a:xfrm>
+            <a:off x="9235440" y="1463040"/>
+            <a:ext cx="2423160" cy="502920"/>
+          </a:xfrm>
+          <a:prstGeom prst="rect">
+            <a:avLst/>
+          </a:prstGeom>
+          <a:noFill/>
+          <a:ln/>
+        </p:spPr>
+        <p:txBody>
+          <a:bodyPr wrap="square" rtlCol="0" anchor="ctr"/>
+          <a:lstStyle/>
+          <a:p>
+            <a:pPr indent="0" marL="0">
+              <a:buNone/>
+            </a:pPr>
+            <a:r>
+              <a:rPr lang="en-US" sz="1250" b="1" dirty="0">
+                <a:solidFill>
+                  <a:srgbClr val="1A1A2E"/>
+                </a:solidFill>
+                <a:latin typeface="Segoe UI" pitchFamily="34" charset="0"/>
+                <a:ea typeface="Segoe UI" pitchFamily="34" charset="-122"/>
+                <a:cs typeface="Segoe UI" pitchFamily="34" charset="-120"/>
+              </a:rPr>
+              <a:t>🍾 VIP Table Management</a:t>
+            </a:r>
+            <a:endParaRPr lang="en-US" sz="1250" dirty="0"/>
+          </a:p>
+        </p:txBody>
+      </p:sp>
+      <p:sp>
+        <p:nvSpPr>
+          <p:cNvPr id="25" name="Text 23"/>
+          <p:cNvSpPr/>
+          <p:nvPr/>
+        </p:nvSpPr>
+        <p:spPr>
+          <a:xfrm>
+            <a:off x="9235440" y="1938528"/>
+            <a:ext cx="2423160" cy="1188720"/>
+          </a:xfrm>
+          <a:prstGeom prst="rect">
+            <a:avLst/>
+          </a:prstGeom>
+          <a:noFill/>
+          <a:ln/>
+        </p:spPr>
+        <p:txBody>
+          <a:bodyPr wrap="square" rtlCol="0" anchor="t"/>
+          <a:lstStyle/>
+          <a:p>
+            <a:pPr indent="0" marL="0">
+              <a:lnSpc>
+                <a:spcPts val="1250"/>
+              </a:lnSpc>
+              <a:buNone/>
+            </a:pPr>
+            <a:r>
+              <a:rPr lang="en-US" sz="950" dirty="0">
+                <a:solidFill>
+                  <a:srgbClr val="55556D"/>
+                </a:solidFill>
+                <a:latin typeface="Segoe UI" pitchFamily="34" charset="0"/>
+                <a:ea typeface="Segoe UI" pitchFamily="34" charset="-122"/>
+                <a:cs typeface="Segoe UI" pitchFamily="34" charset="-120"/>
+              </a:rPr>
+              <a:t>Table inventory, bookings and minimum spends, hosted service — your highest-value guests, managed and measured.</a:t>
+            </a:r>
+            <a:endParaRPr lang="en-US" sz="950" dirty="0"/>
+          </a:p>
+        </p:txBody>
+      </p:sp>
+      <p:sp>
+        <p:nvSpPr>
+          <p:cNvPr id="26" name="Text 24"/>
+          <p:cNvSpPr/>
+          <p:nvPr/>
+        </p:nvSpPr>
+        <p:spPr>
+          <a:xfrm>
+            <a:off x="10177272" y="3200400"/>
+            <a:ext cx="548640" cy="365760"/>
+          </a:xfrm>
+          <a:prstGeom prst="rect">
+            <a:avLst/>
+          </a:prstGeom>
+          <a:noFill/>
+          <a:ln/>
+        </p:spPr>
+        <p:txBody>
+          <a:bodyPr wrap="square" rtlCol="0" anchor="ctr"/>
+          <a:lstStyle/>
+          <a:p>
+            <a:pPr algn="ctr" indent="0" marL="0">
+              <a:buNone/>
+            </a:pPr>
+            <a:r>
+              <a:rPr lang="en-US" sz="1800" b="1" dirty="0">
+                <a:solidFill>
+                  <a:srgbClr val="A89DDD"/>
+                </a:solidFill>
+                <a:latin typeface="Segoe UI" pitchFamily="34" charset="0"/>
+                <a:ea typeface="Segoe UI" pitchFamily="34" charset="-122"/>
+                <a:cs typeface="Segoe UI" pitchFamily="34" charset="-120"/>
+              </a:rPr>
+              <a:t>↓</a:t>
+            </a:r>
+            <a:endParaRPr lang="en-US" sz="1800" dirty="0"/>
+          </a:p>
+        </p:txBody>
+      </p:sp>
+      <p:sp>
+        <p:nvSpPr>
+          <p:cNvPr id="27" name="Shape 25"/>
+          <p:cNvSpPr/>
+          <p:nvPr/>
+        </p:nvSpPr>
+        <p:spPr>
+          <a:xfrm>
+            <a:off x="457200" y="3611880"/>
+            <a:ext cx="11338560" cy="1143000"/>
+          </a:xfrm>
+          <a:prstGeom prst="roundRect">
+            <a:avLst>
+              <a:gd name="adj" fmla="val 9600"/>
+            </a:avLst>
+          </a:prstGeom>
+          <a:solidFill>
+            <a:srgbClr val="1A1A2E"/>
+          </a:solidFill>
+          <a:ln/>
+        </p:spPr>
+      </p:sp>
+      <p:sp>
+        <p:nvSpPr>
+          <p:cNvPr id="28" name="Text 26"/>
+          <p:cNvSpPr/>
+          <p:nvPr/>
+        </p:nvSpPr>
+        <p:spPr>
+          <a:xfrm>
+            <a:off x="777240" y="3703320"/>
+            <a:ext cx="10698480" cy="960120"/>
+          </a:xfrm>
+          <a:prstGeom prst="rect">
+            <a:avLst/>
+          </a:prstGeom>
+          <a:noFill/>
+          <a:ln/>
+        </p:spPr>
+        <p:txBody>
+          <a:bodyPr wrap="square" rtlCol="0" anchor="ctr"/>
+          <a:lstStyle/>
+          <a:p>
+            <a:pPr indent="0" marL="0">
+              <a:lnSpc>
+                <a:spcPts val="1600"/>
+              </a:lnSpc>
+              <a:buNone/>
+            </a:pPr>
+            <a:r>
+              <a:rPr lang="en-US" sz="1500" b="1" dirty="0">
+                <a:solidFill>
+                  <a:srgbClr val="FFFFFF"/>
+                </a:solidFill>
+                <a:latin typeface="Segoe UI" pitchFamily="34" charset="0"/>
+                <a:ea typeface="Segoe UI" pitchFamily="34" charset="-122"/>
+                <a:cs typeface="Segoe UI" pitchFamily="34" charset="-120"/>
+              </a:rPr>
+              <a:t>📊 Pulse — the brain of the stack.  </a:t>
+            </a:r>
+            <a:pPr indent="0" marL="0">
+              <a:lnSpc>
+                <a:spcPts val="1600"/>
+              </a:lnSpc>
+              <a:buNone/>
+            </a:pPr>
+            <a:r>
+              <a:rPr lang="en-US" sz="1150" dirty="0">
+                <a:solidFill>
+                  <a:srgbClr val="D8D4F0"/>
+                </a:solidFill>
+                <a:latin typeface="Segoe UI" pitchFamily="34" charset="0"/>
+                <a:ea typeface="Segoe UI" pitchFamily="34" charset="-122"/>
+                <a:cs typeface="Segoe UI" pitchFamily="34" charset="-120"/>
+              </a:rPr>
+              <a:t>Every ticket scanned, every tap at a bar, every SuperApp session and every VIP booking flows into one governed dataset — where the Owl reads it, your team acts on it, and the results come back measured.</a:t>
+            </a:r>
+            <a:endParaRPr lang="en-US" sz="1500" dirty="0"/>
+          </a:p>
+        </p:txBody>
+      </p:sp>
+      <p:sp>
+        <p:nvSpPr>
+          <p:cNvPr id="29" name="Text 27"/>
+          <p:cNvSpPr/>
+          <p:nvPr/>
+        </p:nvSpPr>
+        <p:spPr>
+          <a:xfrm>
+            <a:off x="457200" y="4864608"/>
+            <a:ext cx="11338560" cy="365760"/>
+          </a:xfrm>
+          <a:prstGeom prst="rect">
+            <a:avLst/>
+          </a:prstGeom>
+          <a:noFill/>
+          <a:ln/>
+        </p:spPr>
+        <p:txBody>
+          <a:bodyPr wrap="square" rtlCol="0" anchor="ctr"/>
+          <a:lstStyle/>
+          <a:p>
+            <a:pPr algn="ctr" indent="0" marL="0">
+              <a:buNone/>
+            </a:pPr>
+            <a:r>
+              <a:rPr lang="en-US" sz="1200" b="1" spc="200" kern="0" dirty="0">
+                <a:solidFill>
+                  <a:srgbClr val="2D2B55"/>
+                </a:solidFill>
+                <a:latin typeface="Segoe UI" pitchFamily="34" charset="0"/>
+                <a:ea typeface="Segoe UI" pitchFamily="34" charset="-122"/>
+                <a:cs typeface="Segoe UI" pitchFamily="34" charset="-120"/>
+              </a:rPr>
+              <a:t>ONE STACK  ·  ONE DATASET  ·  ONE BRAND EXPERIENCE  ·  ONE PARTNER</a:t>
+            </a:r>
+            <a:endParaRPr lang="en-US" sz="1200" dirty="0"/>
+          </a:p>
+        </p:txBody>
+      </p:sp>
+      <p:sp>
+        <p:nvSpPr>
+          <p:cNvPr id="30" name="Shape 28"/>
+          <p:cNvSpPr/>
+          <p:nvPr/>
+        </p:nvSpPr>
+        <p:spPr>
+          <a:xfrm>
+            <a:off x="457200" y="5349240"/>
+            <a:ext cx="3657600" cy="1234440"/>
+          </a:xfrm>
+          <a:prstGeom prst="roundRect">
+            <a:avLst>
+              <a:gd name="adj" fmla="val 7407"/>
+            </a:avLst>
+          </a:prstGeom>
+          <a:solidFill>
+            <a:srgbClr val="FF385C"/>
+          </a:solidFill>
+          <a:ln/>
+        </p:spPr>
+      </p:sp>
+      <p:sp>
+        <p:nvSpPr>
+          <p:cNvPr id="31" name="Text 29"/>
+          <p:cNvSpPr/>
+          <p:nvPr/>
+        </p:nvSpPr>
+        <p:spPr>
+          <a:xfrm>
+            <a:off x="594360" y="5413248"/>
+            <a:ext cx="3383280" cy="1097280"/>
+          </a:xfrm>
+          <a:prstGeom prst="rect">
+            <a:avLst/>
+          </a:prstGeom>
+          <a:noFill/>
+          <a:ln/>
+        </p:spPr>
+        <p:txBody>
+          <a:bodyPr wrap="square" rtlCol="0" anchor="t"/>
+          <a:lstStyle/>
+          <a:p>
+            <a:pPr indent="0" marL="0">
+              <a:lnSpc>
+                <a:spcPts val="1150"/>
+              </a:lnSpc>
+              <a:buNone/>
+            </a:pPr>
+            <a:r>
+              <a:rPr lang="en-US" sz="1100" b="1" dirty="0">
+                <a:solidFill>
+                  <a:srgbClr val="FFFFFF"/>
+                </a:solidFill>
+                <a:latin typeface="Segoe UI" pitchFamily="34" charset="0"/>
+                <a:ea typeface="Segoe UI" pitchFamily="34" charset="-122"/>
+                <a:cs typeface="Segoe UI" pitchFamily="34" charset="-120"/>
+              </a:rPr>
+              <a:t>Better together: The bar
+</a:t>
+            </a:r>
+            <a:pPr indent="0" marL="0">
+              <a:lnSpc>
+                <a:spcPts val="1150"/>
+              </a:lnSpc>
+              <a:buNone/>
+            </a:pPr>
+            <a:r>
+              <a:rPr lang="en-US" sz="900" dirty="0">
+                <a:solidFill>
+                  <a:srgbClr val="FFFFFF">
+                    <a:alpha val="94000"/>
+                  </a:srgbClr>
+                </a:solidFill>
+                <a:latin typeface="Segoe UI" pitchFamily="34" charset="0"/>
+                <a:ea typeface="Segoe UI" pitchFamily="34" charset="-122"/>
+                <a:cs typeface="Segoe UI" pitchFamily="34" charset="-120"/>
+              </a:rPr>
+              <a:t>Cashless spots the Main Bar spiking; the heat map shows the hotspot; the Owl suggests moving two devices — while the night is young.</a:t>
+            </a:r>
+            <a:endParaRPr lang="en-US" sz="1100" dirty="0"/>
+          </a:p>
+        </p:txBody>
+      </p:sp>
+      <p:sp>
+        <p:nvSpPr>
+          <p:cNvPr id="32" name="Shape 30"/>
+          <p:cNvSpPr/>
+          <p:nvPr/>
+        </p:nvSpPr>
+        <p:spPr>
+          <a:xfrm>
+            <a:off x="4297680" y="5349240"/>
+            <a:ext cx="3657600" cy="1234440"/>
+          </a:xfrm>
+          <a:prstGeom prst="roundRect">
+            <a:avLst>
+              <a:gd name="adj" fmla="val 7407"/>
+            </a:avLst>
+          </a:prstGeom>
+          <a:solidFill>
+            <a:srgbClr val="FF6B35"/>
+          </a:solidFill>
+          <a:ln/>
+        </p:spPr>
+      </p:sp>
+      <p:sp>
+        <p:nvSpPr>
+          <p:cNvPr id="33" name="Text 31"/>
+          <p:cNvSpPr/>
+          <p:nvPr/>
+        </p:nvSpPr>
+        <p:spPr>
+          <a:xfrm>
+            <a:off x="4434840" y="5413248"/>
+            <a:ext cx="3383280" cy="1097280"/>
+          </a:xfrm>
+          <a:prstGeom prst="rect">
+            <a:avLst/>
+          </a:prstGeom>
+          <a:noFill/>
+          <a:ln/>
+        </p:spPr>
+        <p:txBody>
+          <a:bodyPr wrap="square" rtlCol="0" anchor="t"/>
+          <a:lstStyle/>
+          <a:p>
+            <a:pPr indent="0" marL="0">
+              <a:lnSpc>
+                <a:spcPts val="1150"/>
+              </a:lnSpc>
+              <a:buNone/>
+            </a:pPr>
+            <a:r>
+              <a:rPr lang="en-US" sz="1100" b="1" dirty="0">
+                <a:solidFill>
+                  <a:srgbClr val="FFFFFF"/>
+                </a:solidFill>
+                <a:latin typeface="Segoe UI" pitchFamily="34" charset="0"/>
+                <a:ea typeface="Segoe UI" pitchFamily="34" charset="-122"/>
+                <a:cs typeface="Segoe UI" pitchFamily="34" charset="-120"/>
+              </a:rPr>
+              <a:t>Better together: The fan
+</a:t>
+            </a:r>
+            <a:pPr indent="0" marL="0">
+              <a:lnSpc>
+                <a:spcPts val="1150"/>
+              </a:lnSpc>
+              <a:buNone/>
+            </a:pPr>
+            <a:r>
+              <a:rPr lang="en-US" sz="900" dirty="0">
+                <a:solidFill>
+                  <a:srgbClr val="FFFFFF">
+                    <a:alpha val="94000"/>
+                  </a:srgbClr>
+                </a:solidFill>
+                <a:latin typeface="Segoe UI" pitchFamily="34" charset="0"/>
+                <a:ea typeface="Segoe UI" pitchFamily="34" charset="-122"/>
+                <a:cs typeface="Segoe UI" pitchFamily="34" charset="-120"/>
+              </a:rPr>
+              <a:t>Ticket + top-ups + bar spend stitched into one picture — your next campaign targets big spenders who haven’t rebought yet.</a:t>
+            </a:r>
+            <a:endParaRPr lang="en-US" sz="1100" dirty="0"/>
+          </a:p>
+        </p:txBody>
+      </p:sp>
+      <p:sp>
+        <p:nvSpPr>
+          <p:cNvPr id="34" name="Shape 32"/>
+          <p:cNvSpPr/>
+          <p:nvPr/>
+        </p:nvSpPr>
+        <p:spPr>
+          <a:xfrm>
+            <a:off x="8138160" y="5349240"/>
+            <a:ext cx="3657600" cy="1234440"/>
+          </a:xfrm>
+          <a:prstGeom prst="roundRect">
+            <a:avLst>
+              <a:gd name="adj" fmla="val 7407"/>
+            </a:avLst>
+          </a:prstGeom>
+          <a:solidFill>
+            <a:srgbClr val="7C3AED"/>
+          </a:solidFill>
+          <a:ln/>
+        </p:spPr>
+      </p:sp>
+      <p:sp>
+        <p:nvSpPr>
+          <p:cNvPr id="35" name="Text 33"/>
+          <p:cNvSpPr/>
+          <p:nvPr/>
+        </p:nvSpPr>
+        <p:spPr>
+          <a:xfrm>
+            <a:off x="8275320" y="5413248"/>
+            <a:ext cx="3383280" cy="1097280"/>
+          </a:xfrm>
+          <a:prstGeom prst="rect">
+            <a:avLst/>
+          </a:prstGeom>
+          <a:noFill/>
+          <a:ln/>
+        </p:spPr>
+        <p:txBody>
+          <a:bodyPr wrap="square" rtlCol="0" anchor="t"/>
+          <a:lstStyle/>
+          <a:p>
+            <a:pPr indent="0" marL="0">
+              <a:lnSpc>
+                <a:spcPts val="1150"/>
+              </a:lnSpc>
+              <a:buNone/>
+            </a:pPr>
+            <a:r>
+              <a:rPr lang="en-US" sz="1100" b="1" dirty="0">
+                <a:solidFill>
+                  <a:srgbClr val="FFFFFF"/>
+                </a:solidFill>
+                <a:latin typeface="Segoe UI" pitchFamily="34" charset="0"/>
+                <a:ea typeface="Segoe UI" pitchFamily="34" charset="-122"/>
+                <a:cs typeface="Segoe UI" pitchFamily="34" charset="-120"/>
+              </a:rPr>
+              <a:t>Better together: The VIP
+</a:t>
+            </a:r>
+            <a:pPr indent="0" marL="0">
+              <a:lnSpc>
+                <a:spcPts val="1150"/>
+              </a:lnSpc>
+              <a:buNone/>
+            </a:pPr>
+            <a:r>
+              <a:rPr lang="en-US" sz="900" dirty="0">
+                <a:solidFill>
+                  <a:srgbClr val="FFFFFF">
+                    <a:alpha val="94000"/>
+                  </a:srgbClr>
+                </a:solidFill>
+                <a:latin typeface="Segoe UI" pitchFamily="34" charset="0"/>
+                <a:ea typeface="Segoe UI" pitchFamily="34" charset="-122"/>
+                <a:cs typeface="Segoe UI" pitchFamily="34" charset="-120"/>
+              </a:rPr>
+              <a:t>Pulse knows who your table guests are, what they spent and when they went quiet — next season’s invitation writes itself.</a:t>
+            </a:r>
+            <a:endParaRPr lang="en-US" sz="1100" dirty="0"/>
+          </a:p>
+        </p:txBody>
+      </p:sp>
+    </p:spTree>
+  </p:cSld>
+  <p:clrMapOvr>
+    <a:masterClrMapping/>
+  </p:clrMapOvr>
+</p:sld>
+</file>
+
+<file path=ppt/slides/slide13.xml><?xml version="1.0" encoding="utf-8"?>
+<p:sld xmlns:a="http://schemas.openxmlformats.org/drawingml/2006/main" xmlns:r="http://schemas.openxmlformats.org/officeDocument/2006/relationships" xmlns:p="http://schemas.openxmlformats.org/presentationml/2006/main">
+  <p:cSld name="Slide 13">
+    <p:bg>
+      <p:bgPr>
+        <a:solidFill>
           <a:srgbClr val="1A1A2E"/>
         </a:solidFill>
       </p:bgPr>
@@ -7851,7 +9223,7 @@
                 <a:ea typeface="Segoe UI" pitchFamily="34" charset="-122"/>
                 <a:cs typeface="Segoe UI" pitchFamily="34" charset="-120"/>
               </a:rPr>
-              <a:t>Fan Owl on your website  </a:t>
+              <a:t>Take action by chat  </a:t>
             </a:r>
             <a:pPr indent="0" marL="0">
               <a:lnSpc>
@@ -7868,7 +9240,7 @@
                 <a:ea typeface="Segoe UI" pitchFamily="34" charset="-122"/>
                 <a:cs typeface="Segoe UI" pitchFamily="34" charset="-120"/>
               </a:rPr>
-              <a:t>— a booking guide on your public event site: answers FAQs from your knowledge base, recommends the right ticket, links to your checkout, captures opted-in fans.</a:t>
+              <a:t>— the Owl doesn’t just answer: it can set up an alert, save a segment or draft a campaign straight from the conversation, with a confirm step before anything is created.</a:t>
             </a:r>
             <a:endParaRPr lang="en-US" sz="1200" dirty="0"/>
           </a:p>
@@ -8103,7 +9475,7 @@
                 <a:ea typeface="Segoe UI" pitchFamily="34" charset="-122"/>
                 <a:cs typeface="Segoe UI" pitchFamily="34" charset="-120"/>
               </a:rPr>
-              <a:t>the same governed data and the same Owl, wherever your team already lives</a:t>
+              <a:t>the Owl at the centre — the doors your team already uses around it</a:t>
             </a:r>
             <a:endParaRPr lang="en-US" sz="1200" dirty="0"/>
           </a:p>
@@ -8308,12 +9680,104 @@
         </p:nvSpPr>
         <p:spPr>
           <a:xfrm>
-            <a:off x="457200" y="1463040"/>
-            <a:ext cx="2697480" cy="1783080"/>
+            <a:off x="3931920" y="2468880"/>
+            <a:ext cx="2157984" cy="1143000"/>
+          </a:xfrm>
+          <a:prstGeom prst="line">
+            <a:avLst/>
+          </a:prstGeom>
+          <a:noFill/>
+          <a:ln w="19050">
+            <a:solidFill>
+              <a:srgbClr val="D6CDF0"/>
+            </a:solidFill>
+            <a:prstDash val="dash"/>
+          </a:ln>
+        </p:spPr>
+      </p:sp>
+      <p:sp>
+        <p:nvSpPr>
+          <p:cNvPr id="12" name="Shape 10"/>
+          <p:cNvSpPr/>
+          <p:nvPr/>
+        </p:nvSpPr>
+        <p:spPr>
+          <a:xfrm flipV="1">
+            <a:off x="3931920" y="3611880"/>
+            <a:ext cx="2157984" cy="1234440"/>
+          </a:xfrm>
+          <a:prstGeom prst="line">
+            <a:avLst/>
+          </a:prstGeom>
+          <a:noFill/>
+          <a:ln w="19050">
+            <a:solidFill>
+              <a:srgbClr val="D6CDF0"/>
+            </a:solidFill>
+            <a:prstDash val="dash"/>
+          </a:ln>
+        </p:spPr>
+      </p:sp>
+      <p:sp>
+        <p:nvSpPr>
+          <p:cNvPr id="13" name="Shape 11"/>
+          <p:cNvSpPr/>
+          <p:nvPr/>
+        </p:nvSpPr>
+        <p:spPr>
+          <a:xfrm>
+            <a:off x="6089904" y="2468880"/>
+            <a:ext cx="2167128" cy="1143000"/>
+          </a:xfrm>
+          <a:prstGeom prst="line">
+            <a:avLst/>
+          </a:prstGeom>
+          <a:noFill/>
+          <a:ln w="19050">
+            <a:solidFill>
+              <a:srgbClr val="D6CDF0"/>
+            </a:solidFill>
+            <a:prstDash val="dash"/>
+          </a:ln>
+        </p:spPr>
+      </p:sp>
+      <p:sp>
+        <p:nvSpPr>
+          <p:cNvPr id="14" name="Shape 12"/>
+          <p:cNvSpPr/>
+          <p:nvPr/>
+        </p:nvSpPr>
+        <p:spPr>
+          <a:xfrm flipV="1">
+            <a:off x="6089904" y="3611880"/>
+            <a:ext cx="2167128" cy="1234440"/>
+          </a:xfrm>
+          <a:prstGeom prst="line">
+            <a:avLst/>
+          </a:prstGeom>
+          <a:noFill/>
+          <a:ln w="19050">
+            <a:solidFill>
+              <a:srgbClr val="D6CDF0"/>
+            </a:solidFill>
+            <a:prstDash val="dash"/>
+          </a:ln>
+        </p:spPr>
+      </p:sp>
+      <p:sp>
+        <p:nvSpPr>
+          <p:cNvPr id="15" name="Shape 13"/>
+          <p:cNvSpPr/>
+          <p:nvPr/>
+        </p:nvSpPr>
+        <p:spPr>
+          <a:xfrm>
+            <a:off x="457200" y="1600200"/>
+            <a:ext cx="3474720" cy="1737360"/>
           </a:xfrm>
           <a:prstGeom prst="roundRect">
             <a:avLst>
-              <a:gd name="adj" fmla="val 5128"/>
+              <a:gd name="adj" fmla="val 6316"/>
             </a:avLst>
           </a:prstGeom>
           <a:solidFill>
@@ -8329,14 +9793,14 @@
       </p:sp>
       <p:sp>
         <p:nvSpPr>
-          <p:cNvPr id="12" name="Text 10"/>
-          <p:cNvSpPr/>
-          <p:nvPr/>
-        </p:nvSpPr>
-        <p:spPr>
-          <a:xfrm>
-            <a:off x="594360" y="1554480"/>
-            <a:ext cx="2423160" cy="365760"/>
+          <p:cNvPr id="16" name="Text 14"/>
+          <p:cNvSpPr/>
+          <p:nvPr/>
+        </p:nvSpPr>
+        <p:spPr>
+          <a:xfrm>
+            <a:off x="621792" y="1691640"/>
+            <a:ext cx="3154680" cy="384048"/>
           </a:xfrm>
           <a:prstGeom prst="rect">
             <a:avLst/>
@@ -8352,7 +9816,7 @@
               <a:buNone/>
             </a:pPr>
             <a:r>
-              <a:rPr lang="en-US" sz="1300" b="1" dirty="0">
+              <a:rPr lang="en-US" sz="1400" b="1" dirty="0">
                 <a:solidFill>
                   <a:srgbClr val="1A1A2E"/>
                 </a:solidFill>
@@ -8360,22 +9824,22 @@
                 <a:ea typeface="Segoe UI" pitchFamily="34" charset="-122"/>
                 <a:cs typeface="Segoe UI" pitchFamily="34" charset="-120"/>
               </a:rPr>
-              <a:t>📱 The Pulse app</a:t>
-            </a:r>
-            <a:endParaRPr lang="en-US" sz="1300" dirty="0"/>
-          </a:p>
-        </p:txBody>
-      </p:sp>
-      <p:sp>
-        <p:nvSpPr>
-          <p:cNvPr id="13" name="Text 11"/>
-          <p:cNvSpPr/>
-          <p:nvPr/>
-        </p:nvSpPr>
-        <p:spPr>
-          <a:xfrm>
-            <a:off x="594360" y="1938528"/>
-            <a:ext cx="2423160" cy="1234440"/>
+              <a:t>📱 The Howler Pulse app</a:t>
+            </a:r>
+            <a:endParaRPr lang="en-US" sz="1400" dirty="0"/>
+          </a:p>
+        </p:txBody>
+      </p:sp>
+      <p:sp>
+        <p:nvSpPr>
+          <p:cNvPr id="17" name="Text 15"/>
+          <p:cNvSpPr/>
+          <p:nvPr/>
+        </p:nvSpPr>
+        <p:spPr>
+          <a:xfrm>
+            <a:off x="621792" y="2103120"/>
+            <a:ext cx="3154680" cy="1143000"/>
           </a:xfrm>
           <a:prstGeom prst="rect">
             <a:avLst/>
@@ -8389,12 +9853,12 @@
           <a:p>
             <a:pPr indent="0" marL="0">
               <a:lnSpc>
-                <a:spcPts val="1300"/>
+                <a:spcPts val="1400"/>
               </a:lnSpc>
               <a:buNone/>
             </a:pPr>
             <a:r>
-              <a:rPr lang="en-US" sz="1000" dirty="0">
+              <a:rPr lang="en-US" sz="1050" dirty="0">
                 <a:solidFill>
                   <a:srgbClr val="55556D"/>
                 </a:solidFill>
@@ -8402,26 +9866,26 @@
                 <a:ea typeface="Segoe UI" pitchFamily="34" charset="-122"/>
                 <a:cs typeface="Segoe UI" pitchFamily="34" charset="-120"/>
               </a:rPr>
-              <a:t>Installs like a native app; push notifications reach you even when it’s closed.</a:t>
-            </a:r>
-            <a:endParaRPr lang="en-US" sz="1000" dirty="0"/>
-          </a:p>
-        </p:txBody>
-      </p:sp>
-      <p:sp>
-        <p:nvSpPr>
-          <p:cNvPr id="14" name="Shape 12"/>
-          <p:cNvSpPr/>
-          <p:nvPr/>
-        </p:nvSpPr>
-        <p:spPr>
-          <a:xfrm>
-            <a:off x="3337560" y="1463040"/>
-            <a:ext cx="2697480" cy="1783080"/>
+              <a:t>Installs like a native app; pushes a nudge even when closed — tap it and you’re in the right place to act.</a:t>
+            </a:r>
+            <a:endParaRPr lang="en-US" sz="1050" dirty="0"/>
+          </a:p>
+        </p:txBody>
+      </p:sp>
+      <p:sp>
+        <p:nvSpPr>
+          <p:cNvPr id="18" name="Shape 16"/>
+          <p:cNvSpPr/>
+          <p:nvPr/>
+        </p:nvSpPr>
+        <p:spPr>
+          <a:xfrm>
+            <a:off x="457200" y="3977640"/>
+            <a:ext cx="3474720" cy="1737360"/>
           </a:xfrm>
           <a:prstGeom prst="roundRect">
             <a:avLst>
-              <a:gd name="adj" fmla="val 5128"/>
+              <a:gd name="adj" fmla="val 6316"/>
             </a:avLst>
           </a:prstGeom>
           <a:solidFill>
@@ -8437,14 +9901,14 @@
       </p:sp>
       <p:sp>
         <p:nvSpPr>
-          <p:cNvPr id="15" name="Text 13"/>
-          <p:cNvSpPr/>
-          <p:nvPr/>
-        </p:nvSpPr>
-        <p:spPr>
-          <a:xfrm>
-            <a:off x="3474720" y="1554480"/>
-            <a:ext cx="2423160" cy="365760"/>
+          <p:cNvPr id="19" name="Text 17"/>
+          <p:cNvSpPr/>
+          <p:nvPr/>
+        </p:nvSpPr>
+        <p:spPr>
+          <a:xfrm>
+            <a:off x="621792" y="4069080"/>
+            <a:ext cx="3154680" cy="384048"/>
           </a:xfrm>
           <a:prstGeom prst="rect">
             <a:avLst/>
@@ -8460,7 +9924,7 @@
               <a:buNone/>
             </a:pPr>
             <a:r>
-              <a:rPr lang="en-US" sz="1300" b="1" dirty="0">
+              <a:rPr lang="en-US" sz="1400" b="1" dirty="0">
                 <a:solidFill>
                   <a:srgbClr val="1A1A2E"/>
                 </a:solidFill>
@@ -8470,20 +9934,20 @@
               </a:rPr>
               <a:t>💬 WhatsApp</a:t>
             </a:r>
-            <a:endParaRPr lang="en-US" sz="1300" dirty="0"/>
-          </a:p>
-        </p:txBody>
-      </p:sp>
-      <p:sp>
-        <p:nvSpPr>
-          <p:cNvPr id="16" name="Text 14"/>
-          <p:cNvSpPr/>
-          <p:nvPr/>
-        </p:nvSpPr>
-        <p:spPr>
-          <a:xfrm>
-            <a:off x="3474720" y="1938528"/>
-            <a:ext cx="2423160" cy="1234440"/>
+            <a:endParaRPr lang="en-US" sz="1400" dirty="0"/>
+          </a:p>
+        </p:txBody>
+      </p:sp>
+      <p:sp>
+        <p:nvSpPr>
+          <p:cNvPr id="20" name="Text 18"/>
+          <p:cNvSpPr/>
+          <p:nvPr/>
+        </p:nvSpPr>
+        <p:spPr>
+          <a:xfrm>
+            <a:off x="621792" y="4480560"/>
+            <a:ext cx="3154680" cy="1143000"/>
           </a:xfrm>
           <a:prstGeom prst="rect">
             <a:avLst/>
@@ -8497,12 +9961,12 @@
           <a:p>
             <a:pPr indent="0" marL="0">
               <a:lnSpc>
-                <a:spcPts val="1300"/>
+                <a:spcPts val="1400"/>
               </a:lnSpc>
               <a:buNone/>
             </a:pPr>
             <a:r>
-              <a:rPr lang="en-US" sz="1000" dirty="0">
+              <a:rPr lang="en-US" sz="1050" dirty="0">
                 <a:solidFill>
                   <a:srgbClr val="55556D"/>
                 </a:solidFill>
@@ -8510,26 +9974,26 @@
                 <a:ea typeface="Segoe UI" pitchFamily="34" charset="-122"/>
                 <a:cs typeface="Segoe UI" pitchFamily="34" charset="-120"/>
               </a:rPr>
-              <a:t>Chat to the Owl: answers, charts as images, daily updates, event-night reports.</a:t>
-            </a:r>
-            <a:endParaRPr lang="en-US" sz="1000" dirty="0"/>
-          </a:p>
-        </p:txBody>
-      </p:sp>
-      <p:sp>
-        <p:nvSpPr>
-          <p:cNvPr id="17" name="Shape 15"/>
-          <p:cNvSpPr/>
-          <p:nvPr/>
-        </p:nvSpPr>
-        <p:spPr>
-          <a:xfrm>
-            <a:off x="6217920" y="1463040"/>
-            <a:ext cx="2697480" cy="1783080"/>
+              <a:t>Message the Owl like a colleague: answers, charts as images, daily updates, event-night reports.</a:t>
+            </a:r>
+            <a:endParaRPr lang="en-US" sz="1050" dirty="0"/>
+          </a:p>
+        </p:txBody>
+      </p:sp>
+      <p:sp>
+        <p:nvSpPr>
+          <p:cNvPr id="21" name="Shape 19"/>
+          <p:cNvSpPr/>
+          <p:nvPr/>
+        </p:nvSpPr>
+        <p:spPr>
+          <a:xfrm>
+            <a:off x="8257032" y="1600200"/>
+            <a:ext cx="3474720" cy="1737360"/>
           </a:xfrm>
           <a:prstGeom prst="roundRect">
             <a:avLst>
-              <a:gd name="adj" fmla="val 5128"/>
+              <a:gd name="adj" fmla="val 6316"/>
             </a:avLst>
           </a:prstGeom>
           <a:solidFill>
@@ -8545,14 +10009,14 @@
       </p:sp>
       <p:sp>
         <p:nvSpPr>
-          <p:cNvPr id="18" name="Text 16"/>
-          <p:cNvSpPr/>
-          <p:nvPr/>
-        </p:nvSpPr>
-        <p:spPr>
-          <a:xfrm>
-            <a:off x="6355080" y="1554480"/>
-            <a:ext cx="2423160" cy="365760"/>
+          <p:cNvPr id="22" name="Text 20"/>
+          <p:cNvSpPr/>
+          <p:nvPr/>
+        </p:nvSpPr>
+        <p:spPr>
+          <a:xfrm>
+            <a:off x="8421624" y="1691640"/>
+            <a:ext cx="3154680" cy="384048"/>
           </a:xfrm>
           <a:prstGeom prst="rect">
             <a:avLst/>
@@ -8568,7 +10032,7 @@
               <a:buNone/>
             </a:pPr>
             <a:r>
-              <a:rPr lang="en-US" sz="1300" b="1" dirty="0">
+              <a:rPr lang="en-US" sz="1400" b="1" dirty="0">
                 <a:solidFill>
                   <a:srgbClr val="1A1A2E"/>
                 </a:solidFill>
@@ -8576,22 +10040,22 @@
                 <a:ea typeface="Segoe UI" pitchFamily="34" charset="-122"/>
                 <a:cs typeface="Segoe UI" pitchFamily="34" charset="-120"/>
               </a:rPr>
-              <a:t>🤖 ChatGPT &amp; Claude</a:t>
-            </a:r>
-            <a:endParaRPr lang="en-US" sz="1300" dirty="0"/>
-          </a:p>
-        </p:txBody>
-      </p:sp>
-      <p:sp>
-        <p:nvSpPr>
-          <p:cNvPr id="19" name="Text 17"/>
-          <p:cNvSpPr/>
-          <p:nvPr/>
-        </p:nvSpPr>
-        <p:spPr>
-          <a:xfrm>
-            <a:off x="6355080" y="1938528"/>
-            <a:ext cx="2423160" cy="1234440"/>
+              <a:t>🤖 ChatGPT</a:t>
+            </a:r>
+            <a:endParaRPr lang="en-US" sz="1400" dirty="0"/>
+          </a:p>
+        </p:txBody>
+      </p:sp>
+      <p:sp>
+        <p:nvSpPr>
+          <p:cNvPr id="23" name="Text 21"/>
+          <p:cNvSpPr/>
+          <p:nvPr/>
+        </p:nvSpPr>
+        <p:spPr>
+          <a:xfrm>
+            <a:off x="8421624" y="2103120"/>
+            <a:ext cx="3154680" cy="1143000"/>
           </a:xfrm>
           <a:prstGeom prst="rect">
             <a:avLst/>
@@ -8605,12 +10069,12 @@
           <a:p>
             <a:pPr indent="0" marL="0">
               <a:lnSpc>
-                <a:spcPts val="1300"/>
+                <a:spcPts val="1400"/>
               </a:lnSpc>
               <a:buNone/>
             </a:pPr>
             <a:r>
-              <a:rPr lang="en-US" sz="1000" dirty="0">
+              <a:rPr lang="en-US" sz="1050" dirty="0">
                 <a:solidFill>
                   <a:srgbClr val="55556D"/>
                 </a:solidFill>
@@ -8618,26 +10082,26 @@
                 <a:ea typeface="Segoe UI" pitchFamily="34" charset="-122"/>
                 <a:cs typeface="Segoe UI" pitchFamily="34" charset="-120"/>
               </a:rPr>
-              <a:t>Ask about your events from the AI tools you already use, via the Pulse connector.</a:t>
-            </a:r>
-            <a:endParaRPr lang="en-US" sz="1000" dirty="0"/>
-          </a:p>
-        </p:txBody>
-      </p:sp>
-      <p:sp>
-        <p:nvSpPr>
-          <p:cNvPr id="20" name="Shape 18"/>
-          <p:cNvSpPr/>
-          <p:nvPr/>
-        </p:nvSpPr>
-        <p:spPr>
-          <a:xfrm>
-            <a:off x="9098280" y="1463040"/>
-            <a:ext cx="2697480" cy="1783080"/>
+              <a:t>Connect Pulse to ChatGPT (incl. Deep Research) and ask about your events from the tool you already have open.</a:t>
+            </a:r>
+            <a:endParaRPr lang="en-US" sz="1050" dirty="0"/>
+          </a:p>
+        </p:txBody>
+      </p:sp>
+      <p:sp>
+        <p:nvSpPr>
+          <p:cNvPr id="24" name="Shape 22"/>
+          <p:cNvSpPr/>
+          <p:nvPr/>
+        </p:nvSpPr>
+        <p:spPr>
+          <a:xfrm>
+            <a:off x="8257032" y="3977640"/>
+            <a:ext cx="3474720" cy="1737360"/>
           </a:xfrm>
           <a:prstGeom prst="roundRect">
             <a:avLst>
-              <a:gd name="adj" fmla="val 5128"/>
+              <a:gd name="adj" fmla="val 6316"/>
             </a:avLst>
           </a:prstGeom>
           <a:solidFill>
@@ -8653,14 +10117,14 @@
       </p:sp>
       <p:sp>
         <p:nvSpPr>
-          <p:cNvPr id="21" name="Text 19"/>
-          <p:cNvSpPr/>
-          <p:nvPr/>
-        </p:nvSpPr>
-        <p:spPr>
-          <a:xfrm>
-            <a:off x="9235440" y="1554480"/>
-            <a:ext cx="2423160" cy="365760"/>
+          <p:cNvPr id="25" name="Text 23"/>
+          <p:cNvSpPr/>
+          <p:nvPr/>
+        </p:nvSpPr>
+        <p:spPr>
+          <a:xfrm>
+            <a:off x="8421624" y="4069080"/>
+            <a:ext cx="3154680" cy="384048"/>
           </a:xfrm>
           <a:prstGeom prst="rect">
             <a:avLst/>
@@ -8676,7 +10140,7 @@
               <a:buNone/>
             </a:pPr>
             <a:r>
-              <a:rPr lang="en-US" sz="1300" b="1" dirty="0">
+              <a:rPr lang="en-US" sz="1400" b="1" dirty="0">
                 <a:solidFill>
                   <a:srgbClr val="1A1A2E"/>
                 </a:solidFill>
@@ -8684,22 +10148,22 @@
                 <a:ea typeface="Segoe UI" pitchFamily="34" charset="-122"/>
                 <a:cs typeface="Segoe UI" pitchFamily="34" charset="-120"/>
               </a:rPr>
-              <a:t>✉️ Email</a:t>
-            </a:r>
-            <a:endParaRPr lang="en-US" sz="1300" dirty="0"/>
-          </a:p>
-        </p:txBody>
-      </p:sp>
-      <p:sp>
-        <p:nvSpPr>
-          <p:cNvPr id="22" name="Text 20"/>
-          <p:cNvSpPr/>
-          <p:nvPr/>
-        </p:nvSpPr>
-        <p:spPr>
-          <a:xfrm>
-            <a:off x="9235440" y="1938528"/>
-            <a:ext cx="2423160" cy="1234440"/>
+              <a:t>✳️ Claude</a:t>
+            </a:r>
+            <a:endParaRPr lang="en-US" sz="1400" dirty="0"/>
+          </a:p>
+        </p:txBody>
+      </p:sp>
+      <p:sp>
+        <p:nvSpPr>
+          <p:cNvPr id="26" name="Text 24"/>
+          <p:cNvSpPr/>
+          <p:nvPr/>
+        </p:nvSpPr>
+        <p:spPr>
+          <a:xfrm>
+            <a:off x="8421624" y="4480560"/>
+            <a:ext cx="3154680" cy="1143000"/>
           </a:xfrm>
           <a:prstGeom prst="rect">
             <a:avLst/>
@@ -8713,12 +10177,12 @@
           <a:p>
             <a:pPr indent="0" marL="0">
               <a:lnSpc>
-                <a:spcPts val="1300"/>
+                <a:spcPts val="1400"/>
               </a:lnSpc>
               <a:buNone/>
             </a:pPr>
             <a:r>
-              <a:rPr lang="en-US" sz="1000" dirty="0">
+              <a:rPr lang="en-US" sz="1050" dirty="0">
                 <a:solidFill>
                   <a:srgbClr val="55556D"/>
                 </a:solidFill>
@@ -8726,459 +10190,45 @@
                 <a:ea typeface="Segoe UI" pitchFamily="34" charset="-122"/>
                 <a:cs typeface="Segoe UI" pitchFamily="34" charset="-120"/>
               </a:rPr>
-              <a:t>Role-based digests, branded campaigns from your own domain, CC-the-Owl filing.</a:t>
-            </a:r>
-            <a:endParaRPr lang="en-US" sz="1000" dirty="0"/>
-          </a:p>
-        </p:txBody>
-      </p:sp>
-      <p:sp>
-        <p:nvSpPr>
-          <p:cNvPr id="23" name="Shape 21"/>
-          <p:cNvSpPr/>
-          <p:nvPr/>
-        </p:nvSpPr>
-        <p:spPr>
-          <a:xfrm>
-            <a:off x="457200" y="3429000"/>
-            <a:ext cx="2697480" cy="1783080"/>
-          </a:xfrm>
-          <a:prstGeom prst="roundRect">
-            <a:avLst>
-              <a:gd name="adj" fmla="val 5128"/>
-            </a:avLst>
+              <a:t>The same connector plugs your event data into Claude — read-only, per-client keys you control.</a:t>
+            </a:r>
+            <a:endParaRPr lang="en-US" sz="1050" dirty="0"/>
+          </a:p>
+        </p:txBody>
+      </p:sp>
+      <p:sp>
+        <p:nvSpPr>
+          <p:cNvPr id="27" name="Shape 25"/>
+          <p:cNvSpPr/>
+          <p:nvPr/>
+        </p:nvSpPr>
+        <p:spPr>
+          <a:xfrm>
+            <a:off x="4956048" y="2468880"/>
+            <a:ext cx="2286000" cy="2286000"/>
+          </a:xfrm>
+          <a:prstGeom prst="ellipse">
+            <a:avLst/>
           </a:prstGeom>
           <a:solidFill>
-            <a:srgbClr val="FBFAFF"/>
+            <a:srgbClr val="FF385C"/>
           </a:solidFill>
-          <a:ln w="12700">
-            <a:solidFill>
-              <a:srgbClr val="ECE9F5"/>
-            </a:solidFill>
-            <a:prstDash val="solid"/>
-          </a:ln>
-        </p:spPr>
-      </p:sp>
-      <p:sp>
-        <p:nvSpPr>
-          <p:cNvPr id="24" name="Text 22"/>
-          <p:cNvSpPr/>
-          <p:nvPr/>
-        </p:nvSpPr>
-        <p:spPr>
-          <a:xfrm>
-            <a:off x="594360" y="3520440"/>
-            <a:ext cx="2423160" cy="365760"/>
-          </a:xfrm>
-          <a:prstGeom prst="rect">
-            <a:avLst/>
-          </a:prstGeom>
-          <a:noFill/>
-          <a:ln/>
-        </p:spPr>
-        <p:txBody>
-          <a:bodyPr wrap="square" rtlCol="0" anchor="ctr"/>
-          <a:lstStyle/>
-          <a:p>
-            <a:pPr indent="0" marL="0">
-              <a:buNone/>
-            </a:pPr>
-            <a:r>
-              <a:rPr lang="en-US" sz="1300" b="1" dirty="0">
-                <a:solidFill>
-                  <a:srgbClr val="1A1A2E"/>
-                </a:solidFill>
-                <a:latin typeface="Segoe UI" pitchFamily="34" charset="0"/>
-                <a:ea typeface="Segoe UI" pitchFamily="34" charset="-122"/>
-                <a:cs typeface="Segoe UI" pitchFamily="34" charset="-120"/>
-              </a:rPr>
-              <a:t>📲 SMS</a:t>
-            </a:r>
-            <a:endParaRPr lang="en-US" sz="1300" dirty="0"/>
-          </a:p>
-        </p:txBody>
-      </p:sp>
-      <p:sp>
-        <p:nvSpPr>
-          <p:cNvPr id="25" name="Text 23"/>
-          <p:cNvSpPr/>
-          <p:nvPr/>
-        </p:nvSpPr>
-        <p:spPr>
-          <a:xfrm>
-            <a:off x="594360" y="3904488"/>
-            <a:ext cx="2423160" cy="1234440"/>
-          </a:xfrm>
-          <a:prstGeom prst="rect">
-            <a:avLst/>
-          </a:prstGeom>
-          <a:noFill/>
-          <a:ln/>
-        </p:spPr>
-        <p:txBody>
-          <a:bodyPr wrap="square" rtlCol="0" anchor="t"/>
-          <a:lstStyle/>
-          <a:p>
-            <a:pPr indent="0" marL="0">
-              <a:lnSpc>
-                <a:spcPts val="1300"/>
-              </a:lnSpc>
-              <a:buNone/>
-            </a:pPr>
-            <a:r>
-              <a:rPr lang="en-US" sz="1000" dirty="0">
-                <a:solidFill>
-                  <a:srgbClr val="55556D"/>
-                </a:solidFill>
-                <a:latin typeface="Segoe UI" pitchFamily="34" charset="0"/>
-                <a:ea typeface="Segoe UI" pitchFamily="34" charset="-122"/>
-                <a:cs typeface="Segoe UI" pitchFamily="34" charset="-120"/>
-              </a:rPr>
-              <a:t>Campaigns, urgent alerts and event-night reports — for moments that can’t wait.</a:t>
-            </a:r>
-            <a:endParaRPr lang="en-US" sz="1000" dirty="0"/>
-          </a:p>
-        </p:txBody>
-      </p:sp>
-      <p:sp>
-        <p:nvSpPr>
-          <p:cNvPr id="26" name="Shape 24"/>
-          <p:cNvSpPr/>
-          <p:nvPr/>
-        </p:nvSpPr>
-        <p:spPr>
-          <a:xfrm>
-            <a:off x="3337560" y="3429000"/>
-            <a:ext cx="2697480" cy="1783080"/>
-          </a:xfrm>
-          <a:prstGeom prst="roundRect">
-            <a:avLst>
-              <a:gd name="adj" fmla="val 5128"/>
-            </a:avLst>
-          </a:prstGeom>
-          <a:solidFill>
-            <a:srgbClr val="FBFAFF"/>
-          </a:solidFill>
-          <a:ln w="12700">
-            <a:solidFill>
-              <a:srgbClr val="ECE9F5"/>
-            </a:solidFill>
-            <a:prstDash val="solid"/>
-          </a:ln>
-        </p:spPr>
-      </p:sp>
-      <p:sp>
-        <p:nvSpPr>
-          <p:cNvPr id="27" name="Text 25"/>
-          <p:cNvSpPr/>
-          <p:nvPr/>
-        </p:nvSpPr>
-        <p:spPr>
-          <a:xfrm>
-            <a:off x="3474720" y="3520440"/>
-            <a:ext cx="2423160" cy="365760"/>
-          </a:xfrm>
-          <a:prstGeom prst="rect">
-            <a:avLst/>
-          </a:prstGeom>
-          <a:noFill/>
-          <a:ln/>
-        </p:spPr>
-        <p:txBody>
-          <a:bodyPr wrap="square" rtlCol="0" anchor="ctr"/>
-          <a:lstStyle/>
-          <a:p>
-            <a:pPr indent="0" marL="0">
-              <a:buNone/>
-            </a:pPr>
-            <a:r>
-              <a:rPr lang="en-US" sz="1300" b="1" dirty="0">
-                <a:solidFill>
-                  <a:srgbClr val="1A1A2E"/>
-                </a:solidFill>
-                <a:latin typeface="Segoe UI" pitchFamily="34" charset="0"/>
-                <a:ea typeface="Segoe UI" pitchFamily="34" charset="-122"/>
-                <a:cs typeface="Segoe UI" pitchFamily="34" charset="-120"/>
-              </a:rPr>
-              <a:t>💼 Slack</a:t>
-            </a:r>
-            <a:endParaRPr lang="en-US" sz="1300" dirty="0"/>
-          </a:p>
-        </p:txBody>
-      </p:sp>
-      <p:sp>
-        <p:nvSpPr>
-          <p:cNvPr id="28" name="Text 26"/>
-          <p:cNvSpPr/>
-          <p:nvPr/>
-        </p:nvSpPr>
-        <p:spPr>
-          <a:xfrm>
-            <a:off x="3474720" y="3904488"/>
-            <a:ext cx="2423160" cy="1234440"/>
-          </a:xfrm>
-          <a:prstGeom prst="rect">
-            <a:avLst/>
-          </a:prstGeom>
-          <a:noFill/>
-          <a:ln/>
-        </p:spPr>
-        <p:txBody>
-          <a:bodyPr wrap="square" rtlCol="0" anchor="t"/>
-          <a:lstStyle/>
-          <a:p>
-            <a:pPr indent="0" marL="0">
-              <a:lnSpc>
-                <a:spcPts val="1300"/>
-              </a:lnSpc>
-              <a:buNone/>
-            </a:pPr>
-            <a:r>
-              <a:rPr lang="en-US" sz="1000" dirty="0">
-                <a:solidFill>
-                  <a:srgbClr val="55556D"/>
-                </a:solidFill>
-                <a:latin typeface="Segoe UI" pitchFamily="34" charset="0"/>
-                <a:ea typeface="Segoe UI" pitchFamily="34" charset="-122"/>
-                <a:cs typeface="Segoe UI" pitchFamily="34" charset="-120"/>
-              </a:rPr>
-              <a:t>Mirror notifications into your channel; share any insight in one tap.</a:t>
-            </a:r>
-            <a:endParaRPr lang="en-US" sz="1000" dirty="0"/>
-          </a:p>
-        </p:txBody>
-      </p:sp>
-      <p:sp>
-        <p:nvSpPr>
-          <p:cNvPr id="29" name="Shape 27"/>
-          <p:cNvSpPr/>
-          <p:nvPr/>
-        </p:nvSpPr>
-        <p:spPr>
-          <a:xfrm>
-            <a:off x="6217920" y="3429000"/>
-            <a:ext cx="2697480" cy="1783080"/>
-          </a:xfrm>
-          <a:prstGeom prst="roundRect">
-            <a:avLst>
-              <a:gd name="adj" fmla="val 5128"/>
-            </a:avLst>
-          </a:prstGeom>
-          <a:solidFill>
-            <a:srgbClr val="FBFAFF"/>
-          </a:solidFill>
-          <a:ln w="12700">
-            <a:solidFill>
-              <a:srgbClr val="ECE9F5"/>
-            </a:solidFill>
-            <a:prstDash val="solid"/>
-          </a:ln>
-        </p:spPr>
-      </p:sp>
-      <p:sp>
-        <p:nvSpPr>
-          <p:cNvPr id="30" name="Text 28"/>
-          <p:cNvSpPr/>
-          <p:nvPr/>
-        </p:nvSpPr>
-        <p:spPr>
-          <a:xfrm>
-            <a:off x="6355080" y="3520440"/>
-            <a:ext cx="2423160" cy="365760"/>
-          </a:xfrm>
-          <a:prstGeom prst="rect">
-            <a:avLst/>
-          </a:prstGeom>
-          <a:noFill/>
-          <a:ln/>
-        </p:spPr>
-        <p:txBody>
-          <a:bodyPr wrap="square" rtlCol="0" anchor="ctr"/>
-          <a:lstStyle/>
-          <a:p>
-            <a:pPr indent="0" marL="0">
-              <a:buNone/>
-            </a:pPr>
-            <a:r>
-              <a:rPr lang="en-US" sz="1300" b="1" dirty="0">
-                <a:solidFill>
-                  <a:srgbClr val="1A1A2E"/>
-                </a:solidFill>
-                <a:latin typeface="Segoe UI" pitchFamily="34" charset="0"/>
-                <a:ea typeface="Segoe UI" pitchFamily="34" charset="-122"/>
-                <a:cs typeface="Segoe UI" pitchFamily="34" charset="-120"/>
-              </a:rPr>
-              <a:t>🌐 Your website</a:t>
-            </a:r>
-            <a:endParaRPr lang="en-US" sz="1300" dirty="0"/>
-          </a:p>
-        </p:txBody>
-      </p:sp>
-      <p:sp>
-        <p:nvSpPr>
-          <p:cNvPr id="31" name="Text 29"/>
-          <p:cNvSpPr/>
-          <p:nvPr/>
-        </p:nvSpPr>
-        <p:spPr>
-          <a:xfrm>
-            <a:off x="6355080" y="3904488"/>
-            <a:ext cx="2423160" cy="1234440"/>
-          </a:xfrm>
-          <a:prstGeom prst="rect">
-            <a:avLst/>
-          </a:prstGeom>
-          <a:noFill/>
-          <a:ln/>
-        </p:spPr>
-        <p:txBody>
-          <a:bodyPr wrap="square" rtlCol="0" anchor="t"/>
-          <a:lstStyle/>
-          <a:p>
-            <a:pPr indent="0" marL="0">
-              <a:lnSpc>
-                <a:spcPts val="1300"/>
-              </a:lnSpc>
-              <a:buNone/>
-            </a:pPr>
-            <a:r>
-              <a:rPr lang="en-US" sz="1000" dirty="0">
-                <a:solidFill>
-                  <a:srgbClr val="55556D"/>
-                </a:solidFill>
-                <a:latin typeface="Segoe UI" pitchFamily="34" charset="0"/>
-                <a:ea typeface="Segoe UI" pitchFamily="34" charset="-122"/>
-                <a:cs typeface="Segoe UI" pitchFamily="34" charset="-120"/>
-              </a:rPr>
-              <a:t>The Fan Owl widget guides fans to the right ticket on every page of your site.</a:t>
-            </a:r>
-            <a:endParaRPr lang="en-US" sz="1000" dirty="0"/>
-          </a:p>
-        </p:txBody>
-      </p:sp>
-      <p:sp>
-        <p:nvSpPr>
-          <p:cNvPr id="32" name="Shape 30"/>
-          <p:cNvSpPr/>
-          <p:nvPr/>
-        </p:nvSpPr>
-        <p:spPr>
-          <a:xfrm>
-            <a:off x="9098280" y="3429000"/>
-            <a:ext cx="2697480" cy="1783080"/>
-          </a:xfrm>
-          <a:prstGeom prst="roundRect">
-            <a:avLst>
-              <a:gd name="adj" fmla="val 5128"/>
-            </a:avLst>
-          </a:prstGeom>
-          <a:solidFill>
-            <a:srgbClr val="FBFAFF"/>
-          </a:solidFill>
-          <a:ln w="12700">
-            <a:solidFill>
-              <a:srgbClr val="ECE9F5"/>
-            </a:solidFill>
-            <a:prstDash val="solid"/>
-          </a:ln>
-        </p:spPr>
-      </p:sp>
-      <p:sp>
-        <p:nvSpPr>
-          <p:cNvPr id="33" name="Text 31"/>
-          <p:cNvSpPr/>
-          <p:nvPr/>
-        </p:nvSpPr>
-        <p:spPr>
-          <a:xfrm>
-            <a:off x="9235440" y="3520440"/>
-            <a:ext cx="2423160" cy="365760"/>
-          </a:xfrm>
-          <a:prstGeom prst="rect">
-            <a:avLst/>
-          </a:prstGeom>
-          <a:noFill/>
-          <a:ln/>
-        </p:spPr>
-        <p:txBody>
-          <a:bodyPr wrap="square" rtlCol="0" anchor="ctr"/>
-          <a:lstStyle/>
-          <a:p>
-            <a:pPr indent="0" marL="0">
-              <a:buNone/>
-            </a:pPr>
-            <a:r>
-              <a:rPr lang="en-US" sz="1300" b="1" dirty="0">
-                <a:solidFill>
-                  <a:srgbClr val="1A1A2E"/>
-                </a:solidFill>
-                <a:latin typeface="Segoe UI" pitchFamily="34" charset="0"/>
-                <a:ea typeface="Segoe UI" pitchFamily="34" charset="-122"/>
-                <a:cs typeface="Segoe UI" pitchFamily="34" charset="-120"/>
-              </a:rPr>
-              <a:t>🎫 Howler portal</a:t>
-            </a:r>
-            <a:endParaRPr lang="en-US" sz="1300" dirty="0"/>
-          </a:p>
-        </p:txBody>
-      </p:sp>
-      <p:sp>
-        <p:nvSpPr>
-          <p:cNvPr id="34" name="Text 32"/>
-          <p:cNvSpPr/>
-          <p:nvPr/>
-        </p:nvSpPr>
-        <p:spPr>
-          <a:xfrm>
-            <a:off x="9235440" y="3904488"/>
-            <a:ext cx="2423160" cy="1234440"/>
-          </a:xfrm>
-          <a:prstGeom prst="rect">
-            <a:avLst/>
-          </a:prstGeom>
-          <a:noFill/>
-          <a:ln/>
-        </p:spPr>
-        <p:txBody>
-          <a:bodyPr wrap="square" rtlCol="0" anchor="t"/>
-          <a:lstStyle/>
-          <a:p>
-            <a:pPr indent="0" marL="0">
-              <a:lnSpc>
-                <a:spcPts val="1300"/>
-              </a:lnSpc>
-              <a:buNone/>
-            </a:pPr>
-            <a:r>
-              <a:rPr lang="en-US" sz="1000" dirty="0">
-                <a:solidFill>
-                  <a:srgbClr val="55556D"/>
-                </a:solidFill>
-                <a:latin typeface="Segoe UI" pitchFamily="34" charset="0"/>
-                <a:ea typeface="Segoe UI" pitchFamily="34" charset="-122"/>
-                <a:cs typeface="Segoe UI" pitchFamily="34" charset="-120"/>
-              </a:rPr>
-              <a:t>The Owl embedded in the organizer portal you already use every day.</a:t>
-            </a:r>
-            <a:endParaRPr lang="en-US" sz="1000" dirty="0"/>
-          </a:p>
-        </p:txBody>
-      </p:sp>
-      <p:sp>
-        <p:nvSpPr>
-          <p:cNvPr id="35" name="Shape 33"/>
-          <p:cNvSpPr/>
-          <p:nvPr/>
-        </p:nvSpPr>
-        <p:spPr>
-          <a:xfrm>
-            <a:off x="457200" y="5486400"/>
-            <a:ext cx="11338560" cy="777240"/>
-          </a:xfrm>
-          <a:prstGeom prst="roundRect">
-            <a:avLst>
-              <a:gd name="adj" fmla="val 11765"/>
-            </a:avLst>
+          <a:ln/>
+        </p:spPr>
+      </p:sp>
+      <p:sp>
+        <p:nvSpPr>
+          <p:cNvPr id="28" name="Shape 26"/>
+          <p:cNvSpPr/>
+          <p:nvPr/>
+        </p:nvSpPr>
+        <p:spPr>
+          <a:xfrm>
+            <a:off x="5047488" y="2560320"/>
+            <a:ext cx="2103120" cy="2103120"/>
+          </a:xfrm>
+          <a:prstGeom prst="ellipse">
+            <a:avLst/>
           </a:prstGeom>
           <a:solidFill>
             <a:srgbClr val="1A1A2E"/>
@@ -9188,14 +10238,14 @@
       </p:sp>
       <p:sp>
         <p:nvSpPr>
-          <p:cNvPr id="36" name="Text 34"/>
-          <p:cNvSpPr/>
-          <p:nvPr/>
-        </p:nvSpPr>
-        <p:spPr>
-          <a:xfrm>
-            <a:off x="731520" y="5486400"/>
-            <a:ext cx="10789920" cy="777240"/>
+          <p:cNvPr id="29" name="Text 27"/>
+          <p:cNvSpPr/>
+          <p:nvPr/>
+        </p:nvSpPr>
+        <p:spPr>
+          <a:xfrm>
+            <a:off x="4956048" y="2468880"/>
+            <a:ext cx="2286000" cy="2286000"/>
           </a:xfrm>
           <a:prstGeom prst="rect">
             <a:avLst/>
@@ -9211,7 +10261,98 @@
               <a:buNone/>
             </a:pPr>
             <a:r>
-              <a:rPr lang="en-US" sz="1400" b="1" dirty="0">
+              <a:rPr lang="en-US" sz="2600" dirty="0">
+                <a:solidFill>
+                  <a:srgbClr val="000000"/>
+                </a:solidFill>
+                <a:latin typeface="Segoe UI" pitchFamily="34" charset="0"/>
+                <a:ea typeface="Segoe UI" pitchFamily="34" charset="-122"/>
+                <a:cs typeface="Segoe UI" pitchFamily="34" charset="-120"/>
+              </a:rPr>
+              <a:t>🦉
+</a:t>
+            </a:r>
+            <a:pPr algn="ctr" indent="0" marL="0">
+              <a:buNone/>
+            </a:pPr>
+            <a:r>
+              <a:rPr lang="en-US" sz="1200" b="1" dirty="0">
+                <a:solidFill>
+                  <a:srgbClr val="FFFFFF"/>
+                </a:solidFill>
+                <a:latin typeface="Segoe UI" pitchFamily="34" charset="0"/>
+                <a:ea typeface="Segoe UI" pitchFamily="34" charset="-122"/>
+                <a:cs typeface="Segoe UI" pitchFamily="34" charset="-120"/>
+              </a:rPr>
+              <a:t>THE OWL
+</a:t>
+            </a:r>
+            <a:pPr algn="ctr" indent="0" marL="0">
+              <a:buNone/>
+            </a:pPr>
+            <a:r>
+              <a:rPr lang="en-US" sz="800" dirty="0">
+                <a:solidFill>
+                  <a:srgbClr val="B8B3D9"/>
+                </a:solidFill>
+                <a:latin typeface="Segoe UI" pitchFamily="34" charset="0"/>
+                <a:ea typeface="Segoe UI" pitchFamily="34" charset="-122"/>
+                <a:cs typeface="Segoe UI" pitchFamily="34" charset="-120"/>
+              </a:rPr>
+              <a:t>one brain · your data</a:t>
+            </a:r>
+            <a:endParaRPr lang="en-US" sz="2600" dirty="0"/>
+          </a:p>
+        </p:txBody>
+      </p:sp>
+      <p:sp>
+        <p:nvSpPr>
+          <p:cNvPr id="30" name="Shape 28"/>
+          <p:cNvSpPr/>
+          <p:nvPr/>
+        </p:nvSpPr>
+        <p:spPr>
+          <a:xfrm>
+            <a:off x="457200" y="5943600"/>
+            <a:ext cx="11338560" cy="502920"/>
+          </a:xfrm>
+          <a:prstGeom prst="roundRect">
+            <a:avLst>
+              <a:gd name="adj" fmla="val 14545"/>
+            </a:avLst>
+          </a:prstGeom>
+          <a:solidFill>
+            <a:srgbClr val="1A1A2E"/>
+          </a:solidFill>
+          <a:ln/>
+        </p:spPr>
+      </p:sp>
+      <p:sp>
+        <p:nvSpPr>
+          <p:cNvPr id="31" name="Text 29"/>
+          <p:cNvSpPr/>
+          <p:nvPr/>
+        </p:nvSpPr>
+        <p:spPr>
+          <a:xfrm>
+            <a:off x="731520" y="5943600"/>
+            <a:ext cx="10789920" cy="502920"/>
+          </a:xfrm>
+          <a:prstGeom prst="rect">
+            <a:avLst/>
+          </a:prstGeom>
+          <a:noFill/>
+          <a:ln/>
+        </p:spPr>
+        <p:txBody>
+          <a:bodyPr wrap="square" rtlCol="0" anchor="ctr"/>
+          <a:lstStyle/>
+          <a:p>
+            <a:pPr algn="ctr" indent="0" marL="0">
+              <a:buNone/>
+            </a:pPr>
+            <a:r>
+              <a:rPr lang="en-US" sz="1250" b="1" dirty="0">
                 <a:solidFill>
                   <a:srgbClr val="D8D4F0"/>
                 </a:solidFill>
@@ -9219,9 +10360,9 @@
                 <a:ea typeface="Segoe UI" pitchFamily="34" charset="-122"/>
                 <a:cs typeface="Segoe UI" pitchFamily="34" charset="-120"/>
               </a:rPr>
-              <a:t>Nobody has to change how they work — Pulse comes to them. Same data, same security boundary, every surface.</a:t>
-            </a:r>
-            <a:endParaRPr lang="en-US" sz="1400" dirty="0"/>
+              <a:t>Ask in the app, on WhatsApp, in ChatGPT or Claude — same Owl, same live data, same security boundary.</a:t>
+            </a:r>
+            <a:endParaRPr lang="en-US" sz="1250" dirty="0"/>
           </a:p>
         </p:txBody>
       </p:sp>
@@ -11493,8 +12634,8 @@
         </p:nvSpPr>
         <p:spPr>
           <a:xfrm>
-            <a:off x="457200" y="1417320"/>
-            <a:ext cx="5486400" cy="914400"/>
+            <a:off x="457200" y="1371600"/>
+            <a:ext cx="5394960" cy="914400"/>
           </a:xfrm>
           <a:prstGeom prst="rect">
             <a:avLst/>
@@ -11521,7 +12662,7 @@
                 <a:ea typeface="Segoe UI" pitchFamily="34" charset="-122"/>
                 <a:cs typeface="Segoe UI" pitchFamily="34" charset="-120"/>
               </a:rPr>
-              <a:t>The live overview  </a:t>
+              <a:t>The live site map  </a:t>
             </a:r>
             <a:pPr indent="0" marL="0">
               <a:lnSpc>
@@ -11538,7 +12679,7 @@
                 <a:ea typeface="Segoe UI" pitchFamily="34" charset="-122"/>
                 <a:cs typeface="Segoe UI" pitchFamily="34" charset="-120"/>
               </a:rPr>
-              <a:t>— device counts by state, per-station deployment, open issues and a live activity feed: the “where is everything right now” board.</a:t>
+              <a:t>— your venue’s own plan with every station pinned: heat shows where the crowd is spending right now; a dark station is flagged the moment its data stops.</a:t>
             </a:r>
             <a:endParaRPr lang="en-US" sz="1200" dirty="0"/>
           </a:p>
@@ -11552,8 +12693,8 @@
         </p:nvSpPr>
         <p:spPr>
           <a:xfrm>
-            <a:off x="457200" y="2514600"/>
-            <a:ext cx="5486400" cy="914400"/>
+            <a:off x="457200" y="2395728"/>
+            <a:ext cx="5394960" cy="914400"/>
           </a:xfrm>
           <a:prstGeom prst="rect">
             <a:avLst/>
@@ -11597,7 +12738,7 @@
                 <a:ea typeface="Segoe UI" pitchFamily="34" charset="-122"/>
                 <a:cs typeface="Segoe UI" pitchFamily="34" charset="-120"/>
               </a:rPr>
-              <a:t>— every station’s activity through the day in time blocks: watch the crowd move, spot the overloaded station and the dead one, staff accordingly.</a:t>
+              <a:t>— station activity through the day in time blocks: watch the crowd move, spot the overloaded station and the dead one, staff accordingly.</a:t>
             </a:r>
             <a:endParaRPr lang="en-US" sz="1200" dirty="0"/>
           </a:p>
@@ -11611,8 +12752,8 @@
         </p:nvSpPr>
         <p:spPr>
           <a:xfrm>
-            <a:off x="457200" y="3611880"/>
-            <a:ext cx="5486400" cy="914400"/>
+            <a:off x="457200" y="3419856"/>
+            <a:ext cx="5394960" cy="914400"/>
           </a:xfrm>
           <a:prstGeom prst="rect">
             <a:avLst/>
@@ -11670,8 +12811,8 @@
         </p:nvSpPr>
         <p:spPr>
           <a:xfrm>
-            <a:off x="6309360" y="1417320"/>
-            <a:ext cx="5486400" cy="914400"/>
+            <a:off x="457200" y="4315968"/>
+            <a:ext cx="5394960" cy="914400"/>
           </a:xfrm>
           <a:prstGeom prst="rect">
             <a:avLst/>
@@ -11715,7 +12856,7 @@
                 <a:ea typeface="Segoe UI" pitchFamily="34" charset="-122"/>
                 <a:cs typeface="Segoe UI" pitchFamily="34" charset="-120"/>
               </a:rPr>
-              <a:t>— per-station stream watch and a device roster showing exactly which units are offline and for how long. Know a scanner died before the queue does.</a:t>
+              <a:t>— stream watch per station and a roster of exactly which units are offline and for how long. Know a scanner died before the queue does.</a:t>
             </a:r>
             <a:endParaRPr lang="en-US" sz="1200" dirty="0"/>
           </a:p>
@@ -11729,8 +12870,8 @@
         </p:nvSpPr>
         <p:spPr>
           <a:xfrm>
-            <a:off x="6309360" y="2514600"/>
-            <a:ext cx="5486400" cy="914400"/>
+            <a:off x="457200" y="5340096"/>
+            <a:ext cx="5394960" cy="914400"/>
           </a:xfrm>
           <a:prstGeom prst="rect">
             <a:avLst/>
@@ -11757,7 +12898,7 @@
                 <a:ea typeface="Segoe UI" pitchFamily="34" charset="-122"/>
                 <a:cs typeface="Segoe UI" pitchFamily="34" charset="-120"/>
               </a:rPr>
-              <a:t>AI Diagnose + event report  </a:t>
+              <a:t>AI Diagnose · live updates · alerts  </a:t>
             </a:r>
             <a:pPr indent="0" marL="0">
               <a:lnSpc>
@@ -11774,99 +12915,133 @@
                 <a:ea typeface="Segoe UI" pitchFamily="34" charset="-122"/>
                 <a:cs typeface="Segoe UI" pitchFamily="34" charset="-120"/>
               </a:rPr>
-              <a:t>— one-tap AI verdicts per station, and a post-event diagnostics report clean enough to forward to the network provider.</a:t>
+              <a:t>— one-tap AI verdicts per station, a multi-metric mini report every 15–120 min while doors are open, and threshold alerts on any number.</a:t>
             </a:r>
             <a:endParaRPr lang="en-US" sz="1200" dirty="0"/>
           </a:p>
         </p:txBody>
       </p:sp>
-      <p:sp>
-        <p:nvSpPr>
-          <p:cNvPr id="16" name="Text 14"/>
-          <p:cNvSpPr/>
-          <p:nvPr/>
-        </p:nvSpPr>
-        <p:spPr>
-          <a:xfrm>
-            <a:off x="6309360" y="3611880"/>
-            <a:ext cx="5486400" cy="914400"/>
-          </a:xfrm>
-          <a:prstGeom prst="rect">
-            <a:avLst/>
-          </a:prstGeom>
-          <a:noFill/>
-          <a:ln/>
-        </p:spPr>
-        <p:txBody>
-          <a:bodyPr wrap="square" rtlCol="0" anchor="t"/>
-          <a:lstStyle/>
-          <a:p>
-            <a:pPr indent="0" marL="0">
+      <p:pic>
+        <p:nvPicPr>
+          <p:cNvPr id="16" name="Image 0" descr="sitemap.png">    </p:cNvPr>
+          <p:cNvPicPr>
+            <a:picLocks noChangeAspect="1"/>
+          </p:cNvPicPr>
+          <p:nvPr/>
+        </p:nvPicPr>
+        <p:blipFill>
+          <a:blip r:embed="rId1"/>
+          <a:stretch>
+            <a:fillRect/>
+          </a:stretch>
+        </p:blipFill>
+        <p:spPr>
+          <a:xfrm>
+            <a:off x="6172200" y="1463040"/>
+            <a:ext cx="5577840" cy="2039112"/>
+          </a:xfrm>
+          <a:prstGeom prst="rect">
+            <a:avLst/>
+          </a:prstGeom>
+        </p:spPr>
+      </p:pic>
+      <p:sp>
+        <p:nvSpPr>
+          <p:cNvPr id="17" name="Text 14"/>
+          <p:cNvSpPr/>
+          <p:nvPr/>
+        </p:nvSpPr>
+        <p:spPr>
+          <a:xfrm>
+            <a:off x="6172200" y="3566160"/>
+            <a:ext cx="5577840" cy="457200"/>
+          </a:xfrm>
+          <a:prstGeom prst="rect">
+            <a:avLst/>
+          </a:prstGeom>
+          <a:noFill/>
+          <a:ln/>
+        </p:spPr>
+        <p:txBody>
+          <a:bodyPr wrap="square" rtlCol="0" anchor="ctr"/>
+          <a:lstStyle/>
+          <a:p>
+            <a:pPr indent="0" marL="0">
+              <a:buNone/>
+            </a:pPr>
+            <a:r>
+              <a:rPr lang="en-US" sz="1000" i="1" dirty="0">
+                <a:solidFill>
+                  <a:srgbClr val="55556D"/>
+                </a:solidFill>
+                <a:latin typeface="Segoe UI" pitchFamily="34" charset="0"/>
+                <a:ea typeface="Segoe UI" pitchFamily="34" charset="-122"/>
+                <a:cs typeface="Segoe UI" pitchFamily="34" charset="-120"/>
+              </a:rPr>
+              <a:t>The Flow board’s live site map — stations, heat and a dark station, on your own venue plan.</a:t>
+            </a:r>
+            <a:endParaRPr lang="en-US" sz="1000" dirty="0"/>
+          </a:p>
+        </p:txBody>
+      </p:sp>
+      <p:sp>
+        <p:nvSpPr>
+          <p:cNvPr id="18" name="Shape 15"/>
+          <p:cNvSpPr/>
+          <p:nvPr/>
+        </p:nvSpPr>
+        <p:spPr>
+          <a:xfrm>
+            <a:off x="6172200" y="4160520"/>
+            <a:ext cx="5577840" cy="1828800"/>
+          </a:xfrm>
+          <a:prstGeom prst="roundRect">
+            <a:avLst>
+              <a:gd name="adj" fmla="val 5000"/>
+            </a:avLst>
+          </a:prstGeom>
+          <a:solidFill>
+            <a:srgbClr val="F0FBFD"/>
+          </a:solidFill>
+          <a:ln w="12700">
+            <a:solidFill>
+              <a:srgbClr val="06B6D4"/>
+            </a:solidFill>
+            <a:prstDash val="solid"/>
+          </a:ln>
+        </p:spPr>
+      </p:sp>
+      <p:sp>
+        <p:nvSpPr>
+          <p:cNvPr id="19" name="Text 16"/>
+          <p:cNvSpPr/>
+          <p:nvPr/>
+        </p:nvSpPr>
+        <p:spPr>
+          <a:xfrm>
+            <a:off x="6400800" y="4297680"/>
+            <a:ext cx="5120640" cy="1554480"/>
+          </a:xfrm>
+          <a:prstGeom prst="rect">
+            <a:avLst/>
+          </a:prstGeom>
+          <a:noFill/>
+          <a:ln/>
+        </p:spPr>
+        <p:txBody>
+          <a:bodyPr wrap="square" rtlCol="0" anchor="ctr"/>
+          <a:lstStyle/>
+          <a:p>
+            <a:pPr algn="ctr" indent="0" marL="0">
               <a:lnSpc>
-                <a:spcPts val="1600"/>
+                <a:spcPts val="2000"/>
               </a:lnSpc>
               <a:buNone/>
             </a:pPr>
             <a:r>
-              <a:rPr lang="en-US" sz="1200" b="1" dirty="0">
-                <a:solidFill>
-                  <a:srgbClr val="1A1A2E"/>
-                </a:solidFill>
-                <a:latin typeface="Segoe UI" pitchFamily="34" charset="0"/>
-                <a:ea typeface="Segoe UI" pitchFamily="34" charset="-122"/>
-                <a:cs typeface="Segoe UI" pitchFamily="34" charset="-120"/>
-              </a:rPr>
-              <a:t>Live updates &amp; alerts  </a:t>
-            </a:r>
-            <a:pPr indent="0" marL="0">
-              <a:lnSpc>
-                <a:spcPts val="1600"/>
-              </a:lnSpc>
-              <a:buNone/>
-            </a:pPr>
-            <a:r>
-              <a:rPr lang="en-US" sz="1200" dirty="0">
-                <a:solidFill>
-                  <a:srgbClr val="55556D"/>
-                </a:solidFill>
-                <a:latin typeface="Segoe UI" pitchFamily="34" charset="0"/>
-                <a:ea typeface="Segoe UI" pitchFamily="34" charset="-122"/>
-                <a:cs typeface="Segoe UI" pitchFamily="34" charset="-120"/>
-              </a:rPr>
-              <a:t>— a multi-metric mini report every 15–120 min while doors are open (gates pace, bar revenue, top vendors, device health), plus threshold alerts on any number.</a:t>
-            </a:r>
-            <a:endParaRPr lang="en-US" sz="1200" dirty="0"/>
-          </a:p>
-        </p:txBody>
-      </p:sp>
-      <p:sp>
-        <p:nvSpPr>
-          <p:cNvPr id="17" name="Text 15"/>
-          <p:cNvSpPr/>
-          <p:nvPr/>
-        </p:nvSpPr>
-        <p:spPr>
-          <a:xfrm>
-            <a:off x="457200" y="5394960"/>
-            <a:ext cx="11338560" cy="457200"/>
-          </a:xfrm>
-          <a:prstGeom prst="rect">
-            <a:avLst/>
-          </a:prstGeom>
-          <a:noFill/>
-          <a:ln/>
-        </p:spPr>
-        <p:txBody>
-          <a:bodyPr wrap="square" rtlCol="0" anchor="ctr"/>
-          <a:lstStyle/>
-          <a:p>
-            <a:pPr algn="ctr" indent="0" marL="0">
-              <a:buNone/>
-            </a:pPr>
-            <a:r>
-              <a:rPr lang="en-US" sz="1500" b="1" i="1" dirty="0">
-                <a:solidFill>
-                  <a:srgbClr val="06B6D4"/>
+              <a:rPr lang="en-US" sz="1400" b="1" i="1" dirty="0">
+                <a:solidFill>
+                  <a:srgbClr val="0E7490"/>
                 </a:solidFill>
                 <a:latin typeface="Segoe UI" pitchFamily="34" charset="0"/>
                 <a:ea typeface="Segoe UI" pitchFamily="34" charset="-122"/>
@@ -11874,7 +13049,7 @@
               </a:rPr>
               <a:t>“You’ll know a hotspot is forming, or a scanner has died, before anyone on the ground has to tell you.”</a:t>
             </a:r>
-            <a:endParaRPr lang="en-US" sz="1500" dirty="0"/>
+            <a:endParaRPr lang="en-US" sz="1400" dirty="0"/>
           </a:p>
         </p:txBody>
       </p:sp>

</xml_diff>

<commit_message>
Sales pitch pack v4: real Owl mark and Howler logo throughout
Replace the owl emoji with the actual Owl mark (client/public/ai-mark.png,
downscaled with alpha) in the channel hub, WhatsApp mockup, connector card
and stack bar, and add the Howler wolf logo to the hero, footers, deck title
and CTA slides.

Co-Authored-By: Claude Fable 5 <noreply@anthropic.com>
Claude-Session: https://claude.ai/code/session_016kfeoZ1Zgn8t5cLdc8YKFo
</commit_message>
<xml_diff>
--- a/docs/sales-collateral/Pulse-Sales-Deck.pptx
+++ b/docs/sales-collateral/Pulse-Sales-Deck.pptx
@@ -2003,9 +2003,33 @@
           <a:ln/>
         </p:spPr>
       </p:sp>
-      <p:sp>
-        <p:nvSpPr>
-          <p:cNvPr id="5" name="Text 3"/>
+      <p:pic>
+        <p:nvPicPr>
+          <p:cNvPr id="5" name="Image 0" descr="howler-logo.png">    </p:cNvPr>
+          <p:cNvPicPr>
+            <a:picLocks noChangeAspect="1"/>
+          </p:cNvPicPr>
+          <p:nvPr/>
+        </p:nvPicPr>
+        <p:blipFill>
+          <a:blip r:embed="rId1"/>
+          <a:stretch>
+            <a:fillRect/>
+          </a:stretch>
+        </p:blipFill>
+        <p:spPr>
+          <a:xfrm>
+            <a:off x="822960" y="502920"/>
+            <a:ext cx="777240" cy="777240"/>
+          </a:xfrm>
+          <a:prstGeom prst="ellipse">
+            <a:avLst/>
+          </a:prstGeom>
+        </p:spPr>
+      </p:pic>
+      <p:sp>
+        <p:nvSpPr>
+          <p:cNvPr id="6" name="Text 3"/>
           <p:cNvSpPr/>
           <p:nvPr/>
         </p:nvSpPr>
@@ -2044,7 +2068,7 @@
       </p:sp>
       <p:sp>
         <p:nvSpPr>
-          <p:cNvPr id="6" name="Text 4"/>
+          <p:cNvPr id="7" name="Text 4"/>
           <p:cNvSpPr/>
           <p:nvPr/>
         </p:nvSpPr>
@@ -2097,7 +2121,7 @@
       </p:sp>
       <p:sp>
         <p:nvSpPr>
-          <p:cNvPr id="7" name="Text 5"/>
+          <p:cNvPr id="8" name="Text 5"/>
           <p:cNvSpPr/>
           <p:nvPr/>
         </p:nvSpPr>
@@ -2136,7 +2160,7 @@
       </p:sp>
       <p:sp>
         <p:nvSpPr>
-          <p:cNvPr id="8" name="Text 6"/>
+          <p:cNvPr id="9" name="Text 6"/>
           <p:cNvSpPr/>
           <p:nvPr/>
         </p:nvSpPr>
@@ -2178,7 +2202,7 @@
       </p:sp>
       <p:sp>
         <p:nvSpPr>
-          <p:cNvPr id="9" name="Shape 7"/>
+          <p:cNvPr id="10" name="Shape 7"/>
           <p:cNvSpPr/>
           <p:nvPr/>
         </p:nvSpPr>
@@ -2198,7 +2222,7 @@
       </p:sp>
       <p:sp>
         <p:nvSpPr>
-          <p:cNvPr id="10" name="Shape 8"/>
+          <p:cNvPr id="11" name="Shape 8"/>
           <p:cNvSpPr/>
           <p:nvPr/>
         </p:nvSpPr>
@@ -2218,7 +2242,7 @@
       </p:sp>
       <p:sp>
         <p:nvSpPr>
-          <p:cNvPr id="11" name="Shape 9"/>
+          <p:cNvPr id="12" name="Shape 9"/>
           <p:cNvSpPr/>
           <p:nvPr/>
         </p:nvSpPr>
@@ -2238,7 +2262,7 @@
       </p:sp>
       <p:sp>
         <p:nvSpPr>
-          <p:cNvPr id="12" name="Text 10"/>
+          <p:cNvPr id="13" name="Text 10"/>
           <p:cNvSpPr/>
           <p:nvPr/>
         </p:nvSpPr>
@@ -5396,16 +5420,40 @@
           <a:ln/>
         </p:spPr>
       </p:sp>
-      <p:sp>
-        <p:nvSpPr>
-          <p:cNvPr id="28" name="Text 26"/>
-          <p:cNvSpPr/>
-          <p:nvPr/>
-        </p:nvSpPr>
-        <p:spPr>
-          <a:xfrm>
-            <a:off x="777240" y="3703320"/>
-            <a:ext cx="10698480" cy="960120"/>
+      <p:pic>
+        <p:nvPicPr>
+          <p:cNvPr id="28" name="Image 0" descr="owl-mark.png">    </p:cNvPr>
+          <p:cNvPicPr>
+            <a:picLocks noChangeAspect="1"/>
+          </p:cNvPicPr>
+          <p:nvPr/>
+        </p:nvPicPr>
+        <p:blipFill>
+          <a:blip r:embed="rId1"/>
+          <a:stretch>
+            <a:fillRect/>
+          </a:stretch>
+        </p:blipFill>
+        <p:spPr>
+          <a:xfrm>
+            <a:off x="713232" y="3794760"/>
+            <a:ext cx="777240" cy="777240"/>
+          </a:xfrm>
+          <a:prstGeom prst="rect">
+            <a:avLst/>
+          </a:prstGeom>
+        </p:spPr>
+      </p:pic>
+      <p:sp>
+        <p:nvSpPr>
+          <p:cNvPr id="29" name="Text 26"/>
+          <p:cNvSpPr/>
+          <p:nvPr/>
+        </p:nvSpPr>
+        <p:spPr>
+          <a:xfrm>
+            <a:off x="1691640" y="3703320"/>
+            <a:ext cx="9875520" cy="960120"/>
           </a:xfrm>
           <a:prstGeom prst="rect">
             <a:avLst/>
@@ -5432,7 +5480,7 @@
                 <a:ea typeface="Segoe UI" pitchFamily="34" charset="-122"/>
                 <a:cs typeface="Segoe UI" pitchFamily="34" charset="-120"/>
               </a:rPr>
-              <a:t>📊 Pulse — the brain of the stack.  </a:t>
+              <a:t>Pulse — the brain of the stack.  </a:t>
             </a:r>
             <a:pPr indent="0" marL="0">
               <a:lnSpc>
@@ -5457,7 +5505,7 @@
       </p:sp>
       <p:sp>
         <p:nvSpPr>
-          <p:cNvPr id="29" name="Text 27"/>
+          <p:cNvPr id="30" name="Text 27"/>
           <p:cNvSpPr/>
           <p:nvPr/>
         </p:nvSpPr>
@@ -5496,7 +5544,7 @@
       </p:sp>
       <p:sp>
         <p:nvSpPr>
-          <p:cNvPr id="30" name="Shape 28"/>
+          <p:cNvPr id="31" name="Shape 28"/>
           <p:cNvSpPr/>
           <p:nvPr/>
         </p:nvSpPr>
@@ -5518,7 +5566,7 @@
       </p:sp>
       <p:sp>
         <p:nvSpPr>
-          <p:cNvPr id="31" name="Text 29"/>
+          <p:cNvPr id="32" name="Text 29"/>
           <p:cNvSpPr/>
           <p:nvPr/>
         </p:nvSpPr>
@@ -5580,7 +5628,7 @@
       </p:sp>
       <p:sp>
         <p:nvSpPr>
-          <p:cNvPr id="32" name="Shape 30"/>
+          <p:cNvPr id="33" name="Shape 30"/>
           <p:cNvSpPr/>
           <p:nvPr/>
         </p:nvSpPr>
@@ -5602,7 +5650,7 @@
       </p:sp>
       <p:sp>
         <p:nvSpPr>
-          <p:cNvPr id="33" name="Text 31"/>
+          <p:cNvPr id="34" name="Text 31"/>
           <p:cNvSpPr/>
           <p:nvPr/>
         </p:nvSpPr>
@@ -5664,7 +5712,7 @@
       </p:sp>
       <p:sp>
         <p:nvSpPr>
-          <p:cNvPr id="34" name="Shape 32"/>
+          <p:cNvPr id="35" name="Shape 32"/>
           <p:cNvSpPr/>
           <p:nvPr/>
         </p:nvSpPr>
@@ -5686,7 +5734,7 @@
       </p:sp>
       <p:sp>
         <p:nvSpPr>
-          <p:cNvPr id="35" name="Text 33"/>
+          <p:cNvPr id="36" name="Text 33"/>
           <p:cNvSpPr/>
           <p:nvPr/>
         </p:nvSpPr>
@@ -5838,9 +5886,33 @@
           <a:ln/>
         </p:spPr>
       </p:sp>
-      <p:sp>
-        <p:nvSpPr>
-          <p:cNvPr id="5" name="Text 3"/>
+      <p:pic>
+        <p:nvPicPr>
+          <p:cNvPr id="5" name="Image 0" descr="howler-logo.png">    </p:cNvPr>
+          <p:cNvPicPr>
+            <a:picLocks noChangeAspect="1"/>
+          </p:cNvPicPr>
+          <p:nvPr/>
+        </p:nvPicPr>
+        <p:blipFill>
+          <a:blip r:embed="rId1"/>
+          <a:stretch>
+            <a:fillRect/>
+          </a:stretch>
+        </p:blipFill>
+        <p:spPr>
+          <a:xfrm>
+            <a:off x="822960" y="502920"/>
+            <a:ext cx="777240" cy="777240"/>
+          </a:xfrm>
+          <a:prstGeom prst="ellipse">
+            <a:avLst/>
+          </a:prstGeom>
+        </p:spPr>
+      </p:pic>
+      <p:sp>
+        <p:nvSpPr>
+          <p:cNvPr id="6" name="Text 3"/>
           <p:cNvSpPr/>
           <p:nvPr/>
         </p:nvSpPr>
@@ -5879,7 +5951,7 @@
       </p:sp>
       <p:sp>
         <p:nvSpPr>
-          <p:cNvPr id="6" name="Text 4"/>
+          <p:cNvPr id="7" name="Text 4"/>
           <p:cNvSpPr/>
           <p:nvPr/>
         </p:nvSpPr>
@@ -5921,7 +5993,7 @@
       </p:sp>
       <p:sp>
         <p:nvSpPr>
-          <p:cNvPr id="7" name="Text 5"/>
+          <p:cNvPr id="8" name="Text 5"/>
           <p:cNvSpPr/>
           <p:nvPr/>
         </p:nvSpPr>
@@ -5960,7 +6032,7 @@
       </p:sp>
       <p:sp>
         <p:nvSpPr>
-          <p:cNvPr id="8" name="Shape 6"/>
+          <p:cNvPr id="9" name="Shape 6"/>
           <p:cNvSpPr/>
           <p:nvPr/>
         </p:nvSpPr>
@@ -5982,7 +6054,7 @@
       </p:sp>
       <p:sp>
         <p:nvSpPr>
-          <p:cNvPr id="9" name="Text 7"/>
+          <p:cNvPr id="10" name="Text 7"/>
           <p:cNvSpPr/>
           <p:nvPr/>
         </p:nvSpPr>
@@ -6021,7 +6093,7 @@
       </p:sp>
       <p:sp>
         <p:nvSpPr>
-          <p:cNvPr id="10" name="Text 8"/>
+          <p:cNvPr id="11" name="Text 8"/>
           <p:cNvSpPr/>
           <p:nvPr/>
         </p:nvSpPr>
@@ -10196,39 +10268,45 @@
           </a:p>
         </p:txBody>
       </p:sp>
-      <p:sp>
-        <p:nvSpPr>
-          <p:cNvPr id="27" name="Shape 25"/>
-          <p:cNvSpPr/>
-          <p:nvPr/>
-        </p:nvSpPr>
-        <p:spPr>
-          <a:xfrm>
-            <a:off x="4956048" y="2468880"/>
+      <p:pic>
+        <p:nvPicPr>
+          <p:cNvPr id="27" name="Image 0" descr="owl-mark.png">    </p:cNvPr>
+          <p:cNvPicPr>
+            <a:picLocks noChangeAspect="1"/>
+          </p:cNvPicPr>
+          <p:nvPr/>
+        </p:nvPicPr>
+        <p:blipFill>
+          <a:blip r:embed="rId1"/>
+          <a:stretch>
+            <a:fillRect/>
+          </a:stretch>
+        </p:blipFill>
+        <p:spPr>
+          <a:xfrm>
+            <a:off x="4956048" y="2331720"/>
             <a:ext cx="2286000" cy="2286000"/>
           </a:xfrm>
-          <a:prstGeom prst="ellipse">
-            <a:avLst/>
-          </a:prstGeom>
-          <a:solidFill>
-            <a:srgbClr val="FF385C"/>
-          </a:solidFill>
-          <a:ln/>
-        </p:spPr>
-      </p:sp>
-      <p:sp>
-        <p:nvSpPr>
-          <p:cNvPr id="28" name="Shape 26"/>
-          <p:cNvSpPr/>
-          <p:nvPr/>
-        </p:nvSpPr>
-        <p:spPr>
-          <a:xfrm>
-            <a:off x="5047488" y="2560320"/>
-            <a:ext cx="2103120" cy="2103120"/>
-          </a:xfrm>
-          <a:prstGeom prst="ellipse">
-            <a:avLst/>
+          <a:prstGeom prst="rect">
+            <a:avLst/>
+          </a:prstGeom>
+        </p:spPr>
+      </p:pic>
+      <p:sp>
+        <p:nvSpPr>
+          <p:cNvPr id="28" name="Shape 25"/>
+          <p:cNvSpPr/>
+          <p:nvPr/>
+        </p:nvSpPr>
+        <p:spPr>
+          <a:xfrm>
+            <a:off x="4681728" y="4754880"/>
+            <a:ext cx="2834640" cy="402336"/>
+          </a:xfrm>
+          <a:prstGeom prst="roundRect">
+            <a:avLst>
+              <a:gd name="adj" fmla="val 50000"/>
+            </a:avLst>
           </a:prstGeom>
           <a:solidFill>
             <a:srgbClr val="1A1A2E"/>
@@ -10238,14 +10316,14 @@
       </p:sp>
       <p:sp>
         <p:nvSpPr>
-          <p:cNvPr id="29" name="Text 27"/>
-          <p:cNvSpPr/>
-          <p:nvPr/>
-        </p:nvSpPr>
-        <p:spPr>
-          <a:xfrm>
-            <a:off x="4956048" y="2468880"/>
-            <a:ext cx="2286000" cy="2286000"/>
+          <p:cNvPr id="29" name="Text 26"/>
+          <p:cNvSpPr/>
+          <p:nvPr/>
+        </p:nvSpPr>
+        <p:spPr>
+          <a:xfrm>
+            <a:off x="4681728" y="4754880"/>
+            <a:ext cx="2834640" cy="402336"/>
           </a:xfrm>
           <a:prstGeom prst="rect">
             <a:avLst/>
@@ -10261,37 +10339,21 @@
               <a:buNone/>
             </a:pPr>
             <a:r>
-              <a:rPr lang="en-US" sz="2600" dirty="0">
-                <a:solidFill>
-                  <a:srgbClr val="000000"/>
-                </a:solidFill>
-                <a:latin typeface="Segoe UI" pitchFamily="34" charset="0"/>
-                <a:ea typeface="Segoe UI" pitchFamily="34" charset="-122"/>
-                <a:cs typeface="Segoe UI" pitchFamily="34" charset="-120"/>
-              </a:rPr>
-              <a:t>🦉
-</a:t>
+              <a:rPr lang="en-US" sz="1000" b="1" dirty="0">
+                <a:solidFill>
+                  <a:srgbClr val="FFFFFF"/>
+                </a:solidFill>
+                <a:latin typeface="Segoe UI" pitchFamily="34" charset="0"/>
+                <a:ea typeface="Segoe UI" pitchFamily="34" charset="-122"/>
+                <a:cs typeface="Segoe UI" pitchFamily="34" charset="-120"/>
+              </a:rPr>
+              <a:t>THE OWL</a:t>
             </a:r>
             <a:pPr algn="ctr" indent="0" marL="0">
               <a:buNone/>
             </a:pPr>
             <a:r>
-              <a:rPr lang="en-US" sz="1200" b="1" dirty="0">
-                <a:solidFill>
-                  <a:srgbClr val="FFFFFF"/>
-                </a:solidFill>
-                <a:latin typeface="Segoe UI" pitchFamily="34" charset="0"/>
-                <a:ea typeface="Segoe UI" pitchFamily="34" charset="-122"/>
-                <a:cs typeface="Segoe UI" pitchFamily="34" charset="-120"/>
-              </a:rPr>
-              <a:t>THE OWL
-</a:t>
-            </a:r>
-            <a:pPr algn="ctr" indent="0" marL="0">
-              <a:buNone/>
-            </a:pPr>
-            <a:r>
-              <a:rPr lang="en-US" sz="800" dirty="0">
+              <a:rPr lang="en-US" sz="900" dirty="0">
                 <a:solidFill>
                   <a:srgbClr val="B8B3D9"/>
                 </a:solidFill>
@@ -10299,15 +10361,15 @@
                 <a:ea typeface="Segoe UI" pitchFamily="34" charset="-122"/>
                 <a:cs typeface="Segoe UI" pitchFamily="34" charset="-120"/>
               </a:rPr>
-              <a:t>one brain · your data</a:t>
-            </a:r>
-            <a:endParaRPr lang="en-US" sz="2600" dirty="0"/>
-          </a:p>
-        </p:txBody>
-      </p:sp>
-      <p:sp>
-        <p:nvSpPr>
-          <p:cNvPr id="30" name="Shape 28"/>
+              <a:t> · one brain · your data</a:t>
+            </a:r>
+            <a:endParaRPr lang="en-US" sz="1000" dirty="0"/>
+          </a:p>
+        </p:txBody>
+      </p:sp>
+      <p:sp>
+        <p:nvSpPr>
+          <p:cNvPr id="30" name="Shape 27"/>
           <p:cNvSpPr/>
           <p:nvPr/>
         </p:nvSpPr>
@@ -10329,7 +10391,7 @@
       </p:sp>
       <p:sp>
         <p:nvSpPr>
-          <p:cNvPr id="31" name="Text 29"/>
+          <p:cNvPr id="31" name="Text 28"/>
           <p:cNvSpPr/>
           <p:nvPr/>
         </p:nvSpPr>

</xml_diff>

<commit_message>
Sales pitch pack v5: dashboard, digest and email-designer/ad-sync mockups
Add three more product mockups to the PDF — a desktop dashboard with an Owl
insight panel (page 1), a scheduled-digest email (page 2), and an AI email
designer + ad-audiences sync pair (page 4, replacing the replaces-the-pile
strip) — and embed the dashboard shot on the deck's SEE slide. Pages 1/2/4
compacted to fit.

Co-Authored-By: Claude Fable 5 <noreply@anthropic.com>
Claude-Session: https://claude.ai/code/session_016kfeoZ1Zgn8t5cLdc8YKFo
</commit_message>
<xml_diff>
--- a/docs/sales-collateral/Pulse-Sales-Deck.pptx
+++ b/docs/sales-collateral/Pulse-Sales-Deck.pptx
@@ -8352,8 +8352,8 @@
         </p:nvSpPr>
         <p:spPr>
           <a:xfrm>
-            <a:off x="457200" y="1417320"/>
-            <a:ext cx="5486400" cy="914400"/>
+            <a:off x="457200" y="1371600"/>
+            <a:ext cx="5394960" cy="914400"/>
           </a:xfrm>
           <a:prstGeom prst="rect">
             <a:avLst/>
@@ -8411,8 +8411,8 @@
         </p:nvSpPr>
         <p:spPr>
           <a:xfrm>
-            <a:off x="457200" y="2423160"/>
-            <a:ext cx="5486400" cy="914400"/>
+            <a:off x="457200" y="2377440"/>
+            <a:ext cx="5394960" cy="914400"/>
           </a:xfrm>
           <a:prstGeom prst="rect">
             <a:avLst/>
@@ -8470,8 +8470,8 @@
         </p:nvSpPr>
         <p:spPr>
           <a:xfrm>
-            <a:off x="457200" y="3429000"/>
-            <a:ext cx="5486400" cy="914400"/>
+            <a:off x="457200" y="3383280"/>
+            <a:ext cx="5394960" cy="914400"/>
           </a:xfrm>
           <a:prstGeom prst="rect">
             <a:avLst/>
@@ -8529,8 +8529,8 @@
         </p:nvSpPr>
         <p:spPr>
           <a:xfrm>
-            <a:off x="6309360" y="1417320"/>
-            <a:ext cx="5486400" cy="914400"/>
+            <a:off x="457200" y="4389120"/>
+            <a:ext cx="5394960" cy="914400"/>
           </a:xfrm>
           <a:prstGeom prst="rect">
             <a:avLst/>
@@ -8557,7 +8557,7 @@
                 <a:ea typeface="Segoe UI" pitchFamily="34" charset="-122"/>
                 <a:cs typeface="Segoe UI" pitchFamily="34" charset="-120"/>
               </a:rPr>
-              <a:t>Scheduled digests  </a:t>
+              <a:t>Goals with pace &amp; forecast  </a:t>
             </a:r>
             <a:pPr indent="0" marL="0">
               <a:lnSpc>
@@ -8574,22 +8574,85 @@
                 <a:ea typeface="Segoe UI" pitchFamily="34" charset="-122"/>
                 <a:cs typeface="Segoe UI" pitchFamily="34" charset="-120"/>
               </a:rPr>
-              <a:t>— role-specific email briefings (exec / marketing / finance / ops) on your cadence, with charts rendered in the email.</a:t>
+              <a:t>— a North Star target on every screen: ahead / on-track / behind vs last event’s real sell-curve, with a projected landing.</a:t>
             </a:r>
             <a:endParaRPr lang="en-US" sz="1200" dirty="0"/>
           </a:p>
         </p:txBody>
       </p:sp>
-      <p:sp>
-        <p:nvSpPr>
-          <p:cNvPr id="15" name="Text 13"/>
-          <p:cNvSpPr/>
-          <p:nvPr/>
-        </p:nvSpPr>
-        <p:spPr>
-          <a:xfrm>
-            <a:off x="6309360" y="2423160"/>
-            <a:ext cx="5486400" cy="914400"/>
+      <p:pic>
+        <p:nvPicPr>
+          <p:cNvPr id="15" name="Image 0" descr="dash.png">    </p:cNvPr>
+          <p:cNvPicPr>
+            <a:picLocks noChangeAspect="1"/>
+          </p:cNvPicPr>
+          <p:nvPr/>
+        </p:nvPicPr>
+        <p:blipFill>
+          <a:blip r:embed="rId1"/>
+          <a:stretch>
+            <a:fillRect/>
+          </a:stretch>
+        </p:blipFill>
+        <p:spPr>
+          <a:xfrm>
+            <a:off x="6172200" y="1417320"/>
+            <a:ext cx="5577840" cy="1572768"/>
+          </a:xfrm>
+          <a:prstGeom prst="rect">
+            <a:avLst/>
+          </a:prstGeom>
+        </p:spPr>
+      </p:pic>
+      <p:sp>
+        <p:nvSpPr>
+          <p:cNvPr id="16" name="Text 13"/>
+          <p:cNvSpPr/>
+          <p:nvPr/>
+        </p:nvSpPr>
+        <p:spPr>
+          <a:xfrm>
+            <a:off x="6172200" y="3017520"/>
+            <a:ext cx="5577840" cy="320040"/>
+          </a:xfrm>
+          <a:prstGeom prst="rect">
+            <a:avLst/>
+          </a:prstGeom>
+          <a:noFill/>
+          <a:ln/>
+        </p:spPr>
+        <p:txBody>
+          <a:bodyPr wrap="square" rtlCol="0" anchor="ctr"/>
+          <a:lstStyle/>
+          <a:p>
+            <a:pPr indent="0" marL="0">
+              <a:buNone/>
+            </a:pPr>
+            <a:r>
+              <a:rPr lang="en-US" sz="950" i="1" dirty="0">
+                <a:solidFill>
+                  <a:srgbClr val="55556D"/>
+                </a:solidFill>
+                <a:latin typeface="Segoe UI" pitchFamily="34" charset="0"/>
+                <a:ea typeface="Segoe UI" pitchFamily="34" charset="-122"/>
+                <a:cs typeface="Segoe UI" pitchFamily="34" charset="-120"/>
+              </a:rPr>
+              <a:t>The dashboard with the Owl one tap away — every number explained.</a:t>
+            </a:r>
+            <a:endParaRPr lang="en-US" sz="950" dirty="0"/>
+          </a:p>
+        </p:txBody>
+      </p:sp>
+      <p:sp>
+        <p:nvSpPr>
+          <p:cNvPr id="17" name="Text 14"/>
+          <p:cNvSpPr/>
+          <p:nvPr/>
+        </p:nvSpPr>
+        <p:spPr>
+          <a:xfrm>
+            <a:off x="6172200" y="3474720"/>
+            <a:ext cx="5577840" cy="914400"/>
           </a:xfrm>
           <a:prstGeom prst="rect">
             <a:avLst/>
@@ -8616,7 +8679,7 @@
                 <a:ea typeface="Segoe UI" pitchFamily="34" charset="-122"/>
                 <a:cs typeface="Segoe UI" pitchFamily="34" charset="-120"/>
               </a:rPr>
-              <a:t>Share any insight  </a:t>
+              <a:t>Scheduled digests  </a:t>
             </a:r>
             <a:pPr indent="0" marL="0">
               <a:lnSpc>
@@ -8633,7 +8696,7 @@
                 <a:ea typeface="Segoe UI" pitchFamily="34" charset="-122"/>
                 <a:cs typeface="Segoe UI" pitchFamily="34" charset="-120"/>
               </a:rPr>
-              <a:t>— hand a finding to email, WhatsApp or Slack in one tap, with a link back to the view.</a:t>
+              <a:t>— role-specific email briefings (exec / marketing / finance / ops) on your cadence, with charts rendered in the email.</a:t>
             </a:r>
             <a:endParaRPr lang="en-US" sz="1200" dirty="0"/>
           </a:p>
@@ -8641,14 +8704,14 @@
       </p:sp>
       <p:sp>
         <p:nvSpPr>
-          <p:cNvPr id="16" name="Text 14"/>
-          <p:cNvSpPr/>
-          <p:nvPr/>
-        </p:nvSpPr>
-        <p:spPr>
-          <a:xfrm>
-            <a:off x="6309360" y="3429000"/>
-            <a:ext cx="5486400" cy="914400"/>
+          <p:cNvPr id="18" name="Text 15"/>
+          <p:cNvSpPr/>
+          <p:nvPr/>
+        </p:nvSpPr>
+        <p:spPr>
+          <a:xfrm>
+            <a:off x="6172200" y="4389120"/>
+            <a:ext cx="5577840" cy="914400"/>
           </a:xfrm>
           <a:prstGeom prst="rect">
             <a:avLst/>
@@ -8675,7 +8738,7 @@
                 <a:ea typeface="Segoe UI" pitchFamily="34" charset="-122"/>
                 <a:cs typeface="Segoe UI" pitchFamily="34" charset="-120"/>
               </a:rPr>
-              <a:t>Goals with pace &amp; forecast  </a:t>
+              <a:t>Share any insight  </a:t>
             </a:r>
             <a:pPr indent="0" marL="0">
               <a:lnSpc>
@@ -8692,7 +8755,7 @@
                 <a:ea typeface="Segoe UI" pitchFamily="34" charset="-122"/>
                 <a:cs typeface="Segoe UI" pitchFamily="34" charset="-120"/>
               </a:rPr>
-              <a:t>— a North Star target on every screen: ahead / on-track / behind vs last event’s real sell-curve, with a projected landing.</a:t>
+              <a:t>— hand a finding to email, WhatsApp or Slack in one tap, with a link back to the view.</a:t>
             </a:r>
             <a:endParaRPr lang="en-US" sz="1200" dirty="0"/>
           </a:p>
@@ -8700,18 +8763,18 @@
       </p:sp>
       <p:sp>
         <p:nvSpPr>
-          <p:cNvPr id="17" name="Shape 15"/>
-          <p:cNvSpPr/>
-          <p:nvPr/>
-        </p:nvSpPr>
-        <p:spPr>
-          <a:xfrm>
-            <a:off x="457200" y="4892040"/>
-            <a:ext cx="11338560" cy="914400"/>
+          <p:cNvPr id="19" name="Shape 16"/>
+          <p:cNvSpPr/>
+          <p:nvPr/>
+        </p:nvSpPr>
+        <p:spPr>
+          <a:xfrm>
+            <a:off x="457200" y="5394960"/>
+            <a:ext cx="11338560" cy="777240"/>
           </a:xfrm>
           <a:prstGeom prst="roundRect">
             <a:avLst>
-              <a:gd name="adj" fmla="val 10000"/>
+              <a:gd name="adj" fmla="val 11765"/>
             </a:avLst>
           </a:prstGeom>
           <a:solidFill>
@@ -8722,14 +8785,14 @@
       </p:sp>
       <p:sp>
         <p:nvSpPr>
-          <p:cNvPr id="18" name="Text 16"/>
-          <p:cNvSpPr/>
-          <p:nvPr/>
-        </p:nvSpPr>
-        <p:spPr>
-          <a:xfrm>
-            <a:off x="731520" y="4983480"/>
-            <a:ext cx="10789920" cy="731520"/>
+          <p:cNvPr id="20" name="Text 17"/>
+          <p:cNvSpPr/>
+          <p:nvPr/>
+        </p:nvSpPr>
+        <p:spPr>
+          <a:xfrm>
+            <a:off x="731520" y="5394960"/>
+            <a:ext cx="10789920" cy="777240"/>
           </a:xfrm>
           <a:prstGeom prst="rect">
             <a:avLst/>
@@ -8745,7 +8808,7 @@
               <a:buNone/>
             </a:pPr>
             <a:r>
-              <a:rPr lang="en-US" sz="1500" b="1" i="1" dirty="0">
+              <a:rPr lang="en-US" sz="1450" b="1" i="1" dirty="0">
                 <a:solidFill>
                   <a:srgbClr val="7C3AED"/>
                 </a:solidFill>
@@ -8755,7 +8818,7 @@
               </a:rPr>
               <a:t>“Your data, read for you — open the app and you already know what changed and what to do.”</a:t>
             </a:r>
-            <a:endParaRPr lang="en-US" sz="1500" dirty="0"/>
+            <a:endParaRPr lang="en-US" sz="1450" dirty="0"/>
           </a:p>
         </p:txBody>
       </p:sp>

</xml_diff>

<commit_message>
Sales pitch pack v6: remove all em-dashes
Feature leads now use colons, headings a middle dot, and prose commas;
verified zero em-dashes in the rendered PDF source and generated deck XML.

Co-Authored-By: Claude Fable 5 <noreply@anthropic.com>
Claude-Session: https://claude.ai/code/session_016kfeoZ1Zgn8t5cLdc8YKFo
</commit_message>
<xml_diff>
--- a/docs/sales-collateral/Pulse-Sales-Deck.pptx
+++ b/docs/sales-collateral/Pulse-Sales-Deck.pptx
@@ -2194,7 +2194,7 @@
                 <a:ea typeface="Segoe UI" pitchFamily="34" charset="-122"/>
                 <a:cs typeface="Segoe UI" pitchFamily="34" charset="-120"/>
               </a:rPr>
-              <a:t>The Experience OS for event organisers — live dashboards, an AI analyst, and a full email/SMS campaign engine, all powered by the same governed data. Insight → action → results, in your brand, on your phone.</a:t>
+              <a:t>The Experience OS for event organisers: live dashboards, an AI analyst, and a full email/SMS campaign engine, all powered by the same governed data. Insight → action → results, in your brand, on your phone.</a:t>
             </a:r>
             <a:endParaRPr lang="en-US" sz="1500" dirty="0"/>
           </a:p>
@@ -2384,7 +2384,7 @@
                 <a:ea typeface="Segoe UI" pitchFamily="34" charset="-122"/>
                 <a:cs typeface="Segoe UI" pitchFamily="34" charset="-120"/>
               </a:rPr>
-              <a:t>🔒  OWN — white-label, security &amp; openness</a:t>
+              <a:t>🔒  OWN · white-label, security &amp; openness</a:t>
             </a:r>
             <a:endParaRPr lang="en-US" sz="2600" dirty="0"/>
           </a:p>
@@ -2658,7 +2658,7 @@
                 <a:ea typeface="Segoe UI" pitchFamily="34" charset="-122"/>
                 <a:cs typeface="Segoe UI" pitchFamily="34" charset="-120"/>
               </a:rPr>
-              <a:t>Fully white-label  </a:t>
+              <a:t>Fully white-label: </a:t>
             </a:r>
             <a:pPr indent="0" marL="0">
               <a:lnSpc>
@@ -2675,7 +2675,7 @@
                 <a:ea typeface="Segoe UI" pitchFamily="34" charset="-122"/>
                 <a:cs typeface="Segoe UI" pitchFamily="34" charset="-120"/>
               </a:rPr>
-              <a:t>— your logo, colours and sender name everywhere; emails from your own domain once verified; even a vanity login page that feels like your product.</a:t>
+              <a:t>your logo, colours and sender name everywhere; emails from your own domain once verified; even a vanity login page that feels like your product.</a:t>
             </a:r>
             <a:endParaRPr lang="en-US" sz="1200" dirty="0"/>
           </a:p>
@@ -2717,7 +2717,7 @@
                 <a:ea typeface="Segoe UI" pitchFamily="34" charset="-122"/>
                 <a:cs typeface="Segoe UI" pitchFamily="34" charset="-120"/>
               </a:rPr>
-              <a:t>Your language &amp; currency  </a:t>
+              <a:t>Your language &amp; currency: </a:t>
             </a:r>
             <a:pPr indent="0" marL="0">
               <a:lnSpc>
@@ -2734,7 +2734,7 @@
                 <a:ea typeface="Segoe UI" pitchFamily="34" charset="-122"/>
                 <a:cs typeface="Segoe UI" pitchFamily="34" charset="-120"/>
               </a:rPr>
-              <a:t>— AI insights, briefings, digests and campaign copy in your reporting currency and your choice of language.</a:t>
+              <a:t>AI insights, briefings, digests and campaign copy in your reporting currency and your choice of language.</a:t>
             </a:r>
             <a:endParaRPr lang="en-US" sz="1200" dirty="0"/>
           </a:p>
@@ -2776,7 +2776,7 @@
                 <a:ea typeface="Segoe UI" pitchFamily="34" charset="-122"/>
                 <a:cs typeface="Segoe UI" pitchFamily="34" charset="-120"/>
               </a:rPr>
-              <a:t>Open by design (API + AI agents)  </a:t>
+              <a:t>Open by design (API + AI agents): </a:t>
             </a:r>
             <a:pPr indent="0" marL="0">
               <a:lnSpc>
@@ -2793,7 +2793,7 @@
                 <a:ea typeface="Segoe UI" pitchFamily="34" charset="-122"/>
                 <a:cs typeface="Segoe UI" pitchFamily="34" charset="-120"/>
               </a:rPr>
-              <a:t>— read-only, per-client API keys; point Claude or ChatGPT at your data via MCP. Your data is never locked in.</a:t>
+              <a:t>read-only, per-client API keys; point Claude or ChatGPT at your data via MCP. Your data is never locked in.</a:t>
             </a:r>
             <a:endParaRPr lang="en-US" sz="1200" dirty="0"/>
           </a:p>
@@ -2835,7 +2835,7 @@
                 <a:ea typeface="Segoe UI" pitchFamily="34" charset="-122"/>
                 <a:cs typeface="Segoe UI" pitchFamily="34" charset="-120"/>
               </a:rPr>
-              <a:t>Watertight data scoping  </a:t>
+              <a:t>Watertight data scoping: </a:t>
             </a:r>
             <a:pPr indent="0" marL="0">
               <a:lnSpc>
@@ -2852,7 +2852,7 @@
                 <a:ea typeface="Segoe UI" pitchFamily="34" charset="-122"/>
                 <a:cs typeface="Segoe UI" pitchFamily="34" charset="-120"/>
               </a:rPr>
-              <a:t>— every query is force-filtered to your events server-side; it cannot be bypassed and fails closed. One client can never see another’s data.</a:t>
+              <a:t>every query is force-filtered to your events server-side; it cannot be bypassed and fails closed. One client can never see another’s data.</a:t>
             </a:r>
             <a:endParaRPr lang="en-US" sz="1200" dirty="0"/>
           </a:p>
@@ -2894,7 +2894,7 @@
                 <a:ea typeface="Segoe UI" pitchFamily="34" charset="-122"/>
                 <a:cs typeface="Segoe UI" pitchFamily="34" charset="-120"/>
               </a:rPr>
-              <a:t>POPIA-minded by design  </a:t>
+              <a:t>POPIA-minded by design: </a:t>
             </a:r>
             <a:pPr indent="0" marL="0">
               <a:lnSpc>
@@ -2911,7 +2911,7 @@
                 <a:ea typeface="Segoe UI" pitchFamily="34" charset="-122"/>
                 <a:cs typeface="Segoe UI" pitchFamily="34" charset="-120"/>
               </a:rPr>
-              <a:t>— per-channel consent, one-click unsubscribe, hashed identities for ad sync, no cross-client data pooling.</a:t>
+              <a:t>per-channel consent, one-click unsubscribe, hashed identities for ad sync, no cross-client data pooling.</a:t>
             </a:r>
             <a:endParaRPr lang="en-US" sz="1200" dirty="0"/>
           </a:p>
@@ -2953,7 +2953,7 @@
                 <a:ea typeface="Segoe UI" pitchFamily="34" charset="-122"/>
                 <a:cs typeface="Segoe UI" pitchFamily="34" charset="-120"/>
               </a:rPr>
-              <a:t>Self-service, with backup  </a:t>
+              <a:t>Self-service, with backup: </a:t>
             </a:r>
             <a:pPr indent="0" marL="0">
               <a:lnSpc>
@@ -2970,7 +2970,7 @@
                 <a:ea typeface="Segoe UI" pitchFamily="34" charset="-122"/>
                 <a:cs typeface="Segoe UI" pitchFamily="34" charset="-120"/>
               </a:rPr>
-              <a:t>— manage everything yourself in Settings, or your Howler team does it for you. Your named contacts are one tap away.</a:t>
+              <a:t>manage everything yourself in Settings, or your Howler team does it for you. Your named contacts are one tap away.</a:t>
             </a:r>
             <a:endParaRPr lang="en-US" sz="1200" dirty="0"/>
           </a:p>
@@ -3031,7 +3031,7 @@
                 <a:ea typeface="Segoe UI" pitchFamily="34" charset="-122"/>
                 <a:cs typeface="Segoe UI" pitchFamily="34" charset="-120"/>
               </a:rPr>
-              <a:t>“It’s their brand, their accounts, their data — Howler just powers it.”</a:t>
+              <a:t>“It’s their brand, their accounts, their data, Howler just powers it.”</a:t>
             </a:r>
             <a:endParaRPr lang="en-US" sz="1500" dirty="0"/>
           </a:p>
@@ -3122,7 +3122,7 @@
                 <a:ea typeface="Segoe UI" pitchFamily="34" charset="-122"/>
                 <a:cs typeface="Segoe UI" pitchFamily="34" charset="-120"/>
               </a:rPr>
-              <a:t>Why Pulse — and not another tool</a:t>
+              <a:t>Why Pulse, and not another tool</a:t>
             </a:r>
             <a:endParaRPr lang="en-US" sz="2600" dirty="0"/>
           </a:p>
@@ -3747,7 +3747,7 @@
                           <a:ea typeface="Segoe UI" pitchFamily="34" charset="-122"/>
                           <a:cs typeface="Segoe UI" pitchFamily="34" charset="-120"/>
                         </a:rPr>
-                        <a:t>See it and act on it in the same governed place — campaign, approval, result.</a:t>
+                        <a:t>See it and act on it in the same governed place, campaign, approval, result.</a:t>
                       </a:r>
                       <a:endParaRPr lang="en-US" sz="1300" dirty="0">
                         <a:latin typeface="Segoe UI" charset="0"/>
@@ -4481,7 +4481,7 @@
                 <a:ea typeface="Segoe UI" pitchFamily="34" charset="-122"/>
                 <a:cs typeface="Segoe UI" pitchFamily="34" charset="-120"/>
               </a:rPr>
-              <a:t>Pulse isn’t another tool on the pile — it replaces the pile with a loop.</a:t>
+              <a:t>Pulse isn’t another tool on the pile, it replaces the pile with a loop.</a:t>
             </a:r>
             <a:endParaRPr lang="en-US" sz="1600" dirty="0"/>
           </a:p>
@@ -4613,7 +4613,7 @@
                 <a:ea typeface="Segoe UI" pitchFamily="34" charset="-122"/>
                 <a:cs typeface="Segoe UI" pitchFamily="34" charset="-120"/>
               </a:rPr>
-              <a:t>one experience, one dataset, one partner — Pulse is the brain of the whole thing</a:t>
+              <a:t>one experience, one dataset, one partner, Pulse is the brain of the whole thing</a:t>
             </a:r>
             <a:endParaRPr lang="en-US" sz="1200" dirty="0"/>
           </a:p>
@@ -4912,7 +4912,7 @@
                 <a:ea typeface="Segoe UI" pitchFamily="34" charset="-122"/>
                 <a:cs typeface="Segoe UI" pitchFamily="34" charset="-120"/>
               </a:rPr>
-              <a:t>Ticket sales, tiers &amp; releases, access control and scanning — every buyer and every entry, captured from minute one.</a:t>
+              <a:t>Ticket sales, tiers &amp; releases, access control and scanning, every buyer and every entry, captured from minute one.</a:t>
             </a:r>
             <a:endParaRPr lang="en-US" sz="950" dirty="0"/>
           </a:p>
@@ -5059,7 +5059,7 @@
                 <a:ea typeface="Segoe UI" pitchFamily="34" charset="-122"/>
                 <a:cs typeface="Segoe UI" pitchFamily="34" charset="-120"/>
               </a:rPr>
-              <a:t>Tap-to-pay across bars and vendors: faster queues, higher spend, zero cash risk — every transaction is live data.</a:t>
+              <a:t>Tap-to-pay across bars and vendors: faster queues, higher spend, zero cash risk, every transaction is live data.</a:t>
             </a:r>
             <a:endParaRPr lang="en-US" sz="950" dirty="0"/>
           </a:p>
@@ -5206,7 +5206,7 @@
                 <a:ea typeface="Segoe UI" pitchFamily="34" charset="-122"/>
                 <a:cs typeface="Segoe UI" pitchFamily="34" charset="-120"/>
               </a:rPr>
-              <a:t>The fan’s companion: tickets, top-ups, line-ups and offers in one place — an ownable channel to every attendee.</a:t>
+              <a:t>The fan’s companion: tickets, top-ups, line-ups and offers in one place, an ownable channel to every attendee.</a:t>
             </a:r>
             <a:endParaRPr lang="en-US" sz="950" dirty="0"/>
           </a:p>
@@ -5353,7 +5353,7 @@
                 <a:ea typeface="Segoe UI" pitchFamily="34" charset="-122"/>
                 <a:cs typeface="Segoe UI" pitchFamily="34" charset="-120"/>
               </a:rPr>
-              <a:t>Table inventory, bookings and minimum spends, hosted service — your highest-value guests, managed and measured.</a:t>
+              <a:t>Table inventory, bookings and minimum spends, hosted service, your highest-value guests, managed and measured.</a:t>
             </a:r>
             <a:endParaRPr lang="en-US" sz="950" dirty="0"/>
           </a:p>
@@ -5480,7 +5480,7 @@
                 <a:ea typeface="Segoe UI" pitchFamily="34" charset="-122"/>
                 <a:cs typeface="Segoe UI" pitchFamily="34" charset="-120"/>
               </a:rPr>
-              <a:t>Pulse — the brain of the stack.  </a:t>
+              <a:t>Pulse: the brain of the stack.  </a:t>
             </a:r>
             <a:pPr indent="0" marL="0">
               <a:lnSpc>
@@ -5497,7 +5497,7 @@
                 <a:ea typeface="Segoe UI" pitchFamily="34" charset="-122"/>
                 <a:cs typeface="Segoe UI" pitchFamily="34" charset="-120"/>
               </a:rPr>
-              <a:t>Every ticket scanned, every tap at a bar, every SuperApp session and every VIP booking flows into one governed dataset — where the Owl reads it, your team acts on it, and the results come back measured.</a:t>
+              <a:t>Every ticket scanned, every tap at a bar, every SuperApp session and every VIP booking flows into one governed dataset, where the Owl reads it, your team acts on it, and the results come back measured.</a:t>
             </a:r>
             <a:endParaRPr lang="en-US" sz="1500" dirty="0"/>
           </a:p>
@@ -5620,7 +5620,7 @@
                 <a:ea typeface="Segoe UI" pitchFamily="34" charset="-122"/>
                 <a:cs typeface="Segoe UI" pitchFamily="34" charset="-120"/>
               </a:rPr>
-              <a:t>Cashless spots the Main Bar spiking; the heat map shows the hotspot; the Owl suggests moving two devices — while the night is young.</a:t>
+              <a:t>Cashless spots the Main Bar spiking; the heat map shows the hotspot; the Owl suggests moving two devices, while the night is young.</a:t>
             </a:r>
             <a:endParaRPr lang="en-US" sz="1100" dirty="0"/>
           </a:p>
@@ -5704,7 +5704,7 @@
                 <a:ea typeface="Segoe UI" pitchFamily="34" charset="-122"/>
                 <a:cs typeface="Segoe UI" pitchFamily="34" charset="-120"/>
               </a:rPr>
-              <a:t>Ticket + top-ups + bar spend stitched into one picture — your next campaign targets big spenders who haven’t rebought yet.</a:t>
+              <a:t>Ticket + top-ups + bar spend stitched into one picture, your next campaign targets big spenders who haven’t rebought yet.</a:t>
             </a:r>
             <a:endParaRPr lang="en-US" sz="1100" dirty="0"/>
           </a:p>
@@ -5788,7 +5788,7 @@
                 <a:ea typeface="Segoe UI" pitchFamily="34" charset="-122"/>
                 <a:cs typeface="Segoe UI" pitchFamily="34" charset="-120"/>
               </a:rPr>
-              <a:t>Pulse knows who your table guests are, what they spent and when they went quiet — next season’s invitation writes itself.</a:t>
+              <a:t>Pulse knows who your table guests are, what they spent and when they went quiet, next season’s invitation writes itself.</a:t>
             </a:r>
             <a:endParaRPr lang="en-US" sz="1100" dirty="0"/>
           </a:p>
@@ -5985,7 +5985,7 @@
                 <a:ea typeface="Segoe UI" pitchFamily="34" charset="-122"/>
                 <a:cs typeface="Segoe UI" pitchFamily="34" charset="-120"/>
               </a:rPr>
-              <a:t>See what’s happening, act on it, and prove the results — on your phone, in your brand, without exporting to five tools.</a:t>
+              <a:t>See what’s happening, act on it, and prove the results, on your phone, in your brand, without exporting to five tools.</a:t>
             </a:r>
             <a:endParaRPr lang="en-US" sz="2000" dirty="0"/>
           </a:p>
@@ -6879,7 +6879,7 @@
                 <a:ea typeface="Segoe UI" pitchFamily="34" charset="-122"/>
                 <a:cs typeface="Segoe UI" pitchFamily="34" charset="-120"/>
               </a:rPr>
-              <a:t>You find out about the problem when the queue does — or the morning after.</a:t>
+              <a:t>You find out about the problem when the queue does, or the morning after.</a:t>
             </a:r>
             <a:endParaRPr lang="en-US" sz="1250" dirty="0"/>
           </a:p>
@@ -6918,7 +6918,7 @@
                 <a:ea typeface="Segoe UI" pitchFamily="34" charset="-122"/>
                 <a:cs typeface="Segoe UI" pitchFamily="34" charset="-120"/>
               </a:rPr>
-              <a:t>Every tool sees a slice. Nobody sees the loop — and the data never learns.</a:t>
+              <a:t>Every tool sees a slice. Nobody sees the loop, and the data never learns.</a:t>
             </a:r>
             <a:endParaRPr lang="en-US" sz="1500" dirty="0"/>
           </a:p>
@@ -7535,7 +7535,7 @@
                 <a:ea typeface="Segoe UI" pitchFamily="34" charset="-122"/>
                 <a:cs typeface="Segoe UI" pitchFamily="34" charset="-120"/>
               </a:rPr>
-              <a:t>AI briefings and digests tell you what changed — and what to do about it.</a:t>
+              <a:t>AI briefings and digests tell you what changed, and what to do about it.</a:t>
             </a:r>
             <a:endParaRPr lang="en-US" sz="1050" dirty="0"/>
           </a:p>
@@ -8015,7 +8015,7 @@
                 <a:ea typeface="Segoe UI" pitchFamily="34" charset="-122"/>
                 <a:cs typeface="Segoe UI" pitchFamily="34" charset="-120"/>
               </a:rPr>
-              <a:t>“It’s not dashboards and email and reports — it’s one living loop. The longer you use Pulse, the better it gets.”</a:t>
+              <a:t>“It’s not dashboards and email and reports, it’s one living loop. The longer you use Pulse, the better it gets.”</a:t>
             </a:r>
             <a:endParaRPr lang="en-US" sz="1600" dirty="0"/>
           </a:p>
@@ -8106,7 +8106,7 @@
                 <a:ea typeface="Segoe UI" pitchFamily="34" charset="-122"/>
                 <a:cs typeface="Segoe UI" pitchFamily="34" charset="-120"/>
               </a:rPr>
-              <a:t>👁  SEE — dashboards &amp; AI insight</a:t>
+              <a:t>👁  SEE · dashboards &amp; AI insight</a:t>
             </a:r>
             <a:endParaRPr lang="en-US" sz="2600" dirty="0"/>
           </a:p>
@@ -8380,7 +8380,7 @@
                 <a:ea typeface="Segoe UI" pitchFamily="34" charset="-122"/>
                 <a:cs typeface="Segoe UI" pitchFamily="34" charset="-120"/>
               </a:rPr>
-              <a:t>Live dashboards  </a:t>
+              <a:t>Live dashboards: </a:t>
             </a:r>
             <a:pPr indent="0" marL="0">
               <a:lnSpc>
@@ -8397,7 +8397,7 @@
                 <a:ea typeface="Segoe UI" pitchFamily="34" charset="-122"/>
                 <a:cs typeface="Segoe UI" pitchFamily="34" charset="-120"/>
               </a:rPr>
-              <a:t>— KPIs, tables and charts on your real ticketing &amp; GA4 data, with drill-through. Mobile-first, installable as an app.</a:t>
+              <a:t>KPIs, tables and charts on your real ticketing &amp; GA4 data, with drill-through. Mobile-first, installable as an app.</a:t>
             </a:r>
             <a:endParaRPr lang="en-US" sz="1200" dirty="0"/>
           </a:p>
@@ -8439,7 +8439,7 @@
                 <a:ea typeface="Segoe UI" pitchFamily="34" charset="-122"/>
                 <a:cs typeface="Segoe UI" pitchFamily="34" charset="-120"/>
               </a:rPr>
-              <a:t>Per-tile AI insight  </a:t>
+              <a:t>Per-tile AI insight: </a:t>
             </a:r>
             <a:pPr indent="0" marL="0">
               <a:lnSpc>
@@ -8456,7 +8456,7 @@
                 <a:ea typeface="Segoe UI" pitchFamily="34" charset="-122"/>
                 <a:cs typeface="Segoe UI" pitchFamily="34" charset="-120"/>
               </a:rPr>
-              <a:t>— tap any tile and the Owl explains the numbers in plain English, grounded in that data.</a:t>
+              <a:t>tap any tile and the Owl explains the numbers in plain English, grounded in that data.</a:t>
             </a:r>
             <a:endParaRPr lang="en-US" sz="1200" dirty="0"/>
           </a:p>
@@ -8498,7 +8498,7 @@
                 <a:ea typeface="Segoe UI" pitchFamily="34" charset="-122"/>
                 <a:cs typeface="Segoe UI" pitchFamily="34" charset="-120"/>
               </a:rPr>
-              <a:t>Personalised AI briefing  </a:t>
+              <a:t>Personalised AI briefing: </a:t>
             </a:r>
             <a:pPr indent="0" marL="0">
               <a:lnSpc>
@@ -8515,7 +8515,7 @@
                 <a:ea typeface="Segoe UI" pitchFamily="34" charset="-122"/>
                 <a:cs typeface="Segoe UI" pitchFamily="34" charset="-120"/>
               </a:rPr>
-              <a:t>— land on a summary of what matters right now, tailored to what you follow and view.</a:t>
+              <a:t>land on a summary of what matters right now, tailored to what you follow and view.</a:t>
             </a:r>
             <a:endParaRPr lang="en-US" sz="1200" dirty="0"/>
           </a:p>
@@ -8557,7 +8557,7 @@
                 <a:ea typeface="Segoe UI" pitchFamily="34" charset="-122"/>
                 <a:cs typeface="Segoe UI" pitchFamily="34" charset="-120"/>
               </a:rPr>
-              <a:t>Goals with pace &amp; forecast  </a:t>
+              <a:t>Goals with pace &amp; forecast: </a:t>
             </a:r>
             <a:pPr indent="0" marL="0">
               <a:lnSpc>
@@ -8574,7 +8574,7 @@
                 <a:ea typeface="Segoe UI" pitchFamily="34" charset="-122"/>
                 <a:cs typeface="Segoe UI" pitchFamily="34" charset="-120"/>
               </a:rPr>
-              <a:t>— a North Star target on every screen: ahead / on-track / behind vs last event’s real sell-curve, with a projected landing.</a:t>
+              <a:t>a North Star target on every screen: ahead / on-track / behind vs last event’s real sell-curve, with a projected landing.</a:t>
             </a:r>
             <a:endParaRPr lang="en-US" sz="1200" dirty="0"/>
           </a:p>
@@ -8637,7 +8637,7 @@
                 <a:ea typeface="Segoe UI" pitchFamily="34" charset="-122"/>
                 <a:cs typeface="Segoe UI" pitchFamily="34" charset="-120"/>
               </a:rPr>
-              <a:t>The dashboard with the Owl one tap away — every number explained.</a:t>
+              <a:t>The dashboard with the Owl one tap away, every number explained.</a:t>
             </a:r>
             <a:endParaRPr lang="en-US" sz="950" dirty="0"/>
           </a:p>
@@ -8679,7 +8679,7 @@
                 <a:ea typeface="Segoe UI" pitchFamily="34" charset="-122"/>
                 <a:cs typeface="Segoe UI" pitchFamily="34" charset="-120"/>
               </a:rPr>
-              <a:t>Scheduled digests  </a:t>
+              <a:t>Scheduled digests: </a:t>
             </a:r>
             <a:pPr indent="0" marL="0">
               <a:lnSpc>
@@ -8696,7 +8696,7 @@
                 <a:ea typeface="Segoe UI" pitchFamily="34" charset="-122"/>
                 <a:cs typeface="Segoe UI" pitchFamily="34" charset="-120"/>
               </a:rPr>
-              <a:t>— role-specific email briefings (exec / marketing / finance / ops) on your cadence, with charts rendered in the email.</a:t>
+              <a:t>role-specific email briefings (exec / marketing / finance / ops) on your cadence, with charts rendered in the email.</a:t>
             </a:r>
             <a:endParaRPr lang="en-US" sz="1200" dirty="0"/>
           </a:p>
@@ -8738,7 +8738,7 @@
                 <a:ea typeface="Segoe UI" pitchFamily="34" charset="-122"/>
                 <a:cs typeface="Segoe UI" pitchFamily="34" charset="-120"/>
               </a:rPr>
-              <a:t>Share any insight  </a:t>
+              <a:t>Share any insight: </a:t>
             </a:r>
             <a:pPr indent="0" marL="0">
               <a:lnSpc>
@@ -8755,7 +8755,7 @@
                 <a:ea typeface="Segoe UI" pitchFamily="34" charset="-122"/>
                 <a:cs typeface="Segoe UI" pitchFamily="34" charset="-120"/>
               </a:rPr>
-              <a:t>— hand a finding to email, WhatsApp or Slack in one tap, with a link back to the view.</a:t>
+              <a:t>hand a finding to email, WhatsApp or Slack in one tap, with a link back to the view.</a:t>
             </a:r>
             <a:endParaRPr lang="en-US" sz="1200" dirty="0"/>
           </a:p>
@@ -8816,7 +8816,7 @@
                 <a:ea typeface="Segoe UI" pitchFamily="34" charset="-122"/>
                 <a:cs typeface="Segoe UI" pitchFamily="34" charset="-120"/>
               </a:rPr>
-              <a:t>“Your data, read for you — open the app and you already know what changed and what to do.”</a:t>
+              <a:t>“Your data, read for you, open the app and you already know what changed and what to do.”</a:t>
             </a:r>
             <a:endParaRPr lang="en-US" sz="1450" dirty="0"/>
           </a:p>
@@ -8907,7 +8907,7 @@
                 <a:ea typeface="Segoe UI" pitchFamily="34" charset="-122"/>
                 <a:cs typeface="Segoe UI" pitchFamily="34" charset="-120"/>
               </a:rPr>
-              <a:t>🦉  ASK — your AI Data Analyst, everywhere</a:t>
+              <a:t>🦉  ASK · your AI Data Analyst, everywhere</a:t>
             </a:r>
             <a:endParaRPr lang="en-US" sz="2600" dirty="0"/>
           </a:p>
@@ -9181,7 +9181,7 @@
                 <a:ea typeface="Segoe UI" pitchFamily="34" charset="-122"/>
                 <a:cs typeface="Segoe UI" pitchFamily="34" charset="-120"/>
               </a:rPr>
-              <a:t>Ask the Owl in-app  </a:t>
+              <a:t>Ask the Owl in-app: </a:t>
             </a:r>
             <a:pPr indent="0" marL="0">
               <a:lnSpc>
@@ -9198,7 +9198,7 @@
                 <a:ea typeface="Segoe UI" pitchFamily="34" charset="-122"/>
                 <a:cs typeface="Segoe UI" pitchFamily="34" charset="-120"/>
               </a:rPr>
-              <a:t>— “what’s on sale right now?”, “how does this compare to last year?” — conversational answers, scoped to your data.</a:t>
+              <a:t>“what’s on sale right now?”, “how does this compare to last year?”, conversational answers, scoped to your data.</a:t>
             </a:r>
             <a:endParaRPr lang="en-US" sz="1200" dirty="0"/>
           </a:p>
@@ -9240,7 +9240,7 @@
                 <a:ea typeface="Segoe UI" pitchFamily="34" charset="-122"/>
                 <a:cs typeface="Segoe UI" pitchFamily="34" charset="-120"/>
               </a:rPr>
-              <a:t>The Owl on WhatsApp  </a:t>
+              <a:t>The Owl on WhatsApp: </a:t>
             </a:r>
             <a:pPr indent="0" marL="0">
               <a:lnSpc>
@@ -9257,7 +9257,7 @@
                 <a:ea typeface="Segoe UI" pitchFamily="34" charset="-122"/>
                 <a:cs typeface="Segoe UI" pitchFamily="34" charset="-120"/>
               </a:rPr>
-              <a:t>— message it from your own WhatsApp: answers, charts as images, tappable follow-ups, daily updates — even draft a campaign by reply button.</a:t>
+              <a:t>message it from your own WhatsApp: answers, charts as images, tappable follow-ups, daily updates, even draft a campaign by reply button.</a:t>
             </a:r>
             <a:endParaRPr lang="en-US" sz="1200" dirty="0"/>
           </a:p>
@@ -9299,7 +9299,7 @@
                 <a:ea typeface="Segoe UI" pitchFamily="34" charset="-122"/>
                 <a:cs typeface="Segoe UI" pitchFamily="34" charset="-120"/>
               </a:rPr>
-              <a:t>Reads your Google Drive  </a:t>
+              <a:t>Reads your Google Drive: </a:t>
             </a:r>
             <a:pPr indent="0" marL="0">
               <a:lnSpc>
@@ -9316,7 +9316,7 @@
                 <a:ea typeface="Segoe UI" pitchFamily="34" charset="-122"/>
                 <a:cs typeface="Segoe UI" pitchFamily="34" charset="-120"/>
               </a:rPr>
-              <a:t>— share budgets, marketing plans or sponsor decks; the Owl answers from them alongside live sales data.</a:t>
+              <a:t>share budgets, marketing plans or sponsor decks; the Owl answers from them alongside live sales data.</a:t>
             </a:r>
             <a:endParaRPr lang="en-US" sz="1200" dirty="0"/>
           </a:p>
@@ -9358,7 +9358,7 @@
                 <a:ea typeface="Segoe UI" pitchFamily="34" charset="-122"/>
                 <a:cs typeface="Segoe UI" pitchFamily="34" charset="-120"/>
               </a:rPr>
-              <a:t>Take action by chat  </a:t>
+              <a:t>Take action by chat: </a:t>
             </a:r>
             <a:pPr indent="0" marL="0">
               <a:lnSpc>
@@ -9375,7 +9375,7 @@
                 <a:ea typeface="Segoe UI" pitchFamily="34" charset="-122"/>
                 <a:cs typeface="Segoe UI" pitchFamily="34" charset="-120"/>
               </a:rPr>
-              <a:t>— the Owl doesn’t just answer: it can set up an alert, save a segment or draft a campaign straight from the conversation, with a confirm step before anything is created.</a:t>
+              <a:t>the Owl doesn’t just answer: it can set up an alert, save a segment or draft a campaign straight from the conversation, with a confirm step before anything is created.</a:t>
             </a:r>
             <a:endParaRPr lang="en-US" sz="1200" dirty="0"/>
           </a:p>
@@ -9439,7 +9439,7 @@
                 <a:ea typeface="Segoe UI" pitchFamily="34" charset="-122"/>
                 <a:cs typeface="Segoe UI" pitchFamily="34" charset="-120"/>
               </a:rPr>
-              <a:t>Grounded, always: the Owl quotes your data — it never invents. And it answers only your own events; the scope gate is enforced server-side and cannot be bypassed.</a:t>
+              <a:t>Grounded, always: the Owl quotes your data, it never invents. And it answers only your own events; the scope gate is enforced server-side and cannot be bypassed.</a:t>
             </a:r>
             <a:endParaRPr lang="en-US" sz="1400" dirty="0"/>
           </a:p>
@@ -9478,7 +9478,7 @@
                 <a:ea typeface="Segoe UI" pitchFamily="34" charset="-122"/>
                 <a:cs typeface="Segoe UI" pitchFamily="34" charset="-120"/>
               </a:rPr>
-              <a:t>“Ask your data anything, in plain language — your own analyst, in your pocket.”</a:t>
+              <a:t>“Ask your data anything, in plain language, your own analyst, in your pocket.”</a:t>
             </a:r>
             <a:endParaRPr lang="en-US" sz="1500" dirty="0"/>
           </a:p>
@@ -9610,7 +9610,7 @@
                 <a:ea typeface="Segoe UI" pitchFamily="34" charset="-122"/>
                 <a:cs typeface="Segoe UI" pitchFamily="34" charset="-120"/>
               </a:rPr>
-              <a:t>the Owl at the centre — the doors your team already uses around it</a:t>
+              <a:t>the Owl at the centre, the doors your team already uses around it</a:t>
             </a:r>
             <a:endParaRPr lang="en-US" sz="1200" dirty="0"/>
           </a:p>
@@ -10001,7 +10001,7 @@
                 <a:ea typeface="Segoe UI" pitchFamily="34" charset="-122"/>
                 <a:cs typeface="Segoe UI" pitchFamily="34" charset="-120"/>
               </a:rPr>
-              <a:t>Installs like a native app; pushes a nudge even when closed — tap it and you’re in the right place to act.</a:t>
+              <a:t>Installs like a native app; pushes a nudge even when closed, tap it and you’re in the right place to act.</a:t>
             </a:r>
             <a:endParaRPr lang="en-US" sz="1050" dirty="0"/>
           </a:p>
@@ -10325,7 +10325,7 @@
                 <a:ea typeface="Segoe UI" pitchFamily="34" charset="-122"/>
                 <a:cs typeface="Segoe UI" pitchFamily="34" charset="-120"/>
               </a:rPr>
-              <a:t>The same connector plugs your event data into Claude — read-only, per-client keys you control.</a:t>
+              <a:t>The same connector plugs your event data into Claude, read-only, per-client keys you control.</a:t>
             </a:r>
             <a:endParaRPr lang="en-US" sz="1050" dirty="0"/>
           </a:p>
@@ -10485,7 +10485,7 @@
                 <a:ea typeface="Segoe UI" pitchFamily="34" charset="-122"/>
                 <a:cs typeface="Segoe UI" pitchFamily="34" charset="-120"/>
               </a:rPr>
-              <a:t>Ask in the app, on WhatsApp, in ChatGPT or Claude — same Owl, same live data, same security boundary.</a:t>
+              <a:t>Ask in the app, on WhatsApp, in ChatGPT or Claude, same Owl, same live data, same security boundary.</a:t>
             </a:r>
             <a:endParaRPr lang="en-US" sz="1250" dirty="0"/>
           </a:p>
@@ -10576,7 +10576,7 @@
                 <a:ea typeface="Segoe UI" pitchFamily="34" charset="-122"/>
                 <a:cs typeface="Segoe UI" pitchFamily="34" charset="-120"/>
               </a:rPr>
-              <a:t>⚡  ACT — Engage, the campaign engine</a:t>
+              <a:t>⚡  ACT · Engage, the campaign engine</a:t>
             </a:r>
             <a:endParaRPr lang="en-US" sz="2600" dirty="0"/>
           </a:p>
@@ -10850,7 +10850,7 @@
                 <a:ea typeface="Segoe UI" pitchFamily="34" charset="-122"/>
                 <a:cs typeface="Segoe UI" pitchFamily="34" charset="-120"/>
               </a:rPr>
-              <a:t>Live segments  </a:t>
+              <a:t>Live segments: </a:t>
             </a:r>
             <a:pPr indent="0" marL="0">
               <a:lnSpc>
@@ -10867,7 +10867,7 @@
                 <a:ea typeface="Segoe UI" pitchFamily="34" charset="-122"/>
                 <a:cs typeface="Segoe UI" pitchFamily="34" charset="-120"/>
               </a:rPr>
-              <a:t>— audiences from a dashboard tile, CSV or linked Google Sheet; union / intersect / exclude (abandoned carts minus already-called). Always current at send time.</a:t>
+              <a:t>audiences from a dashboard tile, CSV or linked Google Sheet; union / intersect / exclude (abandoned carts minus already-called). Always current at send time.</a:t>
             </a:r>
             <a:endParaRPr lang="en-US" sz="1200" dirty="0"/>
           </a:p>
@@ -10909,7 +10909,7 @@
                 <a:ea typeface="Segoe UI" pitchFamily="34" charset="-122"/>
                 <a:cs typeface="Segoe UI" pitchFamily="34" charset="-120"/>
               </a:rPr>
-              <a:t>Email &amp; SMS campaigns  </a:t>
+              <a:t>Email &amp; SMS campaigns: </a:t>
             </a:r>
             <a:pPr indent="0" marL="0">
               <a:lnSpc>
@@ -10926,7 +10926,7 @@
                 <a:ea typeface="Segoe UI" pitchFamily="34" charset="-122"/>
                 <a:cs typeface="Segoe UI" pitchFamily="34" charset="-120"/>
               </a:rPr>
-              <a:t>— AI-drafted copy, drag-and-drop block builder, AI-designed layouts &amp; banners, merge fields, promo codes, full open/click tracking.</a:t>
+              <a:t>AI-drafted copy, drag-and-drop block builder, AI-designed layouts &amp; banners, merge fields, promo codes, full open/click tracking.</a:t>
             </a:r>
             <a:endParaRPr lang="en-US" sz="1200" dirty="0"/>
           </a:p>
@@ -10968,7 +10968,7 @@
                 <a:ea typeface="Segoe UI" pitchFamily="34" charset="-122"/>
                 <a:cs typeface="Segoe UI" pitchFamily="34" charset="-120"/>
               </a:rPr>
-              <a:t>Drip automations  </a:t>
+              <a:t>Drip automations: </a:t>
             </a:r>
             <a:pPr indent="0" marL="0">
               <a:lnSpc>
@@ -10985,7 +10985,7 @@
                 <a:ea typeface="Segoe UI" pitchFamily="34" charset="-122"/>
                 <a:cs typeface="Segoe UI" pitchFamily="34" charset="-120"/>
               </a:rPr>
-              <a:t>— abandoned-cart journeys that catch new abandoners in real time, stop when someone buys, and show a per-step conversion waterfall.</a:t>
+              <a:t>abandoned-cart journeys that catch new abandoners in real time, stop when someone buys, and show a per-step conversion waterfall.</a:t>
             </a:r>
             <a:endParaRPr lang="en-US" sz="1200" dirty="0"/>
           </a:p>
@@ -11027,7 +11027,7 @@
                 <a:ea typeface="Segoe UI" pitchFamily="34" charset="-122"/>
                 <a:cs typeface="Segoe UI" pitchFamily="34" charset="-120"/>
               </a:rPr>
-              <a:t>Owl auto-pilot  </a:t>
+              <a:t>Owl auto-pilot: </a:t>
             </a:r>
             <a:pPr indent="0" marL="0">
               <a:lnSpc>
@@ -11044,7 +11044,7 @@
                 <a:ea typeface="Segoe UI" pitchFamily="34" charset="-122"/>
                 <a:cs typeface="Segoe UI" pitchFamily="34" charset="-120"/>
               </a:rPr>
-              <a:t>— one tap turns an AI suggestion into a drafted campaign; it still rides the normal review + approval gates.</a:t>
+              <a:t>one tap turns an AI suggestion into a drafted campaign; it still rides the normal review + approval gates.</a:t>
             </a:r>
             <a:endParaRPr lang="en-US" sz="1200" dirty="0"/>
           </a:p>
@@ -11086,7 +11086,7 @@
                 <a:ea typeface="Segoe UI" pitchFamily="34" charset="-122"/>
                 <a:cs typeface="Segoe UI" pitchFamily="34" charset="-120"/>
               </a:rPr>
-              <a:t>Approvals &amp; consent built in  </a:t>
+              <a:t>Approvals &amp; consent built in: </a:t>
             </a:r>
             <a:pPr indent="0" marL="0">
               <a:lnSpc>
@@ -11103,7 +11103,7 @@
                 <a:ea typeface="Segoe UI" pitchFamily="34" charset="-122"/>
                 <a:cs typeface="Segoe UI" pitchFamily="34" charset="-120"/>
               </a:rPr>
-              <a:t>— nothing sends without explicit approval; POPIA-aware consent enforced per channel; send caps stop costly mistakes.</a:t>
+              <a:t>nothing sends without explicit approval; POPIA-aware consent enforced per channel; send caps stop costly mistakes.</a:t>
             </a:r>
             <a:endParaRPr lang="en-US" sz="1200" dirty="0"/>
           </a:p>
@@ -11145,7 +11145,7 @@
                 <a:ea typeface="Segoe UI" pitchFamily="34" charset="-122"/>
                 <a:cs typeface="Segoe UI" pitchFamily="34" charset="-120"/>
               </a:rPr>
-              <a:t>Ad-platform sync  </a:t>
+              <a:t>Ad-platform sync: </a:t>
             </a:r>
             <a:pPr indent="0" marL="0">
               <a:lnSpc>
@@ -11162,7 +11162,7 @@
                 <a:ea typeface="Segoe UI" pitchFamily="34" charset="-122"/>
                 <a:cs typeface="Segoe UI" pitchFamily="34" charset="-120"/>
               </a:rPr>
-              <a:t>— push a segment to Meta or TikTok as a Custom Audience (hashed, privacy-safe), auto-synced daily; see spend &amp; ROAS next to ticket sales.</a:t>
+              <a:t>push a segment to Meta or TikTok as a Custom Audience (hashed, privacy-safe), auto-synced daily; see spend &amp; ROAS next to ticket sales.</a:t>
             </a:r>
             <a:endParaRPr lang="en-US" sz="1200" dirty="0"/>
           </a:p>
@@ -11223,7 +11223,7 @@
                 <a:ea typeface="Segoe UI" pitchFamily="34" charset="-122"/>
                 <a:cs typeface="Segoe UI" pitchFamily="34" charset="-120"/>
               </a:rPr>
-              <a:t>“Personalised, on-brand email + SMS to a precise audience — approval gates and real tracking, all from the same data.”</a:t>
+              <a:t>“Personalised, on-brand email + SMS to a precise audience, approval gates and real tracking, all from the same data.”</a:t>
             </a:r>
             <a:endParaRPr lang="en-US" sz="1500" dirty="0"/>
           </a:p>
@@ -11355,7 +11355,7 @@
                 <a:ea typeface="Segoe UI" pitchFamily="34" charset="-122"/>
                 <a:cs typeface="Segoe UI" pitchFamily="34" charset="-120"/>
               </a:rPr>
-              <a:t>audiences · journeys · ad platforms · creative · attribution — one live, governed dataset</a:t>
+              <a:t>audiences · journeys · ad platforms · creative · attribution, one live, governed dataset</a:t>
             </a:r>
             <a:endParaRPr lang="en-US" sz="1200" dirty="0"/>
           </a:p>
@@ -12049,7 +12049,7 @@
                 <a:ea typeface="Segoe UI" pitchFamily="34" charset="-122"/>
                 <a:cs typeface="Segoe UI" pitchFamily="34" charset="-120"/>
               </a:rPr>
-              <a:t>Audiences that never go stale  </a:t>
+              <a:t>Audiences that never go stale: </a:t>
             </a:r>
             <a:pPr indent="0" marL="0">
               <a:lnSpc>
@@ -12066,7 +12066,7 @@
                 <a:ea typeface="Segoe UI" pitchFamily="34" charset="-122"/>
                 <a:cs typeface="Segoe UI" pitchFamily="34" charset="-120"/>
               </a:rPr>
-              <a:t>— segments re-resolve live at send time; combine sources, subtract suppression lists, filter on any column.</a:t>
+              <a:t>segments re-resolve live at send time; combine sources, subtract suppression lists, filter on any column.</a:t>
             </a:r>
             <a:endParaRPr lang="en-US" sz="1200" dirty="0"/>
           </a:p>
@@ -12108,7 +12108,7 @@
                 <a:ea typeface="Segoe UI" pitchFamily="34" charset="-122"/>
                 <a:cs typeface="Segoe UI" pitchFamily="34" charset="-120"/>
               </a:rPr>
-              <a:t>Complex journeys, simple setup  </a:t>
+              <a:t>Complex journeys, simple setup: </a:t>
             </a:r>
             <a:pPr indent="0" marL="0">
               <a:lnSpc>
@@ -12125,7 +12125,7 @@
                 <a:ea typeface="Segoe UI" pitchFamily="34" charset="-122"/>
                 <a:cs typeface="Segoe UI" pitchFamily="34" charset="-120"/>
               </a:rPr>
-              <a:t>— timed multi-step email/SMS drips; true real-time abandoned-cart; buyers auto-exit; a per-step conversion waterfall.</a:t>
+              <a:t>timed multi-step email/SMS drips; true real-time abandoned-cart; buyers auto-exit; a per-step conversion waterfall.</a:t>
             </a:r>
             <a:endParaRPr lang="en-US" sz="1200" dirty="0"/>
           </a:p>
@@ -12167,7 +12167,7 @@
                 <a:ea typeface="Segoe UI" pitchFamily="34" charset="-122"/>
                 <a:cs typeface="Segoe UI" pitchFamily="34" charset="-120"/>
               </a:rPr>
-              <a:t>Live data → your ad accounts  </a:t>
+              <a:t>Live data → your ad accounts: </a:t>
             </a:r>
             <a:pPr indent="0" marL="0">
               <a:lnSpc>
@@ -12184,7 +12184,7 @@
                 <a:ea typeface="Segoe UI" pitchFamily="34" charset="-122"/>
                 <a:cs typeface="Segoe UI" pitchFamily="34" charset="-120"/>
               </a:rPr>
-              <a:t>— push segments to Meta/TikTok as Custom Audiences (hashed, mirrored daily); see spend, CPC and ROAS next to ticket sales.</a:t>
+              <a:t>push segments to Meta/TikTok as Custom Audiences (hashed, mirrored daily); see spend, CPC and ROAS next to ticket sales.</a:t>
             </a:r>
             <a:endParaRPr lang="en-US" sz="1200" dirty="0"/>
           </a:p>
@@ -12226,7 +12226,7 @@
                 <a:ea typeface="Segoe UI" pitchFamily="34" charset="-122"/>
                 <a:cs typeface="Segoe UI" pitchFamily="34" charset="-120"/>
               </a:rPr>
-              <a:t>An AI creative studio inside  </a:t>
+              <a:t>An AI creative studio inside: </a:t>
             </a:r>
             <a:pPr indent="0" marL="0">
               <a:lnSpc>
@@ -12243,7 +12243,7 @@
                 <a:ea typeface="Segoe UI" pitchFamily="34" charset="-122"/>
                 <a:cs typeface="Segoe UI" pitchFamily="34" charset="-120"/>
               </a:rPr>
-              <a:t>— the Owl drafts copy, designs whole themed email layouts and draws on-brand banners; any campaign in any language.</a:t>
+              <a:t>the Owl drafts copy, designs whole themed email layouts and draws on-brand banners; any campaign in any language.</a:t>
             </a:r>
             <a:endParaRPr lang="en-US" sz="1200" dirty="0"/>
           </a:p>
@@ -12285,7 +12285,7 @@
                 <a:ea typeface="Segoe UI" pitchFamily="34" charset="-122"/>
                 <a:cs typeface="Segoe UI" pitchFamily="34" charset="-120"/>
               </a:rPr>
-              <a:t>Attribution you can defend  </a:t>
+              <a:t>Attribution you can defend: </a:t>
             </a:r>
             <a:pPr indent="0" marL="0">
               <a:lnSpc>
@@ -12302,7 +12302,7 @@
                 <a:ea typeface="Segoe UI" pitchFamily="34" charset="-122"/>
                 <a:cs typeface="Segoe UI" pitchFamily="34" charset="-120"/>
               </a:rPr>
-              <a:t>— per-recipient opens, clicks and tracked purchases; UTMs everywhere; unique-per-person promo codes tie a sale to a send.</a:t>
+              <a:t>per-recipient opens, clicks and tracked purchases; UTMs everywhere; unique-per-person promo codes tie a sale to a send.</a:t>
             </a:r>
             <a:endParaRPr lang="en-US" sz="1200" dirty="0"/>
           </a:p>
@@ -12344,7 +12344,7 @@
                 <a:ea typeface="Segoe UI" pitchFamily="34" charset="-122"/>
                 <a:cs typeface="Segoe UI" pitchFamily="34" charset="-120"/>
               </a:rPr>
-              <a:t>Guardrails a CMO will love  </a:t>
+              <a:t>Guardrails a CMO will love: </a:t>
             </a:r>
             <a:pPr indent="0" marL="0">
               <a:lnSpc>
@@ -12361,7 +12361,7 @@
                 <a:ea typeface="Segoe UI" pitchFamily="34" charset="-122"/>
                 <a:cs typeface="Segoe UI" pitchFamily="34" charset="-120"/>
               </a:rPr>
-              <a:t>— approval gates, POPIA-aware consent, one-click unsubscribe, audience &amp; SMS send caps.</a:t>
+              <a:t>approval gates, POPIA-aware consent, one-click unsubscribe, audience &amp; SMS send caps.</a:t>
             </a:r>
             <a:endParaRPr lang="en-US" sz="1200" dirty="0"/>
           </a:p>
@@ -12422,7 +12422,7 @@
                 <a:ea typeface="Segoe UI" pitchFamily="34" charset="-122"/>
                 <a:cs typeface="Segoe UI" pitchFamily="34" charset="-120"/>
               </a:rPr>
-              <a:t>“From seeing a cohort to a live journey, an ad audience and tracked revenue — without exporting a single CSV.”</a:t>
+              <a:t>“From seeing a cohort to a live journey, an ad audience and tracked revenue, without exporting a single CSV.”</a:t>
             </a:r>
             <a:endParaRPr lang="en-US" sz="1500" dirty="0"/>
           </a:p>
@@ -12513,7 +12513,7 @@
                 <a:ea typeface="Segoe UI" pitchFamily="34" charset="-122"/>
                 <a:cs typeface="Segoe UI" pitchFamily="34" charset="-120"/>
               </a:rPr>
-              <a:t>🎪  RUN — Event Ops, your operations command centre</a:t>
+              <a:t>🎪  RUN · Event Ops, your operations command centre</a:t>
             </a:r>
             <a:endParaRPr lang="en-US" sz="2600" dirty="0"/>
           </a:p>
@@ -12554,7 +12554,7 @@
                 <a:ea typeface="Segoe UI" pitchFamily="34" charset="-122"/>
                 <a:cs typeface="Segoe UI" pitchFamily="34" charset="-120"/>
               </a:rPr>
-              <a:t>the gates, the bars, the devices, the data itself — one live board</a:t>
+              <a:t>the gates, the bars, the devices, the data itself, one live board</a:t>
             </a:r>
             <a:endParaRPr lang="en-US" sz="1200" dirty="0"/>
           </a:p>
@@ -12787,7 +12787,7 @@
                 <a:ea typeface="Segoe UI" pitchFamily="34" charset="-122"/>
                 <a:cs typeface="Segoe UI" pitchFamily="34" charset="-120"/>
               </a:rPr>
-              <a:t>The live site map  </a:t>
+              <a:t>The live site map: </a:t>
             </a:r>
             <a:pPr indent="0" marL="0">
               <a:lnSpc>
@@ -12804,7 +12804,7 @@
                 <a:ea typeface="Segoe UI" pitchFamily="34" charset="-122"/>
                 <a:cs typeface="Segoe UI" pitchFamily="34" charset="-120"/>
               </a:rPr>
-              <a:t>— your venue’s own plan with every station pinned: heat shows where the crowd is spending right now; a dark station is flagged the moment its data stops.</a:t>
+              <a:t>your venue’s own plan with every station pinned: heat shows where the crowd is spending right now; a dark station is flagged the moment its data stops.</a:t>
             </a:r>
             <a:endParaRPr lang="en-US" sz="1200" dirty="0"/>
           </a:p>
@@ -12846,7 +12846,7 @@
                 <a:ea typeface="Segoe UI" pitchFamily="34" charset="-122"/>
                 <a:cs typeface="Segoe UI" pitchFamily="34" charset="-120"/>
               </a:rPr>
-              <a:t>Hotspots &amp; the heat map  </a:t>
+              <a:t>Hotspots &amp; the heat map: </a:t>
             </a:r>
             <a:pPr indent="0" marL="0">
               <a:lnSpc>
@@ -12863,7 +12863,7 @@
                 <a:ea typeface="Segoe UI" pitchFamily="34" charset="-122"/>
                 <a:cs typeface="Segoe UI" pitchFamily="34" charset="-120"/>
               </a:rPr>
-              <a:t>— station activity through the day in time blocks: watch the crowd move, spot the overloaded station and the dead one, staff accordingly.</a:t>
+              <a:t>station activity through the day in time blocks: watch the crowd move, spot the overloaded station and the dead one, staff accordingly.</a:t>
             </a:r>
             <a:endParaRPr lang="en-US" sz="1200" dirty="0"/>
           </a:p>
@@ -12905,7 +12905,7 @@
                 <a:ea typeface="Segoe UI" pitchFamily="34" charset="-122"/>
                 <a:cs typeface="Segoe UI" pitchFamily="34" charset="-120"/>
               </a:rPr>
-              <a:t>Every device tracked  </a:t>
+              <a:t>Every device tracked: </a:t>
             </a:r>
             <a:pPr indent="0" marL="0">
               <a:lnSpc>
@@ -12922,7 +12922,7 @@
                 <a:ea typeface="Segoe UI" pitchFamily="34" charset="-122"/>
                 <a:cs typeface="Segoe UI" pitchFamily="34" charset="-120"/>
               </a:rPr>
-              <a:t>— scan to move between store and stations; append-only audit trail; every device accounted for at event close.</a:t>
+              <a:t>scan to move between store and stations; append-only audit trail; every device accounted for at event close.</a:t>
             </a:r>
             <a:endParaRPr lang="en-US" sz="1200" dirty="0"/>
           </a:p>
@@ -12964,7 +12964,7 @@
                 <a:ea typeface="Segoe UI" pitchFamily="34" charset="-122"/>
                 <a:cs typeface="Segoe UI" pitchFamily="34" charset="-120"/>
               </a:rPr>
-              <a:t>Connectivity &amp; data health  </a:t>
+              <a:t>Connectivity &amp; data health: </a:t>
             </a:r>
             <a:pPr indent="0" marL="0">
               <a:lnSpc>
@@ -12981,7 +12981,7 @@
                 <a:ea typeface="Segoe UI" pitchFamily="34" charset="-122"/>
                 <a:cs typeface="Segoe UI" pitchFamily="34" charset="-120"/>
               </a:rPr>
-              <a:t>— stream watch per station and a roster of exactly which units are offline and for how long. Know a scanner died before the queue does.</a:t>
+              <a:t>stream watch per station and a roster of exactly which units are offline and for how long. Know a scanner died before the queue does.</a:t>
             </a:r>
             <a:endParaRPr lang="en-US" sz="1200" dirty="0"/>
           </a:p>
@@ -13023,7 +13023,7 @@
                 <a:ea typeface="Segoe UI" pitchFamily="34" charset="-122"/>
                 <a:cs typeface="Segoe UI" pitchFamily="34" charset="-120"/>
               </a:rPr>
-              <a:t>AI Diagnose · live updates · alerts  </a:t>
+              <a:t>AI Diagnose · live updates · alerts: </a:t>
             </a:r>
             <a:pPr indent="0" marL="0">
               <a:lnSpc>
@@ -13040,7 +13040,7 @@
                 <a:ea typeface="Segoe UI" pitchFamily="34" charset="-122"/>
                 <a:cs typeface="Segoe UI" pitchFamily="34" charset="-120"/>
               </a:rPr>
-              <a:t>— one-tap AI verdicts per station, a multi-metric mini report every 15–120 min while doors are open, and threshold alerts on any number.</a:t>
+              <a:t>one-tap AI verdicts per station, a multi-metric mini report every 15–120 min while doors are open, and threshold alerts on any number.</a:t>
             </a:r>
             <a:endParaRPr lang="en-US" sz="1200" dirty="0"/>
           </a:p>
@@ -13103,7 +13103,7 @@
                 <a:ea typeface="Segoe UI" pitchFamily="34" charset="-122"/>
                 <a:cs typeface="Segoe UI" pitchFamily="34" charset="-120"/>
               </a:rPr>
-              <a:t>The Flow board’s live site map — stations, heat and a dark station, on your own venue plan.</a:t>
+              <a:t>The Flow board’s live site map, stations, heat and a dark station, on your own venue plan.</a:t>
             </a:r>
             <a:endParaRPr lang="en-US" sz="1000" dirty="0"/>
           </a:p>

</xml_diff>

<commit_message>
Sales pitch pack v8: bar & operator performance with River view mockup
Event Ops page gains a Bar & operator performance feature and a mockup of
the Flow board's River view in operators-only mode: one flowing lane per
bartender whose width is money through that till, with per-operator sales
and rands-per-hour, a star performer and an idle-till flag. Deck ops slide
carries the River image alongside the site map; live-updates and alerts
bullets merged to fit.

Co-Authored-By: Claude Fable 5 <noreply@anthropic.com>
Claude-Session: https://claude.ai/code/session_016kfeoZ1Zgn8t5cLdc8YKFo
</commit_message>
<xml_diff>
--- a/docs/sales-collateral/Pulse-Sales-Deck.pptx
+++ b/docs/sales-collateral/Pulse-Sales-Deck.pptx
@@ -12846,7 +12846,7 @@
                 <a:ea typeface="Segoe UI" pitchFamily="34" charset="-122"/>
                 <a:cs typeface="Segoe UI" pitchFamily="34" charset="-120"/>
               </a:rPr>
-              <a:t>Hotspots &amp; the heat map: </a:t>
+              <a:t>Bar &amp; operator performance: </a:t>
             </a:r>
             <a:pPr indent="0" marL="0">
               <a:lnSpc>
@@ -12863,7 +12863,7 @@
                 <a:ea typeface="Segoe UI" pitchFamily="34" charset="-122"/>
                 <a:cs typeface="Segoe UI" pitchFamily="34" charset="-120"/>
               </a:rPr>
-              <a:t>station activity through the day in time blocks: watch the crowd move, spot the overloaded station and the dead one, staff accordingly.</a:t>
+              <a:t>every bar and every bartender, live: sales and rands-per-hour per operator, who is flying and which till has gone quiet. The River view turns the night into flowing lanes.</a:t>
             </a:r>
             <a:endParaRPr lang="en-US" sz="1200" dirty="0"/>
           </a:p>
@@ -13062,8 +13062,8 @@
         </p:blipFill>
         <p:spPr>
           <a:xfrm>
-            <a:off x="6172200" y="1463040"/>
-            <a:ext cx="5577840" cy="2039112"/>
+            <a:off x="6172200" y="1417320"/>
+            <a:ext cx="5577840" cy="1883664"/>
           </a:xfrm>
           <a:prstGeom prst="rect">
             <a:avLst/>
@@ -13078,8 +13078,8 @@
         </p:nvSpPr>
         <p:spPr>
           <a:xfrm>
-            <a:off x="6172200" y="3566160"/>
-            <a:ext cx="5577840" cy="457200"/>
+            <a:off x="6172200" y="3319272"/>
+            <a:ext cx="5577840" cy="292608"/>
           </a:xfrm>
           <a:prstGeom prst="rect">
             <a:avLst/>
@@ -13095,7 +13095,7 @@
               <a:buNone/>
             </a:pPr>
             <a:r>
-              <a:rPr lang="en-US" sz="1000" i="1" dirty="0">
+              <a:rPr lang="en-US" sz="950" i="1" dirty="0">
                 <a:solidFill>
                   <a:srgbClr val="55556D"/>
                 </a:solidFill>
@@ -13103,49 +13103,46 @@
                 <a:ea typeface="Segoe UI" pitchFamily="34" charset="-122"/>
                 <a:cs typeface="Segoe UI" pitchFamily="34" charset="-120"/>
               </a:rPr>
-              <a:t>The Flow board’s live site map, stations, heat and a dark station, on your own venue plan.</a:t>
-            </a:r>
-            <a:endParaRPr lang="en-US" sz="1000" dirty="0"/>
-          </a:p>
-        </p:txBody>
-      </p:sp>
-      <p:sp>
-        <p:nvSpPr>
-          <p:cNvPr id="18" name="Shape 15"/>
-          <p:cNvSpPr/>
-          <p:nvPr/>
-        </p:nvSpPr>
-        <p:spPr>
-          <a:xfrm>
-            <a:off x="6172200" y="4160520"/>
-            <a:ext cx="5577840" cy="1828800"/>
-          </a:xfrm>
-          <a:prstGeom prst="roundRect">
-            <a:avLst>
-              <a:gd name="adj" fmla="val 5000"/>
-            </a:avLst>
-          </a:prstGeom>
-          <a:solidFill>
-            <a:srgbClr val="F0FBFD"/>
-          </a:solidFill>
-          <a:ln w="12700">
-            <a:solidFill>
-              <a:srgbClr val="06B6D4"/>
-            </a:solidFill>
-            <a:prstDash val="solid"/>
-          </a:ln>
-        </p:spPr>
-      </p:sp>
-      <p:sp>
-        <p:nvSpPr>
-          <p:cNvPr id="19" name="Text 16"/>
-          <p:cNvSpPr/>
-          <p:nvPr/>
-        </p:nvSpPr>
-        <p:spPr>
-          <a:xfrm>
-            <a:off x="6400800" y="4297680"/>
-            <a:ext cx="5120640" cy="1554480"/>
+              <a:t>The live site map: stations, heat and a dark station, on your own venue plan.</a:t>
+            </a:r>
+            <a:endParaRPr lang="en-US" sz="950" dirty="0"/>
+          </a:p>
+        </p:txBody>
+      </p:sp>
+      <p:pic>
+        <p:nvPicPr>
+          <p:cNvPr id="18" name="Image 1" descr="river.png">    </p:cNvPr>
+          <p:cNvPicPr>
+            <a:picLocks noChangeAspect="1"/>
+          </p:cNvPicPr>
+          <p:nvPr/>
+        </p:nvPicPr>
+        <p:blipFill>
+          <a:blip r:embed="rId2"/>
+          <a:stretch>
+            <a:fillRect/>
+          </a:stretch>
+        </p:blipFill>
+        <p:spPr>
+          <a:xfrm>
+            <a:off x="6172200" y="3749040"/>
+            <a:ext cx="5577840" cy="1965960"/>
+          </a:xfrm>
+          <a:prstGeom prst="rect">
+            <a:avLst/>
+          </a:prstGeom>
+        </p:spPr>
+      </p:pic>
+      <p:sp>
+        <p:nvSpPr>
+          <p:cNvPr id="19" name="Text 15"/>
+          <p:cNvSpPr/>
+          <p:nvPr/>
+        </p:nvSpPr>
+        <p:spPr>
+          <a:xfrm>
+            <a:off x="6172200" y="5742432"/>
+            <a:ext cx="5577840" cy="292608"/>
           </a:xfrm>
           <a:prstGeom prst="rect">
             <a:avLst/>
@@ -13157,24 +13154,21 @@
           <a:bodyPr wrap="square" rtlCol="0" anchor="ctr"/>
           <a:lstStyle/>
           <a:p>
-            <a:pPr algn="ctr" indent="0" marL="0">
-              <a:lnSpc>
-                <a:spcPts val="2000"/>
-              </a:lnSpc>
-              <a:buNone/>
-            </a:pPr>
-            <a:r>
-              <a:rPr lang="en-US" sz="1400" b="1" i="1" dirty="0">
-                <a:solidFill>
-                  <a:srgbClr val="0E7490"/>
-                </a:solidFill>
-                <a:latin typeface="Segoe UI" pitchFamily="34" charset="0"/>
-                <a:ea typeface="Segoe UI" pitchFamily="34" charset="-122"/>
-                <a:cs typeface="Segoe UI" pitchFamily="34" charset="-120"/>
-              </a:rPr>
-              <a:t>“You’ll know a hotspot is forming, or a scanner has died, before anyone on the ground has to tell you.”</a:t>
-            </a:r>
-            <a:endParaRPr lang="en-US" sz="1400" dirty="0"/>
+            <a:pPr indent="0" marL="0">
+              <a:buNone/>
+            </a:pPr>
+            <a:r>
+              <a:rPr lang="en-US" sz="950" i="1" dirty="0">
+                <a:solidFill>
+                  <a:srgbClr val="55556D"/>
+                </a:solidFill>
+                <a:latin typeface="Segoe UI" pitchFamily="34" charset="0"/>
+                <a:ea typeface="Segoe UI" pitchFamily="34" charset="-122"/>
+                <a:cs typeface="Segoe UI" pitchFamily="34" charset="-120"/>
+              </a:rPr>
+              <a:t>The River, operators only: each lane is money flowing through one bartender’s till.</a:t>
+            </a:r>
+            <a:endParaRPr lang="en-US" sz="950" dirty="0"/>
           </a:p>
         </p:txBody>
       </p:sp>

</xml_diff>

<commit_message>
Sales pitch pack v9: correct positioning, Howler is the Experience OS, Pulse its flagship
Opening line and footers now read: Howler is the Experience Operating
System for live events; Pulse is our new flagship product.

Co-Authored-By: Claude Fable 5 <noreply@anthropic.com>
Claude-Session: https://claude.ai/code/session_016kfeoZ1Zgn8t5cLdc8YKFo
</commit_message>
<xml_diff>
--- a/docs/sales-collateral/Pulse-Sales-Deck.pptx
+++ b/docs/sales-collateral/Pulse-Sales-Deck.pptx
@@ -2194,7 +2194,7 @@
                 <a:ea typeface="Segoe UI" pitchFamily="34" charset="-122"/>
                 <a:cs typeface="Segoe UI" pitchFamily="34" charset="-120"/>
               </a:rPr>
-              <a:t>The Experience OS for event organisers: live dashboards, an AI analyst, and a full email/SMS campaign engine, all powered by the same governed data. Insight → action → results, in your brand, on your phone.</a:t>
+              <a:t>Howler is the Experience Operating System for live events; Pulse is our new flagship product: live dashboards, an AI analyst, and a full email/SMS campaign engine, all powered by the same governed data. Insight → action → results, in your brand, on your phone.</a:t>
             </a:r>
             <a:endParaRPr lang="en-US" sz="1500" dirty="0"/>
           </a:p>
@@ -2538,7 +2538,7 @@
                 <a:ea typeface="Segoe UI" pitchFamily="34" charset="-122"/>
                 <a:cs typeface="Segoe UI" pitchFamily="34" charset="-120"/>
               </a:rPr>
-              <a:t>  ·  The Experience OS by Howler</a:t>
+              <a:t>  ·  flagship of the Howler Experience OS</a:t>
             </a:r>
             <a:endParaRPr lang="en-US" sz="900" dirty="0"/>
           </a:p>
@@ -3276,7 +3276,7 @@
                 <a:ea typeface="Segoe UI" pitchFamily="34" charset="-122"/>
                 <a:cs typeface="Segoe UI" pitchFamily="34" charset="-120"/>
               </a:rPr>
-              <a:t>  ·  The Experience OS by Howler</a:t>
+              <a:t>  ·  flagship of the Howler Experience OS</a:t>
             </a:r>
             <a:endParaRPr lang="en-US" sz="900" dirty="0"/>
           </a:p>
@@ -4726,7 +4726,7 @@
                 <a:ea typeface="Segoe UI" pitchFamily="34" charset="-122"/>
                 <a:cs typeface="Segoe UI" pitchFamily="34" charset="-120"/>
               </a:rPr>
-              <a:t>  ·  The Experience OS by Howler</a:t>
+              <a:t>  ·  flagship of the Howler Experience OS</a:t>
             </a:r>
             <a:endParaRPr lang="en-US" sz="900" dirty="0"/>
           </a:p>
@@ -6369,7 +6369,7 @@
                 <a:ea typeface="Segoe UI" pitchFamily="34" charset="-122"/>
                 <a:cs typeface="Segoe UI" pitchFamily="34" charset="-120"/>
               </a:rPr>
-              <a:t>  ·  The Experience OS by Howler</a:t>
+              <a:t>  ·  flagship of the Howler Experience OS</a:t>
             </a:r>
             <a:endParaRPr lang="en-US" sz="900" dirty="0"/>
           </a:p>
@@ -7163,7 +7163,7 @@
                 <a:ea typeface="Segoe UI" pitchFamily="34" charset="-122"/>
                 <a:cs typeface="Segoe UI" pitchFamily="34" charset="-120"/>
               </a:rPr>
-              <a:t>  ·  The Experience OS by Howler</a:t>
+              <a:t>  ·  flagship of the Howler Experience OS</a:t>
             </a:r>
             <a:endParaRPr lang="en-US" sz="900" dirty="0"/>
           </a:p>
@@ -8260,7 +8260,7 @@
                 <a:ea typeface="Segoe UI" pitchFamily="34" charset="-122"/>
                 <a:cs typeface="Segoe UI" pitchFamily="34" charset="-120"/>
               </a:rPr>
-              <a:t>  ·  The Experience OS by Howler</a:t>
+              <a:t>  ·  flagship of the Howler Experience OS</a:t>
             </a:r>
             <a:endParaRPr lang="en-US" sz="900" dirty="0"/>
           </a:p>
@@ -9061,7 +9061,7 @@
                 <a:ea typeface="Segoe UI" pitchFamily="34" charset="-122"/>
                 <a:cs typeface="Segoe UI" pitchFamily="34" charset="-120"/>
               </a:rPr>
-              <a:t>  ·  The Experience OS by Howler</a:t>
+              <a:t>  ·  flagship of the Howler Experience OS</a:t>
             </a:r>
             <a:endParaRPr lang="en-US" sz="900" dirty="0"/>
           </a:p>
@@ -9723,7 +9723,7 @@
                 <a:ea typeface="Segoe UI" pitchFamily="34" charset="-122"/>
                 <a:cs typeface="Segoe UI" pitchFamily="34" charset="-120"/>
               </a:rPr>
-              <a:t>  ·  The Experience OS by Howler</a:t>
+              <a:t>  ·  flagship of the Howler Experience OS</a:t>
             </a:r>
             <a:endParaRPr lang="en-US" sz="900" dirty="0"/>
           </a:p>
@@ -10730,7 +10730,7 @@
                 <a:ea typeface="Segoe UI" pitchFamily="34" charset="-122"/>
                 <a:cs typeface="Segoe UI" pitchFamily="34" charset="-120"/>
               </a:rPr>
-              <a:t>  ·  The Experience OS by Howler</a:t>
+              <a:t>  ·  flagship of the Howler Experience OS</a:t>
             </a:r>
             <a:endParaRPr lang="en-US" sz="900" dirty="0"/>
           </a:p>
@@ -11468,7 +11468,7 @@
                 <a:ea typeface="Segoe UI" pitchFamily="34" charset="-122"/>
                 <a:cs typeface="Segoe UI" pitchFamily="34" charset="-120"/>
               </a:rPr>
-              <a:t>  ·  The Experience OS by Howler</a:t>
+              <a:t>  ·  flagship of the Howler Experience OS</a:t>
             </a:r>
             <a:endParaRPr lang="en-US" sz="900" dirty="0"/>
           </a:p>
@@ -12667,7 +12667,7 @@
                 <a:ea typeface="Segoe UI" pitchFamily="34" charset="-122"/>
                 <a:cs typeface="Segoe UI" pitchFamily="34" charset="-120"/>
               </a:rPr>
-              <a:t>  ·  The Experience OS by Howler</a:t>
+              <a:t>  ·  flagship of the Howler Experience OS</a:t>
             </a:r>
             <a:endParaRPr lang="en-US" sz="900" dirty="0"/>
           </a:p>

</xml_diff>

<commit_message>
Sales pitch deck: fix three slide formatting errors
Rendered every slide via LibreOffice and fixed what showed up: slide 9's
title wrapped out of the header band (shortened), slide 11's comparison
table had a washed-out header overlay leaving a phantom empty row (header
fill now set per cell, overlay removed), and slide 12's better-together
cards overlapped the footer (resized).

Co-Authored-By: Claude Fable 5 <noreply@anthropic.com>
Claude-Session: https://claude.ai/code/session_016kfeoZ1Zgn8t5cLdc8YKFo
</commit_message>
<xml_diff>
--- a/docs/sales-collateral/Pulse-Sales-Deck.pptx
+++ b/docs/sales-collateral/Pulse-Sales-Deck.pptx
@@ -3452,7 +3452,7 @@
                       <a:tailEnd type="none" w="med" len="med"/>
                     </a:lnB>
                     <a:solidFill>
-                      <a:srgbClr val="FFFFFF"/>
+                      <a:srgbClr val="F6F1FF"/>
                     </a:solidFill>
                   </a:tcPr>
                 </a:tc>
@@ -3520,7 +3520,7 @@
                       <a:tailEnd type="none" w="med" len="med"/>
                     </a:lnB>
                     <a:solidFill>
-                      <a:srgbClr val="FFFFFF"/>
+                      <a:srgbClr val="F6F1FF"/>
                     </a:solidFill>
                   </a:tcPr>
                 </a:tc>
@@ -3588,7 +3588,7 @@
                       <a:tailEnd type="none" w="med" len="med"/>
                     </a:lnB>
                     <a:solidFill>
-                      <a:srgbClr val="FFFFFF"/>
+                      <a:srgbClr val="F6F1FF"/>
                     </a:solidFill>
                   </a:tcPr>
                 </a:tc>
@@ -4423,34 +4423,7 @@
       </p:graphicFrame>
       <p:sp>
         <p:nvSpPr>
-          <p:cNvPr id="12" name="Shape 9"/>
-          <p:cNvSpPr/>
-          <p:nvPr/>
-        </p:nvSpPr>
-        <p:spPr>
-          <a:xfrm>
-            <a:off x="457200" y="1463040"/>
-            <a:ext cx="11338560" cy="457200"/>
-          </a:xfrm>
-          <a:prstGeom prst="rect">
-            <a:avLst/>
-          </a:prstGeom>
-          <a:solidFill>
-            <a:srgbClr val="F6F1FF">
-              <a:alpha val="60000"/>
-            </a:srgbClr>
-          </a:solidFill>
-          <a:ln w="19050">
-            <a:solidFill>
-              <a:srgbClr val="7C3AED"/>
-            </a:solidFill>
-            <a:prstDash val="solid"/>
-          </a:ln>
-        </p:spPr>
-      </p:sp>
-      <p:sp>
-        <p:nvSpPr>
-          <p:cNvPr id="13" name="Text 10"/>
+          <p:cNvPr id="12" name="Text 9"/>
           <p:cNvSpPr/>
           <p:nvPr/>
         </p:nvSpPr>
@@ -5511,8 +5484,8 @@
         </p:nvSpPr>
         <p:spPr>
           <a:xfrm>
-            <a:off x="457200" y="4864608"/>
-            <a:ext cx="11338560" cy="365760"/>
+            <a:off x="457200" y="4791456"/>
+            <a:ext cx="11338560" cy="347472"/>
           </a:xfrm>
           <a:prstGeom prst="rect">
             <a:avLst/>
@@ -5550,12 +5523,12 @@
         </p:nvSpPr>
         <p:spPr>
           <a:xfrm>
-            <a:off x="457200" y="5349240"/>
-            <a:ext cx="3657600" cy="1234440"/>
+            <a:off x="457200" y="5193792"/>
+            <a:ext cx="3657600" cy="1133856"/>
           </a:xfrm>
           <a:prstGeom prst="roundRect">
             <a:avLst>
-              <a:gd name="adj" fmla="val 7407"/>
+              <a:gd name="adj" fmla="val 8065"/>
             </a:avLst>
           </a:prstGeom>
           <a:solidFill>
@@ -5572,8 +5545,8 @@
         </p:nvSpPr>
         <p:spPr>
           <a:xfrm>
-            <a:off x="594360" y="5413248"/>
-            <a:ext cx="3383280" cy="1097280"/>
+            <a:off x="594360" y="5248656"/>
+            <a:ext cx="3401568" cy="1042416"/>
           </a:xfrm>
           <a:prstGeom prst="rect">
             <a:avLst/>
@@ -5587,12 +5560,12 @@
           <a:p>
             <a:pPr indent="0" marL="0">
               <a:lnSpc>
-                <a:spcPts val="1150"/>
+                <a:spcPts val="1080"/>
               </a:lnSpc>
               <a:buNone/>
             </a:pPr>
             <a:r>
-              <a:rPr lang="en-US" sz="1100" b="1" dirty="0">
+              <a:rPr lang="en-US" sz="1050" b="1" dirty="0">
                 <a:solidFill>
                   <a:srgbClr val="FFFFFF"/>
                 </a:solidFill>
@@ -5605,12 +5578,12 @@
             </a:r>
             <a:pPr indent="0" marL="0">
               <a:lnSpc>
-                <a:spcPts val="1150"/>
+                <a:spcPts val="1080"/>
               </a:lnSpc>
               <a:buNone/>
             </a:pPr>
             <a:r>
-              <a:rPr lang="en-US" sz="900" dirty="0">
+              <a:rPr lang="en-US" sz="860" dirty="0">
                 <a:solidFill>
                   <a:srgbClr val="FFFFFF">
                     <a:alpha val="94000"/>
@@ -5622,7 +5595,7 @@
               </a:rPr>
               <a:t>Cashless spots the Main Bar spiking; the heat map shows the hotspot; the Owl suggests moving two devices, while the night is young.</a:t>
             </a:r>
-            <a:endParaRPr lang="en-US" sz="1100" dirty="0"/>
+            <a:endParaRPr lang="en-US" sz="1050" dirty="0"/>
           </a:p>
         </p:txBody>
       </p:sp>
@@ -5634,12 +5607,12 @@
         </p:nvSpPr>
         <p:spPr>
           <a:xfrm>
-            <a:off x="4297680" y="5349240"/>
-            <a:ext cx="3657600" cy="1234440"/>
+            <a:off x="4297680" y="5193792"/>
+            <a:ext cx="3657600" cy="1133856"/>
           </a:xfrm>
           <a:prstGeom prst="roundRect">
             <a:avLst>
-              <a:gd name="adj" fmla="val 7407"/>
+              <a:gd name="adj" fmla="val 8065"/>
             </a:avLst>
           </a:prstGeom>
           <a:solidFill>
@@ -5656,8 +5629,8 @@
         </p:nvSpPr>
         <p:spPr>
           <a:xfrm>
-            <a:off x="4434840" y="5413248"/>
-            <a:ext cx="3383280" cy="1097280"/>
+            <a:off x="4434840" y="5248656"/>
+            <a:ext cx="3401568" cy="1042416"/>
           </a:xfrm>
           <a:prstGeom prst="rect">
             <a:avLst/>
@@ -5671,12 +5644,12 @@
           <a:p>
             <a:pPr indent="0" marL="0">
               <a:lnSpc>
-                <a:spcPts val="1150"/>
+                <a:spcPts val="1080"/>
               </a:lnSpc>
               <a:buNone/>
             </a:pPr>
             <a:r>
-              <a:rPr lang="en-US" sz="1100" b="1" dirty="0">
+              <a:rPr lang="en-US" sz="1050" b="1" dirty="0">
                 <a:solidFill>
                   <a:srgbClr val="FFFFFF"/>
                 </a:solidFill>
@@ -5689,12 +5662,12 @@
             </a:r>
             <a:pPr indent="0" marL="0">
               <a:lnSpc>
-                <a:spcPts val="1150"/>
+                <a:spcPts val="1080"/>
               </a:lnSpc>
               <a:buNone/>
             </a:pPr>
             <a:r>
-              <a:rPr lang="en-US" sz="900" dirty="0">
+              <a:rPr lang="en-US" sz="860" dirty="0">
                 <a:solidFill>
                   <a:srgbClr val="FFFFFF">
                     <a:alpha val="94000"/>
@@ -5706,7 +5679,7 @@
               </a:rPr>
               <a:t>Ticket + top-ups + bar spend stitched into one picture, your next campaign targets big spenders who haven’t rebought yet.</a:t>
             </a:r>
-            <a:endParaRPr lang="en-US" sz="1100" dirty="0"/>
+            <a:endParaRPr lang="en-US" sz="1050" dirty="0"/>
           </a:p>
         </p:txBody>
       </p:sp>
@@ -5718,12 +5691,12 @@
         </p:nvSpPr>
         <p:spPr>
           <a:xfrm>
-            <a:off x="8138160" y="5349240"/>
-            <a:ext cx="3657600" cy="1234440"/>
+            <a:off x="8138160" y="5193792"/>
+            <a:ext cx="3657600" cy="1133856"/>
           </a:xfrm>
           <a:prstGeom prst="roundRect">
             <a:avLst>
-              <a:gd name="adj" fmla="val 7407"/>
+              <a:gd name="adj" fmla="val 8065"/>
             </a:avLst>
           </a:prstGeom>
           <a:solidFill>
@@ -5740,8 +5713,8 @@
         </p:nvSpPr>
         <p:spPr>
           <a:xfrm>
-            <a:off x="8275320" y="5413248"/>
-            <a:ext cx="3383280" cy="1097280"/>
+            <a:off x="8275320" y="5248656"/>
+            <a:ext cx="3401568" cy="1042416"/>
           </a:xfrm>
           <a:prstGeom prst="rect">
             <a:avLst/>
@@ -5755,12 +5728,12 @@
           <a:p>
             <a:pPr indent="0" marL="0">
               <a:lnSpc>
-                <a:spcPts val="1150"/>
+                <a:spcPts val="1080"/>
               </a:lnSpc>
               <a:buNone/>
             </a:pPr>
             <a:r>
-              <a:rPr lang="en-US" sz="1100" b="1" dirty="0">
+              <a:rPr lang="en-US" sz="1050" b="1" dirty="0">
                 <a:solidFill>
                   <a:srgbClr val="FFFFFF"/>
                 </a:solidFill>
@@ -5773,12 +5746,12 @@
             </a:r>
             <a:pPr indent="0" marL="0">
               <a:lnSpc>
-                <a:spcPts val="1150"/>
+                <a:spcPts val="1080"/>
               </a:lnSpc>
               <a:buNone/>
             </a:pPr>
             <a:r>
-              <a:rPr lang="en-US" sz="900" dirty="0">
+              <a:rPr lang="en-US" sz="860" dirty="0">
                 <a:solidFill>
                   <a:srgbClr val="FFFFFF">
                     <a:alpha val="94000"/>
@@ -5790,7 +5763,7 @@
               </a:rPr>
               <a:t>Pulse knows who your table guests are, what they spent and when they went quiet, next season’s invitation writes itself.</a:t>
             </a:r>
-            <a:endParaRPr lang="en-US" sz="1100" dirty="0"/>
+            <a:endParaRPr lang="en-US" sz="1050" dirty="0"/>
           </a:p>
         </p:txBody>
       </p:sp>
@@ -12513,7 +12486,7 @@
                 <a:ea typeface="Segoe UI" pitchFamily="34" charset="-122"/>
                 <a:cs typeface="Segoe UI" pitchFamily="34" charset="-120"/>
               </a:rPr>
-              <a:t>🎪  RUN · Event Ops, your operations command centre</a:t>
+              <a:t>🎪  RUN · the Event Ops command centre</a:t>
             </a:r>
             <a:endParaRPr lang="en-US" sz="2600" dirty="0"/>
           </a:p>

</xml_diff>

<commit_message>
Sales collateral: real WhatsApp, ChatGPT and Claude logos (board deck v5, lite, decks)
Replace emoji channel icons with the actual brand marks (transparent PNGs
rasterised from the official SVGs) in the channel hub and AI-chat cards:
new board-deck v5 (per never-edit-in-place), lite PDF rebuilt, both PPTX
decks rebuilt with logo images on the hub slide and a recaptured phone-trio
visual. v5 restores the ChatGPT/Claude card naming to match the logos.

Co-Authored-By: Claude Fable 5 <noreply@anthropic.com>
Claude-Session: https://claude.ai/code/session_016kfeoZ1Zgn8t5cLdc8YKFo
</commit_message>
<xml_diff>
--- a/docs/sales-collateral/Pulse-Sales-Deck.pptx
+++ b/docs/sales-collateral/Pulse-Sales-Deck.pptx
@@ -9899,16 +9899,40 @@
           </a:ln>
         </p:spPr>
       </p:sp>
-      <p:sp>
-        <p:nvSpPr>
-          <p:cNvPr id="16" name="Text 14"/>
-          <p:cNvSpPr/>
-          <p:nvPr/>
-        </p:nvSpPr>
-        <p:spPr>
-          <a:xfrm>
-            <a:off x="621792" y="1691640"/>
-            <a:ext cx="3154680" cy="384048"/>
+      <p:pic>
+        <p:nvPicPr>
+          <p:cNvPr id="16" name="Image 0" descr="howler-logo.png">    </p:cNvPr>
+          <p:cNvPicPr>
+            <a:picLocks noChangeAspect="1"/>
+          </p:cNvPicPr>
+          <p:nvPr/>
+        </p:nvPicPr>
+        <p:blipFill>
+          <a:blip r:embed="rId1"/>
+          <a:stretch>
+            <a:fillRect/>
+          </a:stretch>
+        </p:blipFill>
+        <p:spPr>
+          <a:xfrm>
+            <a:off x="621792" y="1728216"/>
+            <a:ext cx="310896" cy="310896"/>
+          </a:xfrm>
+          <a:prstGeom prst="rect">
+            <a:avLst/>
+          </a:prstGeom>
+        </p:spPr>
+      </p:pic>
+      <p:sp>
+        <p:nvSpPr>
+          <p:cNvPr id="17" name="Text 14"/>
+          <p:cNvSpPr/>
+          <p:nvPr/>
+        </p:nvSpPr>
+        <p:spPr>
+          <a:xfrm>
+            <a:off x="987552" y="1691640"/>
+            <a:ext cx="2788920" cy="384048"/>
           </a:xfrm>
           <a:prstGeom prst="rect">
             <a:avLst/>
@@ -9932,7 +9956,7 @@
                 <a:ea typeface="Segoe UI" pitchFamily="34" charset="-122"/>
                 <a:cs typeface="Segoe UI" pitchFamily="34" charset="-120"/>
               </a:rPr>
-              <a:t>📱 The Howler Pulse app</a:t>
+              <a:t>The Howler Pulse app</a:t>
             </a:r>
             <a:endParaRPr lang="en-US" sz="1400" dirty="0"/>
           </a:p>
@@ -9940,7 +9964,7 @@
       </p:sp>
       <p:sp>
         <p:nvSpPr>
-          <p:cNvPr id="17" name="Text 15"/>
+          <p:cNvPr id="18" name="Text 15"/>
           <p:cNvSpPr/>
           <p:nvPr/>
         </p:nvSpPr>
@@ -9982,7 +10006,7 @@
       </p:sp>
       <p:sp>
         <p:nvSpPr>
-          <p:cNvPr id="18" name="Shape 16"/>
+          <p:cNvPr id="19" name="Shape 16"/>
           <p:cNvSpPr/>
           <p:nvPr/>
         </p:nvSpPr>
@@ -10007,16 +10031,40 @@
           </a:ln>
         </p:spPr>
       </p:sp>
-      <p:sp>
-        <p:nvSpPr>
-          <p:cNvPr id="19" name="Text 17"/>
-          <p:cNvSpPr/>
-          <p:nvPr/>
-        </p:nvSpPr>
-        <p:spPr>
-          <a:xfrm>
-            <a:off x="621792" y="4069080"/>
-            <a:ext cx="3154680" cy="384048"/>
+      <p:pic>
+        <p:nvPicPr>
+          <p:cNvPr id="20" name="Image 1" descr="whatsapp-logo.png">    </p:cNvPr>
+          <p:cNvPicPr>
+            <a:picLocks noChangeAspect="1"/>
+          </p:cNvPicPr>
+          <p:nvPr/>
+        </p:nvPicPr>
+        <p:blipFill>
+          <a:blip r:embed="rId2"/>
+          <a:stretch>
+            <a:fillRect/>
+          </a:stretch>
+        </p:blipFill>
+        <p:spPr>
+          <a:xfrm>
+            <a:off x="621792" y="4105656"/>
+            <a:ext cx="310896" cy="310896"/>
+          </a:xfrm>
+          <a:prstGeom prst="rect">
+            <a:avLst/>
+          </a:prstGeom>
+        </p:spPr>
+      </p:pic>
+      <p:sp>
+        <p:nvSpPr>
+          <p:cNvPr id="21" name="Text 17"/>
+          <p:cNvSpPr/>
+          <p:nvPr/>
+        </p:nvSpPr>
+        <p:spPr>
+          <a:xfrm>
+            <a:off x="987552" y="4069080"/>
+            <a:ext cx="2788920" cy="384048"/>
           </a:xfrm>
           <a:prstGeom prst="rect">
             <a:avLst/>
@@ -10040,7 +10088,7 @@
                 <a:ea typeface="Segoe UI" pitchFamily="34" charset="-122"/>
                 <a:cs typeface="Segoe UI" pitchFamily="34" charset="-120"/>
               </a:rPr>
-              <a:t>💬 WhatsApp</a:t>
+              <a:t>WhatsApp</a:t>
             </a:r>
             <a:endParaRPr lang="en-US" sz="1400" dirty="0"/>
           </a:p>
@@ -10048,7 +10096,7 @@
       </p:sp>
       <p:sp>
         <p:nvSpPr>
-          <p:cNvPr id="20" name="Text 18"/>
+          <p:cNvPr id="22" name="Text 18"/>
           <p:cNvSpPr/>
           <p:nvPr/>
         </p:nvSpPr>
@@ -10090,7 +10138,7 @@
       </p:sp>
       <p:sp>
         <p:nvSpPr>
-          <p:cNvPr id="21" name="Shape 19"/>
+          <p:cNvPr id="23" name="Shape 19"/>
           <p:cNvSpPr/>
           <p:nvPr/>
         </p:nvSpPr>
@@ -10115,16 +10163,40 @@
           </a:ln>
         </p:spPr>
       </p:sp>
-      <p:sp>
-        <p:nvSpPr>
-          <p:cNvPr id="22" name="Text 20"/>
-          <p:cNvSpPr/>
-          <p:nvPr/>
-        </p:nvSpPr>
-        <p:spPr>
-          <a:xfrm>
-            <a:off x="8421624" y="1691640"/>
-            <a:ext cx="3154680" cy="384048"/>
+      <p:pic>
+        <p:nvPicPr>
+          <p:cNvPr id="24" name="Image 2" descr="chatgpt-logo.png">    </p:cNvPr>
+          <p:cNvPicPr>
+            <a:picLocks noChangeAspect="1"/>
+          </p:cNvPicPr>
+          <p:nvPr/>
+        </p:nvPicPr>
+        <p:blipFill>
+          <a:blip r:embed="rId3"/>
+          <a:stretch>
+            <a:fillRect/>
+          </a:stretch>
+        </p:blipFill>
+        <p:spPr>
+          <a:xfrm>
+            <a:off x="8421624" y="1728216"/>
+            <a:ext cx="310896" cy="310896"/>
+          </a:xfrm>
+          <a:prstGeom prst="rect">
+            <a:avLst/>
+          </a:prstGeom>
+        </p:spPr>
+      </p:pic>
+      <p:sp>
+        <p:nvSpPr>
+          <p:cNvPr id="25" name="Text 20"/>
+          <p:cNvSpPr/>
+          <p:nvPr/>
+        </p:nvSpPr>
+        <p:spPr>
+          <a:xfrm>
+            <a:off x="8787384" y="1691640"/>
+            <a:ext cx="2788920" cy="384048"/>
           </a:xfrm>
           <a:prstGeom prst="rect">
             <a:avLst/>
@@ -10148,7 +10220,7 @@
                 <a:ea typeface="Segoe UI" pitchFamily="34" charset="-122"/>
                 <a:cs typeface="Segoe UI" pitchFamily="34" charset="-120"/>
               </a:rPr>
-              <a:t>🤖 ChatGPT</a:t>
+              <a:t>ChatGPT</a:t>
             </a:r>
             <a:endParaRPr lang="en-US" sz="1400" dirty="0"/>
           </a:p>
@@ -10156,7 +10228,7 @@
       </p:sp>
       <p:sp>
         <p:nvSpPr>
-          <p:cNvPr id="23" name="Text 21"/>
+          <p:cNvPr id="26" name="Text 21"/>
           <p:cNvSpPr/>
           <p:nvPr/>
         </p:nvSpPr>
@@ -10198,7 +10270,7 @@
       </p:sp>
       <p:sp>
         <p:nvSpPr>
-          <p:cNvPr id="24" name="Shape 22"/>
+          <p:cNvPr id="27" name="Shape 22"/>
           <p:cNvSpPr/>
           <p:nvPr/>
         </p:nvSpPr>
@@ -10223,103 +10295,127 @@
           </a:ln>
         </p:spPr>
       </p:sp>
-      <p:sp>
-        <p:nvSpPr>
-          <p:cNvPr id="25" name="Text 23"/>
-          <p:cNvSpPr/>
-          <p:nvPr/>
-        </p:nvSpPr>
-        <p:spPr>
-          <a:xfrm>
-            <a:off x="8421624" y="4069080"/>
-            <a:ext cx="3154680" cy="384048"/>
-          </a:xfrm>
-          <a:prstGeom prst="rect">
-            <a:avLst/>
-          </a:prstGeom>
-          <a:noFill/>
-          <a:ln/>
-        </p:spPr>
-        <p:txBody>
-          <a:bodyPr wrap="square" rtlCol="0" anchor="ctr"/>
-          <a:lstStyle/>
-          <a:p>
-            <a:pPr indent="0" marL="0">
-              <a:buNone/>
-            </a:pPr>
-            <a:r>
-              <a:rPr lang="en-US" sz="1400" b="1" dirty="0">
-                <a:solidFill>
-                  <a:srgbClr val="1A1A2E"/>
-                </a:solidFill>
-                <a:latin typeface="Segoe UI" pitchFamily="34" charset="0"/>
-                <a:ea typeface="Segoe UI" pitchFamily="34" charset="-122"/>
-                <a:cs typeface="Segoe UI" pitchFamily="34" charset="-120"/>
-              </a:rPr>
-              <a:t>✳️ Claude</a:t>
-            </a:r>
-            <a:endParaRPr lang="en-US" sz="1400" dirty="0"/>
-          </a:p>
-        </p:txBody>
-      </p:sp>
-      <p:sp>
-        <p:nvSpPr>
-          <p:cNvPr id="26" name="Text 24"/>
-          <p:cNvSpPr/>
-          <p:nvPr/>
-        </p:nvSpPr>
-        <p:spPr>
-          <a:xfrm>
-            <a:off x="8421624" y="4480560"/>
-            <a:ext cx="3154680" cy="1143000"/>
-          </a:xfrm>
-          <a:prstGeom prst="rect">
-            <a:avLst/>
-          </a:prstGeom>
-          <a:noFill/>
-          <a:ln/>
-        </p:spPr>
-        <p:txBody>
-          <a:bodyPr wrap="square" rtlCol="0" anchor="t"/>
-          <a:lstStyle/>
-          <a:p>
-            <a:pPr indent="0" marL="0">
-              <a:lnSpc>
-                <a:spcPts val="1400"/>
-              </a:lnSpc>
-              <a:buNone/>
-            </a:pPr>
-            <a:r>
-              <a:rPr lang="en-US" sz="1050" dirty="0">
-                <a:solidFill>
-                  <a:srgbClr val="55556D"/>
-                </a:solidFill>
-                <a:latin typeface="Segoe UI" pitchFamily="34" charset="0"/>
-                <a:ea typeface="Segoe UI" pitchFamily="34" charset="-122"/>
-                <a:cs typeface="Segoe UI" pitchFamily="34" charset="-120"/>
-              </a:rPr>
-              <a:t>The same connector plugs your event data into Claude, read-only, per-client keys you control.</a:t>
-            </a:r>
-            <a:endParaRPr lang="en-US" sz="1050" dirty="0"/>
-          </a:p>
-        </p:txBody>
-      </p:sp>
       <p:pic>
         <p:nvPicPr>
-          <p:cNvPr id="27" name="Image 0" descr="owl-mark.png">    </p:cNvPr>
+          <p:cNvPr id="28" name="Image 3" descr="claude-logo.png">    </p:cNvPr>
           <p:cNvPicPr>
             <a:picLocks noChangeAspect="1"/>
           </p:cNvPicPr>
           <p:nvPr/>
         </p:nvPicPr>
         <p:blipFill>
-          <a:blip r:embed="rId1"/>
+          <a:blip r:embed="rId4"/>
           <a:stretch>
             <a:fillRect/>
           </a:stretch>
         </p:blipFill>
         <p:spPr>
           <a:xfrm>
+            <a:off x="8421624" y="4105656"/>
+            <a:ext cx="310896" cy="310896"/>
+          </a:xfrm>
+          <a:prstGeom prst="rect">
+            <a:avLst/>
+          </a:prstGeom>
+        </p:spPr>
+      </p:pic>
+      <p:sp>
+        <p:nvSpPr>
+          <p:cNvPr id="29" name="Text 23"/>
+          <p:cNvSpPr/>
+          <p:nvPr/>
+        </p:nvSpPr>
+        <p:spPr>
+          <a:xfrm>
+            <a:off x="8787384" y="4069080"/>
+            <a:ext cx="2788920" cy="384048"/>
+          </a:xfrm>
+          <a:prstGeom prst="rect">
+            <a:avLst/>
+          </a:prstGeom>
+          <a:noFill/>
+          <a:ln/>
+        </p:spPr>
+        <p:txBody>
+          <a:bodyPr wrap="square" rtlCol="0" anchor="ctr"/>
+          <a:lstStyle/>
+          <a:p>
+            <a:pPr indent="0" marL="0">
+              <a:buNone/>
+            </a:pPr>
+            <a:r>
+              <a:rPr lang="en-US" sz="1400" b="1" dirty="0">
+                <a:solidFill>
+                  <a:srgbClr val="1A1A2E"/>
+                </a:solidFill>
+                <a:latin typeface="Segoe UI" pitchFamily="34" charset="0"/>
+                <a:ea typeface="Segoe UI" pitchFamily="34" charset="-122"/>
+                <a:cs typeface="Segoe UI" pitchFamily="34" charset="-120"/>
+              </a:rPr>
+              <a:t>Claude</a:t>
+            </a:r>
+            <a:endParaRPr lang="en-US" sz="1400" dirty="0"/>
+          </a:p>
+        </p:txBody>
+      </p:sp>
+      <p:sp>
+        <p:nvSpPr>
+          <p:cNvPr id="30" name="Text 24"/>
+          <p:cNvSpPr/>
+          <p:nvPr/>
+        </p:nvSpPr>
+        <p:spPr>
+          <a:xfrm>
+            <a:off x="8421624" y="4480560"/>
+            <a:ext cx="3154680" cy="1143000"/>
+          </a:xfrm>
+          <a:prstGeom prst="rect">
+            <a:avLst/>
+          </a:prstGeom>
+          <a:noFill/>
+          <a:ln/>
+        </p:spPr>
+        <p:txBody>
+          <a:bodyPr wrap="square" rtlCol="0" anchor="t"/>
+          <a:lstStyle/>
+          <a:p>
+            <a:pPr indent="0" marL="0">
+              <a:lnSpc>
+                <a:spcPts val="1400"/>
+              </a:lnSpc>
+              <a:buNone/>
+            </a:pPr>
+            <a:r>
+              <a:rPr lang="en-US" sz="1050" dirty="0">
+                <a:solidFill>
+                  <a:srgbClr val="55556D"/>
+                </a:solidFill>
+                <a:latin typeface="Segoe UI" pitchFamily="34" charset="0"/>
+                <a:ea typeface="Segoe UI" pitchFamily="34" charset="-122"/>
+                <a:cs typeface="Segoe UI" pitchFamily="34" charset="-120"/>
+              </a:rPr>
+              <a:t>The same connector plugs your event data into Claude, read-only, per-client keys you control.</a:t>
+            </a:r>
+            <a:endParaRPr lang="en-US" sz="1050" dirty="0"/>
+          </a:p>
+        </p:txBody>
+      </p:sp>
+      <p:pic>
+        <p:nvPicPr>
+          <p:cNvPr id="31" name="Image 4" descr="owl-mark.png">    </p:cNvPr>
+          <p:cNvPicPr>
+            <a:picLocks noChangeAspect="1"/>
+          </p:cNvPicPr>
+          <p:nvPr/>
+        </p:nvPicPr>
+        <p:blipFill>
+          <a:blip r:embed="rId5"/>
+          <a:stretch>
+            <a:fillRect/>
+          </a:stretch>
+        </p:blipFill>
+        <p:spPr>
+          <a:xfrm>
             <a:off x="4956048" y="2331720"/>
             <a:ext cx="2286000" cy="2286000"/>
           </a:xfrm>
@@ -10330,7 +10426,7 @@
       </p:pic>
       <p:sp>
         <p:nvSpPr>
-          <p:cNvPr id="28" name="Shape 25"/>
+          <p:cNvPr id="32" name="Shape 25"/>
           <p:cNvSpPr/>
           <p:nvPr/>
         </p:nvSpPr>
@@ -10352,7 +10448,7 @@
       </p:sp>
       <p:sp>
         <p:nvSpPr>
-          <p:cNvPr id="29" name="Text 26"/>
+          <p:cNvPr id="33" name="Text 26"/>
           <p:cNvSpPr/>
           <p:nvPr/>
         </p:nvSpPr>
@@ -10405,7 +10501,7 @@
       </p:sp>
       <p:sp>
         <p:nvSpPr>
-          <p:cNvPr id="30" name="Shape 27"/>
+          <p:cNvPr id="34" name="Shape 27"/>
           <p:cNvSpPr/>
           <p:nvPr/>
         </p:nvSpPr>
@@ -10427,7 +10523,7 @@
       </p:sp>
       <p:sp>
         <p:nvSpPr>
-          <p:cNvPr id="31" name="Text 28"/>
+          <p:cNvPr id="35" name="Text 28"/>
           <p:cNvSpPr/>
           <p:nvPr/>
         </p:nvSpPr>

</xml_diff>